<commit_message>
Remove handoff owner from slide 31
</commit_message>
<xml_diff>
--- a/presentations/Aurora_Stays_RAG_Project_Presentation_Template_Style.pptx
+++ b/presentations/Aurora_Stays_RAG_Project_Presentation_Template_Style.pptx
@@ -46760,94 +46760,6 @@
           </a:p>
         </p:txBody>
       </p:sp>
-      <p:sp>
-        <p:nvSpPr>
-          <p:cNvPr id="424" name="TextBox 423"/>
-          <p:cNvSpPr txBox="1"/>
-          <p:nvPr/>
-        </p:nvSpPr>
-        <p:spPr>
-          <a:xfrm>
-            <a:off x="694944" y="3927348"/>
-            <a:ext cx="6729984" cy="256032"/>
-          </a:xfrm>
-          <a:prstGeom prst="rect">
-            <a:avLst/>
-          </a:prstGeom>
-          <a:noFill/>
-        </p:spPr>
-        <p:txBody>
-          <a:bodyPr wrap="square" lIns="82296" rIns="36576" tIns="18288" bIns="18288">
-            <a:normAutofit/>
-          </a:bodyPr>
-          <a:lstStyle/>
-          <a:p>
-            <a:pPr>
-              <a:lnSpc>
-                <a:spcPct val="100000"/>
-              </a:lnSpc>
-              <a:spcBef>
-                <a:spcPts val="0"/>
-              </a:spcBef>
-              <a:spcAft>
-                <a:spcPts val="0"/>
-              </a:spcAft>
-            </a:pPr>
-            <a:r>
-              <a:rPr sz="1350" b="0">
-                <a:solidFill>
-                  <a:srgbClr val="000000"/>
-                </a:solidFill>
-                <a:latin typeface="Montserrat"/>
-              </a:rPr>
-              <a:t>Handoff owner: raovutukoor1/aurora-stay-qna.</a:t>
-            </a:r>
-          </a:p>
-        </p:txBody>
-      </p:sp>
-      <p:sp>
-        <p:nvSpPr>
-          <p:cNvPr id="425" name="Oval 424"/>
-          <p:cNvSpPr/>
-          <p:nvPr/>
-        </p:nvSpPr>
-        <p:spPr>
-          <a:xfrm>
-            <a:off x="402336" y="4027932"/>
-            <a:ext cx="192024" cy="192024"/>
-          </a:xfrm>
-          <a:prstGeom prst="ellipse">
-            <a:avLst/>
-          </a:prstGeom>
-          <a:solidFill>
-            <a:srgbClr val="0944A1"/>
-          </a:solidFill>
-          <a:ln>
-            <a:noFill/>
-          </a:ln>
-        </p:spPr>
-        <p:style>
-          <a:lnRef idx="1">
-            <a:schemeClr val="accent1"/>
-          </a:lnRef>
-          <a:fillRef idx="3">
-            <a:schemeClr val="accent1"/>
-          </a:fillRef>
-          <a:effectRef idx="2">
-            <a:schemeClr val="accent1"/>
-          </a:effectRef>
-          <a:fontRef idx="minor">
-            <a:schemeClr val="lt1"/>
-          </a:fontRef>
-        </p:style>
-        <p:txBody>
-          <a:bodyPr rtlCol="0" anchor="ctr"/>
-          <a:lstStyle/>
-          <a:p>
-            <a:pPr algn="ctr"/>
-          </a:p>
-        </p:txBody>
-      </p:sp>
     </p:spTree>
   </p:cSld>
   <p:clrMapOvr>

</xml_diff>

<commit_message>
Address presentation rubric gaps
</commit_message>
<xml_diff>
--- a/presentations/Aurora_Stays_RAG_Project_Presentation_Template_Style.pptx
+++ b/presentations/Aurora_Stays_RAG_Project_Presentation_Template_Style.pptx
@@ -33940,7 +33940,7 @@
                 </a:solidFill>
                 <a:latin typeface="Montserrat"/>
               </a:rPr>
-              <a:t>Use only information explicitly supported by retrieved policy text.</a:t>
+              <a:t>Core system prompt: You are the Aurora Stays policy assistant. Use only the retrieved policy context to answer.</a:t>
             </a:r>
           </a:p>
         </p:txBody>
@@ -34028,7 +34028,7 @@
                 </a:solidFill>
                 <a:latin typeface="Montserrat"/>
               </a:rPr>
-              <a:t>Include relevant conditions, exclusions, limits, exceptions, and coverage details.</a:t>
+              <a:t>Use only information explicitly supported by retrieved policy text.</a:t>
             </a:r>
           </a:p>
         </p:txBody>
@@ -34116,7 +34116,7 @@
                 </a:solidFill>
                 <a:latin typeface="Montserrat"/>
               </a:rPr>
-              <a:t>Focus on the question; omit unrelated content and do not invent facts.</a:t>
+              <a:t>Include relevant conditions, exclusions, limits, exceptions, and coverage details.</a:t>
             </a:r>
           </a:p>
         </p:txBody>
@@ -34173,7 +34173,7 @@
         <p:spPr>
           <a:xfrm>
             <a:off x="694944" y="3054096"/>
-            <a:ext cx="6729984" cy="649224"/>
+            <a:ext cx="6729984" cy="448056"/>
           </a:xfrm>
           <a:prstGeom prst="rect">
             <a:avLst/>
@@ -34204,7 +34204,7 @@
                 </a:solidFill>
                 <a:latin typeface="Montserrat"/>
               </a:rPr>
-              <a:t>If evidence is insufficient, return: The available policy documents do not contain enough information to answer this question.</a:t>
+              <a:t>Focus on the question; omit unrelated content and do not invent facts.</a:t>
             </a:r>
           </a:p>
         </p:txBody>
@@ -34260,8 +34260,8 @@
         </p:nvSpPr>
         <p:spPr>
           <a:xfrm>
-            <a:off x="694944" y="3735324"/>
-            <a:ext cx="6729984" cy="448056"/>
+            <a:off x="694944" y="3534156"/>
+            <a:ext cx="6729984" cy="649224"/>
           </a:xfrm>
           <a:prstGeom prst="rect">
             <a:avLst/>
@@ -34292,6 +34292,94 @@
                 </a:solidFill>
                 <a:latin typeface="Montserrat"/>
               </a:rPr>
+              <a:t>If evidence is insufficient, return: The available policy documents do not contain enough information to answer this question.</a:t>
+            </a:r>
+          </a:p>
+        </p:txBody>
+      </p:sp>
+      <p:sp>
+        <p:nvSpPr>
+          <p:cNvPr id="275" name="Oval 274"/>
+          <p:cNvSpPr/>
+          <p:nvPr/>
+        </p:nvSpPr>
+        <p:spPr>
+          <a:xfrm>
+            <a:off x="402336" y="3634739"/>
+            <a:ext cx="192024" cy="192024"/>
+          </a:xfrm>
+          <a:prstGeom prst="ellipse">
+            <a:avLst/>
+          </a:prstGeom>
+          <a:solidFill>
+            <a:srgbClr val="0944A1"/>
+          </a:solidFill>
+          <a:ln>
+            <a:noFill/>
+          </a:ln>
+        </p:spPr>
+        <p:style>
+          <a:lnRef idx="1">
+            <a:schemeClr val="accent1"/>
+          </a:lnRef>
+          <a:fillRef idx="3">
+            <a:schemeClr val="accent1"/>
+          </a:fillRef>
+          <a:effectRef idx="2">
+            <a:schemeClr val="accent1"/>
+          </a:effectRef>
+          <a:fontRef idx="minor">
+            <a:schemeClr val="lt1"/>
+          </a:fontRef>
+        </p:style>
+        <p:txBody>
+          <a:bodyPr rtlCol="0" anchor="ctr"/>
+          <a:lstStyle/>
+          <a:p>
+            <a:pPr algn="ctr"/>
+          </a:p>
+        </p:txBody>
+      </p:sp>
+      <p:sp>
+        <p:nvSpPr>
+          <p:cNvPr id="276" name="TextBox 275"/>
+          <p:cNvSpPr txBox="1"/>
+          <p:nvPr/>
+        </p:nvSpPr>
+        <p:spPr>
+          <a:xfrm>
+            <a:off x="694944" y="4215383"/>
+            <a:ext cx="6729984" cy="448056"/>
+          </a:xfrm>
+          <a:prstGeom prst="rect">
+            <a:avLst/>
+          </a:prstGeom>
+          <a:noFill/>
+        </p:spPr>
+        <p:txBody>
+          <a:bodyPr wrap="square" lIns="82296" rIns="36576" tIns="18288" bIns="18288">
+            <a:normAutofit/>
+          </a:bodyPr>
+          <a:lstStyle/>
+          <a:p>
+            <a:pPr>
+              <a:lnSpc>
+                <a:spcPct val="100000"/>
+              </a:lnSpc>
+              <a:spcBef>
+                <a:spcPts val="0"/>
+              </a:spcBef>
+              <a:spcAft>
+                <a:spcPts val="0"/>
+              </a:spcAft>
+            </a:pPr>
+            <a:r>
+              <a:rPr sz="1350" b="0">
+                <a:solidFill>
+                  <a:srgbClr val="000000"/>
+                </a:solidFill>
+                <a:latin typeface="Montserrat"/>
+              </a:rPr>
               <a:t>Additional guards focus Advance Purchase, Accessible King, and late-checkout questions on their relevant evidence.</a:t>
             </a:r>
           </a:p>
@@ -34299,13 +34387,13 @@
       </p:sp>
       <p:sp>
         <p:nvSpPr>
-          <p:cNvPr id="275" name="Oval 274"/>
+          <p:cNvPr id="277" name="Oval 276"/>
           <p:cNvSpPr/>
           <p:nvPr/>
         </p:nvSpPr>
         <p:spPr>
           <a:xfrm>
-            <a:off x="402336" y="3835908"/>
+            <a:off x="402336" y="4315968"/>
             <a:ext cx="192024" cy="192024"/>
           </a:xfrm>
           <a:prstGeom prst="ellipse">
@@ -36939,7 +37027,7 @@
                 </a:solidFill>
                 <a:latin typeface="Montserrat"/>
               </a:rPr>
-              <a:t>Cases are classified as AUTO ANSWER, ASSISTED REVIEW, or MANUAL LOOKUP from the composite score.</a:t>
+              <a:t>Output artifacts: deepeval_options_summary.csv and deepeval_options_cases.csv.</a:t>
             </a:r>
           </a:p>
         </p:txBody>
@@ -37027,6 +37115,94 @@
                 </a:solidFill>
                 <a:latin typeface="Montserrat"/>
               </a:rPr>
+              <a:t>Cases are classified as AUTO ANSWER, ASSISTED REVIEW, or MANUAL LOOKUP from the composite score.</a:t>
+            </a:r>
+          </a:p>
+        </p:txBody>
+      </p:sp>
+      <p:sp>
+        <p:nvSpPr>
+          <p:cNvPr id="315" name="Oval 314"/>
+          <p:cNvSpPr/>
+          <p:nvPr/>
+        </p:nvSpPr>
+        <p:spPr>
+          <a:xfrm>
+            <a:off x="402336" y="4027932"/>
+            <a:ext cx="192024" cy="192024"/>
+          </a:xfrm>
+          <a:prstGeom prst="ellipse">
+            <a:avLst/>
+          </a:prstGeom>
+          <a:solidFill>
+            <a:srgbClr val="0944A1"/>
+          </a:solidFill>
+          <a:ln>
+            <a:noFill/>
+          </a:ln>
+        </p:spPr>
+        <p:style>
+          <a:lnRef idx="1">
+            <a:schemeClr val="accent1"/>
+          </a:lnRef>
+          <a:fillRef idx="3">
+            <a:schemeClr val="accent1"/>
+          </a:fillRef>
+          <a:effectRef idx="2">
+            <a:schemeClr val="accent1"/>
+          </a:effectRef>
+          <a:fontRef idx="minor">
+            <a:schemeClr val="lt1"/>
+          </a:fontRef>
+        </p:style>
+        <p:txBody>
+          <a:bodyPr rtlCol="0" anchor="ctr"/>
+          <a:lstStyle/>
+          <a:p>
+            <a:pPr algn="ctr"/>
+          </a:p>
+        </p:txBody>
+      </p:sp>
+      <p:sp>
+        <p:nvSpPr>
+          <p:cNvPr id="316" name="TextBox 315"/>
+          <p:cNvSpPr txBox="1"/>
+          <p:nvPr/>
+        </p:nvSpPr>
+        <p:spPr>
+          <a:xfrm>
+            <a:off x="694944" y="4407408"/>
+            <a:ext cx="6729984" cy="274319"/>
+          </a:xfrm>
+          <a:prstGeom prst="rect">
+            <a:avLst/>
+          </a:prstGeom>
+          <a:noFill/>
+        </p:spPr>
+        <p:txBody>
+          <a:bodyPr wrap="square" lIns="82296" rIns="36576" tIns="18288" bIns="18288">
+            <a:normAutofit/>
+          </a:bodyPr>
+          <a:lstStyle/>
+          <a:p>
+            <a:pPr>
+              <a:lnSpc>
+                <a:spcPct val="100000"/>
+              </a:lnSpc>
+              <a:spcBef>
+                <a:spcPts val="0"/>
+              </a:spcBef>
+              <a:spcAft>
+                <a:spcPts val="0"/>
+              </a:spcAft>
+            </a:pPr>
+            <a:r>
+              <a:rPr sz="1350" b="0">
+                <a:solidFill>
+                  <a:srgbClr val="000000"/>
+                </a:solidFill>
+                <a:latin typeface="Montserrat"/>
+              </a:rPr>
               <a:t>Result: baseline k=5 is the selected configuration by highest composite score.</a:t>
             </a:r>
           </a:p>
@@ -37034,13 +37210,13 @@
       </p:sp>
       <p:sp>
         <p:nvSpPr>
-          <p:cNvPr id="315" name="Oval 314"/>
+          <p:cNvPr id="317" name="Oval 316"/>
           <p:cNvSpPr/>
           <p:nvPr/>
         </p:nvSpPr>
         <p:spPr>
           <a:xfrm>
-            <a:off x="402336" y="4027932"/>
+            <a:off x="402336" y="4507992"/>
             <a:ext cx="192024" cy="192024"/>
           </a:xfrm>
           <a:prstGeom prst="ellipse">
@@ -37763,27 +37939,70 @@
               </a:spcAft>
             </a:pPr>
             <a:r>
-              <a:rPr sz="1350" b="1">
-                <a:solidFill>
-                  <a:srgbClr val="0E39A9"/>
+              <a:rPr sz="1350" b="0">
+                <a:solidFill>
+                  <a:srgbClr val="000000"/>
                 </a:solidFill>
                 <a:latin typeface="Montserrat"/>
               </a:rPr>
-              <a:t>Held-out DeepEval comparison (10 cases)</a:t>
+              <a:t>Held-out case-level output — selected baseline k=5</a:t>
             </a:r>
           </a:p>
         </p:txBody>
       </p:sp>
       <p:sp>
         <p:nvSpPr>
-          <p:cNvPr id="321" name="TextBox 320"/>
+          <p:cNvPr id="321" name="Oval 320"/>
+          <p:cNvSpPr/>
+          <p:nvPr/>
+        </p:nvSpPr>
+        <p:spPr>
+          <a:xfrm>
+            <a:off x="402336" y="1426464"/>
+            <a:ext cx="192024" cy="192024"/>
+          </a:xfrm>
+          <a:prstGeom prst="ellipse">
+            <a:avLst/>
+          </a:prstGeom>
+          <a:solidFill>
+            <a:srgbClr val="0944A1"/>
+          </a:solidFill>
+          <a:ln>
+            <a:noFill/>
+          </a:ln>
+        </p:spPr>
+        <p:style>
+          <a:lnRef idx="1">
+            <a:schemeClr val="accent1"/>
+          </a:lnRef>
+          <a:fillRef idx="3">
+            <a:schemeClr val="accent1"/>
+          </a:fillRef>
+          <a:effectRef idx="2">
+            <a:schemeClr val="accent1"/>
+          </a:effectRef>
+          <a:fontRef idx="minor">
+            <a:schemeClr val="lt1"/>
+          </a:fontRef>
+        </p:style>
+        <p:txBody>
+          <a:bodyPr rtlCol="0" anchor="ctr"/>
+          <a:lstStyle/>
+          <a:p>
+            <a:pPr algn="ctr"/>
+          </a:p>
+        </p:txBody>
+      </p:sp>
+      <p:sp>
+        <p:nvSpPr>
+          <p:cNvPr id="322" name="TextBox 321"/>
           <p:cNvSpPr txBox="1"/>
           <p:nvPr/>
         </p:nvSpPr>
         <p:spPr>
           <a:xfrm>
             <a:off x="694944" y="1613916"/>
-            <a:ext cx="6729984" cy="448056"/>
+            <a:ext cx="6729984" cy="256032"/>
           </a:xfrm>
           <a:prstGeom prst="rect">
             <a:avLst/>
@@ -37814,14 +38033,14 @@
                 </a:solidFill>
                 <a:latin typeface="Montserrat"/>
               </a:rPr>
-              <a:t>Baseline k=5     F=.993  R=.977  P=.808  AR=.939  Composite=.941  Pass=9/10</a:t>
+              <a:t>Case 01 | OTA cancellation/refund | PASS | Composite .944</a:t>
             </a:r>
           </a:p>
         </p:txBody>
       </p:sp>
       <p:sp>
         <p:nvSpPr>
-          <p:cNvPr id="322" name="Oval 321"/>
+          <p:cNvPr id="323" name="Oval 322"/>
           <p:cNvSpPr/>
           <p:nvPr/>
         </p:nvSpPr>
@@ -37864,14 +38083,14 @@
       </p:sp>
       <p:sp>
         <p:nvSpPr>
-          <p:cNvPr id="323" name="TextBox 322"/>
+          <p:cNvPr id="324" name="TextBox 323"/>
           <p:cNvSpPr txBox="1"/>
           <p:nvPr/>
         </p:nvSpPr>
         <p:spPr>
           <a:xfrm>
-            <a:off x="694944" y="2093976"/>
-            <a:ext cx="6729984" cy="448056"/>
+            <a:off x="694944" y="1901952"/>
+            <a:ext cx="6729984" cy="256032"/>
           </a:xfrm>
           <a:prstGeom prst="rect">
             <a:avLst/>
@@ -37902,20 +38121,20 @@
                 </a:solidFill>
                 <a:latin typeface="Montserrat"/>
               </a:rPr>
-              <a:t>Hybrid k=5       F=.995  R=.979  P=.787  AR=.922  Composite=.935  Pass=8/10</a:t>
+              <a:t>Case 02 | Member discount/cancellation | PASS | Composite .956</a:t>
             </a:r>
           </a:p>
         </p:txBody>
       </p:sp>
       <p:sp>
         <p:nvSpPr>
-          <p:cNvPr id="324" name="Oval 323"/>
+          <p:cNvPr id="325" name="Oval 324"/>
           <p:cNvSpPr/>
           <p:nvPr/>
         </p:nvSpPr>
         <p:spPr>
           <a:xfrm>
-            <a:off x="402336" y="2194560"/>
+            <a:off x="402336" y="2002536"/>
             <a:ext cx="192024" cy="192024"/>
           </a:xfrm>
           <a:prstGeom prst="ellipse">
@@ -37952,14 +38171,14 @@
       </p:sp>
       <p:sp>
         <p:nvSpPr>
-          <p:cNvPr id="325" name="TextBox 324"/>
+          <p:cNvPr id="326" name="TextBox 325"/>
           <p:cNvSpPr txBox="1"/>
           <p:nvPr/>
         </p:nvSpPr>
         <p:spPr>
           <a:xfrm>
-            <a:off x="694944" y="2574036"/>
-            <a:ext cx="6729984" cy="448056"/>
+            <a:off x="694944" y="2189988"/>
+            <a:ext cx="6729984" cy="256032"/>
           </a:xfrm>
           <a:prstGeom prst="rect">
             <a:avLst/>
@@ -37990,20 +38209,20 @@
                 </a:solidFill>
                 <a:latin typeface="Montserrat"/>
               </a:rPr>
-              <a:t>Hybrid k=6       F=.993  R=.982  P=.781  AR=.929  Composite=.935  Pass=8/10</a:t>
+              <a:t>Case 03 | Double Queen occupancy | PASS | Composite .988</a:t>
             </a:r>
           </a:p>
         </p:txBody>
       </p:sp>
       <p:sp>
         <p:nvSpPr>
-          <p:cNvPr id="326" name="Oval 325"/>
+          <p:cNvPr id="327" name="Oval 326"/>
           <p:cNvSpPr/>
           <p:nvPr/>
         </p:nvSpPr>
         <p:spPr>
           <a:xfrm>
-            <a:off x="402336" y="2674620"/>
+            <a:off x="402336" y="2290572"/>
             <a:ext cx="192024" cy="192024"/>
           </a:xfrm>
           <a:prstGeom prst="ellipse">
@@ -38040,14 +38259,14 @@
       </p:sp>
       <p:sp>
         <p:nvSpPr>
-          <p:cNvPr id="327" name="TextBox 326"/>
+          <p:cNvPr id="328" name="TextBox 327"/>
           <p:cNvSpPr txBox="1"/>
           <p:nvPr/>
         </p:nvSpPr>
         <p:spPr>
           <a:xfrm>
-            <a:off x="694944" y="3054096"/>
-            <a:ext cx="6729984" cy="448056"/>
+            <a:off x="694944" y="2478024"/>
+            <a:ext cx="6729984" cy="256032"/>
           </a:xfrm>
           <a:prstGeom prst="rect">
             <a:avLst/>
@@ -38072,26 +38291,26 @@
               </a:spcAft>
             </a:pPr>
             <a:r>
-              <a:rPr sz="1350" b="1">
-                <a:solidFill>
-                  <a:srgbClr val="1F7752"/>
+              <a:rPr sz="1350" b="0">
+                <a:solidFill>
+                  <a:srgbClr val="000000"/>
                 </a:solidFill>
                 <a:latin typeface="Montserrat"/>
               </a:rPr>
-              <a:t>Selected: baseline k=5 because it has the highest weighted composite score.</a:t>
+              <a:t>Case 04 | Accessible King inclusions | FAIL | Precision .451</a:t>
             </a:r>
           </a:p>
         </p:txBody>
       </p:sp>
       <p:sp>
         <p:nvSpPr>
-          <p:cNvPr id="328" name="Oval 327"/>
+          <p:cNvPr id="329" name="Oval 328"/>
           <p:cNvSpPr/>
           <p:nvPr/>
         </p:nvSpPr>
         <p:spPr>
           <a:xfrm>
-            <a:off x="402336" y="3154679"/>
+            <a:off x="402336" y="2578608"/>
             <a:ext cx="192024" cy="192024"/>
           </a:xfrm>
           <a:prstGeom prst="ellipse">
@@ -38128,14 +38347,14 @@
       </p:sp>
       <p:sp>
         <p:nvSpPr>
-          <p:cNvPr id="329" name="TextBox 328"/>
+          <p:cNvPr id="330" name="TextBox 329"/>
           <p:cNvSpPr txBox="1"/>
           <p:nvPr/>
         </p:nvSpPr>
         <p:spPr>
           <a:xfrm>
-            <a:off x="694944" y="3534156"/>
-            <a:ext cx="6729984" cy="448056"/>
+            <a:off x="694944" y="2766060"/>
+            <a:ext cx="6729984" cy="256032"/>
           </a:xfrm>
           <a:prstGeom prst="rect">
             <a:avLst/>
@@ -38160,26 +38379,26 @@
               </a:spcAft>
             </a:pPr>
             <a:r>
-              <a:rPr sz="1350" b="1">
-                <a:solidFill>
-                  <a:srgbClr val="A62A2A"/>
+              <a:rPr sz="1350" b="0">
+                <a:solidFill>
+                  <a:srgbClr val="000000"/>
                 </a:solidFill>
                 <a:latin typeface="Montserrat"/>
               </a:rPr>
-              <a:t>Only remaining failure: Accessible King room inclusions; Contextual Precision=.451.</a:t>
+              <a:t>Case 05 | Atlanta/Miami parking | PASS | Composite .975</a:t>
             </a:r>
           </a:p>
         </p:txBody>
       </p:sp>
       <p:sp>
         <p:nvSpPr>
-          <p:cNvPr id="330" name="Oval 329"/>
+          <p:cNvPr id="331" name="Oval 330"/>
           <p:cNvSpPr/>
           <p:nvPr/>
         </p:nvSpPr>
         <p:spPr>
           <a:xfrm>
-            <a:off x="402336" y="3634739"/>
+            <a:off x="402336" y="2866644"/>
             <a:ext cx="192024" cy="192024"/>
           </a:xfrm>
           <a:prstGeom prst="ellipse">
@@ -38216,14 +38435,14 @@
       </p:sp>
       <p:sp>
         <p:nvSpPr>
-          <p:cNvPr id="331" name="TextBox 330"/>
+          <p:cNvPr id="332" name="TextBox 331"/>
           <p:cNvSpPr txBox="1"/>
           <p:nvPr/>
         </p:nvSpPr>
         <p:spPr>
           <a:xfrm>
-            <a:off x="694944" y="4014215"/>
-            <a:ext cx="6729984" cy="649224"/>
+            <a:off x="694944" y="3054096"/>
+            <a:ext cx="6729984" cy="256032"/>
           </a:xfrm>
           <a:prstGeom prst="rect">
             <a:avLst/>
@@ -38254,20 +38473,548 @@
                 </a:solidFill>
                 <a:latin typeface="Montserrat"/>
               </a:rPr>
-              <a:t>The benchmark question is underspecified. A focused clarification plus single-chunk retrieval scored Precision=.961 and passed all four metrics.</a:t>
+              <a:t>Case 06 | Miami breakfast | PASS | Composite .963</a:t>
             </a:r>
           </a:p>
         </p:txBody>
       </p:sp>
       <p:sp>
         <p:nvSpPr>
-          <p:cNvPr id="332" name="Oval 331"/>
+          <p:cNvPr id="333" name="Oval 332"/>
           <p:cNvSpPr/>
           <p:nvPr/>
         </p:nvSpPr>
         <p:spPr>
           <a:xfrm>
-            <a:off x="402336" y="4114800"/>
+            <a:off x="402336" y="3154679"/>
+            <a:ext cx="192024" cy="192024"/>
+          </a:xfrm>
+          <a:prstGeom prst="ellipse">
+            <a:avLst/>
+          </a:prstGeom>
+          <a:solidFill>
+            <a:srgbClr val="0944A1"/>
+          </a:solidFill>
+          <a:ln>
+            <a:noFill/>
+          </a:ln>
+        </p:spPr>
+        <p:style>
+          <a:lnRef idx="1">
+            <a:schemeClr val="accent1"/>
+          </a:lnRef>
+          <a:fillRef idx="3">
+            <a:schemeClr val="accent1"/>
+          </a:fillRef>
+          <a:effectRef idx="2">
+            <a:schemeClr val="accent1"/>
+          </a:effectRef>
+          <a:fontRef idx="minor">
+            <a:schemeClr val="lt1"/>
+          </a:fontRef>
+        </p:style>
+        <p:txBody>
+          <a:bodyPr rtlCol="0" anchor="ctr"/>
+          <a:lstStyle/>
+          <a:p>
+            <a:pPr algn="ctr"/>
+          </a:p>
+        </p:txBody>
+      </p:sp>
+      <p:sp>
+        <p:nvSpPr>
+          <p:cNvPr id="334" name="TextBox 333"/>
+          <p:cNvSpPr txBox="1"/>
+          <p:nvPr/>
+        </p:nvSpPr>
+        <p:spPr>
+          <a:xfrm>
+            <a:off x="694944" y="3342132"/>
+            <a:ext cx="6729984" cy="256032"/>
+          </a:xfrm>
+          <a:prstGeom prst="rect">
+            <a:avLst/>
+          </a:prstGeom>
+          <a:noFill/>
+        </p:spPr>
+        <p:txBody>
+          <a:bodyPr wrap="square" lIns="82296" rIns="36576" tIns="18288" bIns="18288">
+            <a:normAutofit/>
+          </a:bodyPr>
+          <a:lstStyle/>
+          <a:p>
+            <a:pPr>
+              <a:lnSpc>
+                <a:spcPct val="100000"/>
+              </a:lnSpc>
+              <a:spcBef>
+                <a:spcPts val="0"/>
+              </a:spcBef>
+              <a:spcAft>
+                <a:spcPts val="0"/>
+              </a:spcAft>
+            </a:pPr>
+            <a:r>
+              <a:rPr sz="1350" b="0">
+                <a:solidFill>
+                  <a:srgbClr val="000000"/>
+                </a:solidFill>
+                <a:latin typeface="Montserrat"/>
+              </a:rPr>
+              <a:t>Case 07 | Advance Purchase change | PASS | Composite .916</a:t>
+            </a:r>
+          </a:p>
+        </p:txBody>
+      </p:sp>
+      <p:sp>
+        <p:nvSpPr>
+          <p:cNvPr id="335" name="Oval 334"/>
+          <p:cNvSpPr/>
+          <p:nvPr/>
+        </p:nvSpPr>
+        <p:spPr>
+          <a:xfrm>
+            <a:off x="402336" y="3442715"/>
+            <a:ext cx="192024" cy="192024"/>
+          </a:xfrm>
+          <a:prstGeom prst="ellipse">
+            <a:avLst/>
+          </a:prstGeom>
+          <a:solidFill>
+            <a:srgbClr val="0944A1"/>
+          </a:solidFill>
+          <a:ln>
+            <a:noFill/>
+          </a:ln>
+        </p:spPr>
+        <p:style>
+          <a:lnRef idx="1">
+            <a:schemeClr val="accent1"/>
+          </a:lnRef>
+          <a:fillRef idx="3">
+            <a:schemeClr val="accent1"/>
+          </a:fillRef>
+          <a:effectRef idx="2">
+            <a:schemeClr val="accent1"/>
+          </a:effectRef>
+          <a:fontRef idx="minor">
+            <a:schemeClr val="lt1"/>
+          </a:fontRef>
+        </p:style>
+        <p:txBody>
+          <a:bodyPr rtlCol="0" anchor="ctr"/>
+          <a:lstStyle/>
+          <a:p>
+            <a:pPr algn="ctr"/>
+          </a:p>
+        </p:txBody>
+      </p:sp>
+      <p:sp>
+        <p:nvSpPr>
+          <p:cNvPr id="336" name="TextBox 335"/>
+          <p:cNvSpPr txBox="1"/>
+          <p:nvPr/>
+        </p:nvSpPr>
+        <p:spPr>
+          <a:xfrm>
+            <a:off x="694944" y="3630168"/>
+            <a:ext cx="6729984" cy="256032"/>
+          </a:xfrm>
+          <a:prstGeom prst="rect">
+            <a:avLst/>
+          </a:prstGeom>
+          <a:noFill/>
+        </p:spPr>
+        <p:txBody>
+          <a:bodyPr wrap="square" lIns="82296" rIns="36576" tIns="18288" bIns="18288">
+            <a:normAutofit/>
+          </a:bodyPr>
+          <a:lstStyle/>
+          <a:p>
+            <a:pPr>
+              <a:lnSpc>
+                <a:spcPct val="100000"/>
+              </a:lnSpc>
+              <a:spcBef>
+                <a:spcPts val="0"/>
+              </a:spcBef>
+              <a:spcAft>
+                <a:spcPts val="0"/>
+              </a:spcAft>
+            </a:pPr>
+            <a:r>
+              <a:rPr sz="1350" b="0">
+                <a:solidFill>
+                  <a:srgbClr val="000000"/>
+                </a:solidFill>
+                <a:latin typeface="Montserrat"/>
+              </a:rPr>
+              <a:t>Case 08 | Denver late checkout | PASS | Composite .939</a:t>
+            </a:r>
+          </a:p>
+        </p:txBody>
+      </p:sp>
+      <p:sp>
+        <p:nvSpPr>
+          <p:cNvPr id="337" name="Oval 336"/>
+          <p:cNvSpPr/>
+          <p:nvPr/>
+        </p:nvSpPr>
+        <p:spPr>
+          <a:xfrm>
+            <a:off x="402336" y="3730752"/>
+            <a:ext cx="192024" cy="192024"/>
+          </a:xfrm>
+          <a:prstGeom prst="ellipse">
+            <a:avLst/>
+          </a:prstGeom>
+          <a:solidFill>
+            <a:srgbClr val="0944A1"/>
+          </a:solidFill>
+          <a:ln>
+            <a:noFill/>
+          </a:ln>
+        </p:spPr>
+        <p:style>
+          <a:lnRef idx="1">
+            <a:schemeClr val="accent1"/>
+          </a:lnRef>
+          <a:fillRef idx="3">
+            <a:schemeClr val="accent1"/>
+          </a:fillRef>
+          <a:effectRef idx="2">
+            <a:schemeClr val="accent1"/>
+          </a:effectRef>
+          <a:fontRef idx="minor">
+            <a:schemeClr val="lt1"/>
+          </a:fontRef>
+        </p:style>
+        <p:txBody>
+          <a:bodyPr rtlCol="0" anchor="ctr"/>
+          <a:lstStyle/>
+          <a:p>
+            <a:pPr algn="ctr"/>
+          </a:p>
+        </p:txBody>
+      </p:sp>
+      <p:sp>
+        <p:nvSpPr>
+          <p:cNvPr id="338" name="TextBox 337"/>
+          <p:cNvSpPr txBox="1"/>
+          <p:nvPr/>
+        </p:nvSpPr>
+        <p:spPr>
+          <a:xfrm>
+            <a:off x="694944" y="3918204"/>
+            <a:ext cx="6729984" cy="256032"/>
+          </a:xfrm>
+          <a:prstGeom prst="rect">
+            <a:avLst/>
+          </a:prstGeom>
+          <a:noFill/>
+        </p:spPr>
+        <p:txBody>
+          <a:bodyPr wrap="square" lIns="82296" rIns="36576" tIns="18288" bIns="18288">
+            <a:normAutofit/>
+          </a:bodyPr>
+          <a:lstStyle/>
+          <a:p>
+            <a:pPr>
+              <a:lnSpc>
+                <a:spcPct val="100000"/>
+              </a:lnSpc>
+              <a:spcBef>
+                <a:spcPts val="0"/>
+              </a:spcBef>
+              <a:spcAft>
+                <a:spcPts val="0"/>
+              </a:spcAft>
+            </a:pPr>
+            <a:r>
+              <a:rPr sz="1350" b="0">
+                <a:solidFill>
+                  <a:srgbClr val="000000"/>
+                </a:solidFill>
+                <a:latin typeface="Montserrat"/>
+              </a:rPr>
+              <a:t>Case 09 | ASH-CHI pet fee | PASS | Composite .974</a:t>
+            </a:r>
+          </a:p>
+        </p:txBody>
+      </p:sp>
+      <p:sp>
+        <p:nvSpPr>
+          <p:cNvPr id="339" name="Oval 338"/>
+          <p:cNvSpPr/>
+          <p:nvPr/>
+        </p:nvSpPr>
+        <p:spPr>
+          <a:xfrm>
+            <a:off x="402336" y="4018788"/>
+            <a:ext cx="192024" cy="192024"/>
+          </a:xfrm>
+          <a:prstGeom prst="ellipse">
+            <a:avLst/>
+          </a:prstGeom>
+          <a:solidFill>
+            <a:srgbClr val="0944A1"/>
+          </a:solidFill>
+          <a:ln>
+            <a:noFill/>
+          </a:ln>
+        </p:spPr>
+        <p:style>
+          <a:lnRef idx="1">
+            <a:schemeClr val="accent1"/>
+          </a:lnRef>
+          <a:fillRef idx="3">
+            <a:schemeClr val="accent1"/>
+          </a:fillRef>
+          <a:effectRef idx="2">
+            <a:schemeClr val="accent1"/>
+          </a:effectRef>
+          <a:fontRef idx="minor">
+            <a:schemeClr val="lt1"/>
+          </a:fontRef>
+        </p:style>
+        <p:txBody>
+          <a:bodyPr rtlCol="0" anchor="ctr"/>
+          <a:lstStyle/>
+          <a:p>
+            <a:pPr algn="ctr"/>
+          </a:p>
+        </p:txBody>
+      </p:sp>
+      <p:sp>
+        <p:nvSpPr>
+          <p:cNvPr id="340" name="TextBox 339"/>
+          <p:cNvSpPr txBox="1"/>
+          <p:nvPr/>
+        </p:nvSpPr>
+        <p:spPr>
+          <a:xfrm>
+            <a:off x="694944" y="4206240"/>
+            <a:ext cx="6729984" cy="256032"/>
+          </a:xfrm>
+          <a:prstGeom prst="rect">
+            <a:avLst/>
+          </a:prstGeom>
+          <a:noFill/>
+        </p:spPr>
+        <p:txBody>
+          <a:bodyPr wrap="square" lIns="82296" rIns="36576" tIns="18288" bIns="18288">
+            <a:normAutofit/>
+          </a:bodyPr>
+          <a:lstStyle/>
+          <a:p>
+            <a:pPr>
+              <a:lnSpc>
+                <a:spcPct val="100000"/>
+              </a:lnSpc>
+              <a:spcBef>
+                <a:spcPts val="0"/>
+              </a:spcBef>
+              <a:spcAft>
+                <a:spcPts val="0"/>
+              </a:spcAft>
+            </a:pPr>
+            <a:r>
+              <a:rPr sz="1350" b="0">
+                <a:solidFill>
+                  <a:srgbClr val="000000"/>
+                </a:solidFill>
+                <a:latin typeface="Montserrat"/>
+              </a:rPr>
+              <a:t>Case 10 | Card-hold difference | PASS | Composite .934</a:t>
+            </a:r>
+          </a:p>
+        </p:txBody>
+      </p:sp>
+      <p:sp>
+        <p:nvSpPr>
+          <p:cNvPr id="341" name="Oval 340"/>
+          <p:cNvSpPr/>
+          <p:nvPr/>
+        </p:nvSpPr>
+        <p:spPr>
+          <a:xfrm>
+            <a:off x="402336" y="4306824"/>
+            <a:ext cx="192024" cy="192024"/>
+          </a:xfrm>
+          <a:prstGeom prst="ellipse">
+            <a:avLst/>
+          </a:prstGeom>
+          <a:solidFill>
+            <a:srgbClr val="0944A1"/>
+          </a:solidFill>
+          <a:ln>
+            <a:noFill/>
+          </a:ln>
+        </p:spPr>
+        <p:style>
+          <a:lnRef idx="1">
+            <a:schemeClr val="accent1"/>
+          </a:lnRef>
+          <a:fillRef idx="3">
+            <a:schemeClr val="accent1"/>
+          </a:fillRef>
+          <a:effectRef idx="2">
+            <a:schemeClr val="accent1"/>
+          </a:effectRef>
+          <a:fontRef idx="minor">
+            <a:schemeClr val="lt1"/>
+          </a:fontRef>
+        </p:style>
+        <p:txBody>
+          <a:bodyPr rtlCol="0" anchor="ctr"/>
+          <a:lstStyle/>
+          <a:p>
+            <a:pPr algn="ctr"/>
+          </a:p>
+        </p:txBody>
+      </p:sp>
+      <p:sp>
+        <p:nvSpPr>
+          <p:cNvPr id="342" name="TextBox 341"/>
+          <p:cNvSpPr txBox="1"/>
+          <p:nvPr/>
+        </p:nvSpPr>
+        <p:spPr>
+          <a:xfrm>
+            <a:off x="694944" y="4494276"/>
+            <a:ext cx="6729984" cy="187451"/>
+          </a:xfrm>
+          <a:prstGeom prst="rect">
+            <a:avLst/>
+          </a:prstGeom>
+          <a:noFill/>
+        </p:spPr>
+        <p:txBody>
+          <a:bodyPr wrap="square" lIns="82296" rIns="36576" tIns="18288" bIns="18288">
+            <a:normAutofit/>
+          </a:bodyPr>
+          <a:lstStyle/>
+          <a:p>
+            <a:pPr>
+              <a:lnSpc>
+                <a:spcPct val="100000"/>
+              </a:lnSpc>
+              <a:spcBef>
+                <a:spcPts val="0"/>
+              </a:spcBef>
+              <a:spcAft>
+                <a:spcPts val="0"/>
+              </a:spcAft>
+            </a:pPr>
+            <a:r>
+              <a:rPr sz="1350" b="0">
+                <a:solidFill>
+                  <a:srgbClr val="000000"/>
+                </a:solidFill>
+                <a:latin typeface="Montserrat"/>
+              </a:rPr>
+              <a:t>Selected baseline result: 9/10 passed; weighted composite .941.</a:t>
+            </a:r>
+          </a:p>
+        </p:txBody>
+      </p:sp>
+      <p:sp>
+        <p:nvSpPr>
+          <p:cNvPr id="343" name="Oval 342"/>
+          <p:cNvSpPr/>
+          <p:nvPr/>
+        </p:nvSpPr>
+        <p:spPr>
+          <a:xfrm>
+            <a:off x="402336" y="4594860"/>
+            <a:ext cx="192024" cy="192024"/>
+          </a:xfrm>
+          <a:prstGeom prst="ellipse">
+            <a:avLst/>
+          </a:prstGeom>
+          <a:solidFill>
+            <a:srgbClr val="0944A1"/>
+          </a:solidFill>
+          <a:ln>
+            <a:noFill/>
+          </a:ln>
+        </p:spPr>
+        <p:style>
+          <a:lnRef idx="1">
+            <a:schemeClr val="accent1"/>
+          </a:lnRef>
+          <a:fillRef idx="3">
+            <a:schemeClr val="accent1"/>
+          </a:fillRef>
+          <a:effectRef idx="2">
+            <a:schemeClr val="accent1"/>
+          </a:effectRef>
+          <a:fontRef idx="minor">
+            <a:schemeClr val="lt1"/>
+          </a:fontRef>
+        </p:style>
+        <p:txBody>
+          <a:bodyPr rtlCol="0" anchor="ctr"/>
+          <a:lstStyle/>
+          <a:p>
+            <a:pPr algn="ctr"/>
+          </a:p>
+        </p:txBody>
+      </p:sp>
+      <p:sp>
+        <p:nvSpPr>
+          <p:cNvPr id="344" name="TextBox 343"/>
+          <p:cNvSpPr txBox="1"/>
+          <p:nvPr/>
+        </p:nvSpPr>
+        <p:spPr>
+          <a:xfrm>
+            <a:off x="694944" y="4713732"/>
+            <a:ext cx="6729984" cy="182880"/>
+          </a:xfrm>
+          <a:prstGeom prst="rect">
+            <a:avLst/>
+          </a:prstGeom>
+          <a:noFill/>
+        </p:spPr>
+        <p:txBody>
+          <a:bodyPr wrap="square" lIns="82296" rIns="36576" tIns="18288" bIns="18288">
+            <a:normAutofit/>
+          </a:bodyPr>
+          <a:lstStyle/>
+          <a:p>
+            <a:pPr>
+              <a:lnSpc>
+                <a:spcPct val="100000"/>
+              </a:lnSpc>
+              <a:spcBef>
+                <a:spcPts val="0"/>
+              </a:spcBef>
+              <a:spcAft>
+                <a:spcPts val="0"/>
+              </a:spcAft>
+            </a:pPr>
+            <a:r>
+              <a:rPr sz="1350" b="0">
+                <a:solidFill>
+                  <a:srgbClr val="000000"/>
+                </a:solidFill>
+                <a:latin typeface="Montserrat"/>
+              </a:rPr>
+              <a:t>The focused clarification experiment raised the failed case's Precision to .961 and passed all four metrics.</a:t>
+            </a:r>
+          </a:p>
+        </p:txBody>
+      </p:sp>
+      <p:sp>
+        <p:nvSpPr>
+          <p:cNvPr id="345" name="Oval 344"/>
+          <p:cNvSpPr/>
+          <p:nvPr/>
+        </p:nvSpPr>
+        <p:spPr>
+          <a:xfrm>
+            <a:off x="402336" y="4814316"/>
             <a:ext cx="192024" cy="192024"/>
           </a:xfrm>
           <a:prstGeom prst="ellipse">
@@ -42990,7 +43737,7 @@
                 </a:solidFill>
                 <a:latin typeface="Montserrat"/>
               </a:rPr>
-              <a:t>Latest published commit: 7fda05a — Publish latest Aurora Stays evaluation and presentation.</a:t>
+              <a:t>Latest published commit: 3b34c59 — removed the handoff-owner line from slide 31.</a:t>
             </a:r>
           </a:p>
         </p:txBody>
@@ -43047,7 +43794,7 @@
         <p:spPr>
           <a:xfrm>
             <a:off x="694944" y="2093976"/>
-            <a:ext cx="6729984" cy="649224"/>
+            <a:ext cx="6729984" cy="448056"/>
           </a:xfrm>
           <a:prstGeom prst="rect">
             <a:avLst/>
@@ -43078,7 +43825,7 @@
                 </a:solidFill>
                 <a:latin typeface="Montserrat"/>
               </a:rPr>
-              <a:t>Published groups include backend and frontend source, FAISS artifacts, the final executed notebook, evaluation CSVs, and the presentation pack.</a:t>
+              <a:t>Key files: backend/app.py, backend/rag_utils.py, frontend/app.py, Dockerfiles, and requirements files.</a:t>
             </a:r>
           </a:p>
         </p:txBody>
@@ -43134,8 +43881,8 @@
         </p:nvSpPr>
         <p:spPr>
           <a:xfrm>
-            <a:off x="694944" y="2775204"/>
-            <a:ext cx="6729984" cy="448056"/>
+            <a:off x="694944" y="2574036"/>
+            <a:ext cx="6729984" cy="649224"/>
           </a:xfrm>
           <a:prstGeom prst="rect">
             <a:avLst/>
@@ -43166,7 +43913,7 @@
                 </a:solidFill>
                 <a:latin typeface="Montserrat"/>
               </a:rPr>
-              <a:t>The supplied template and generated PPTX/PDF presentation files are included for handoff.</a:t>
+              <a:t>Evaluation files: notebooks/Aurora_Stays_RAG_POC_Local_final_executed.ipynb, reports/evaluation_results.md, and deepeval_options_cases.csv.</a:t>
             </a:r>
           </a:p>
         </p:txBody>
@@ -43179,7 +43926,7 @@
         </p:nvSpPr>
         <p:spPr>
           <a:xfrm>
-            <a:off x="402336" y="2875788"/>
+            <a:off x="402336" y="2674620"/>
             <a:ext cx="192024" cy="192024"/>
           </a:xfrm>
           <a:prstGeom prst="ellipse">
@@ -43254,6 +44001,94 @@
                 </a:solidFill>
                 <a:latin typeface="Montserrat"/>
               </a:rPr>
+              <a:t>Presentation files: build_aurora_presentation.py, the template-style PPTX, and the generated PDF packs.</a:t>
+            </a:r>
+          </a:p>
+        </p:txBody>
+      </p:sp>
+      <p:sp>
+        <p:nvSpPr>
+          <p:cNvPr id="385" name="Oval 384"/>
+          <p:cNvSpPr/>
+          <p:nvPr/>
+        </p:nvSpPr>
+        <p:spPr>
+          <a:xfrm>
+            <a:off x="402336" y="3355848"/>
+            <a:ext cx="192024" cy="192024"/>
+          </a:xfrm>
+          <a:prstGeom prst="ellipse">
+            <a:avLst/>
+          </a:prstGeom>
+          <a:solidFill>
+            <a:srgbClr val="0944A1"/>
+          </a:solidFill>
+          <a:ln>
+            <a:noFill/>
+          </a:ln>
+        </p:spPr>
+        <p:style>
+          <a:lnRef idx="1">
+            <a:schemeClr val="accent1"/>
+          </a:lnRef>
+          <a:fillRef idx="3">
+            <a:schemeClr val="accent1"/>
+          </a:fillRef>
+          <a:effectRef idx="2">
+            <a:schemeClr val="accent1"/>
+          </a:effectRef>
+          <a:fontRef idx="minor">
+            <a:schemeClr val="lt1"/>
+          </a:fontRef>
+        </p:style>
+        <p:txBody>
+          <a:bodyPr rtlCol="0" anchor="ctr"/>
+          <a:lstStyle/>
+          <a:p>
+            <a:pPr algn="ctr"/>
+          </a:p>
+        </p:txBody>
+      </p:sp>
+      <p:sp>
+        <p:nvSpPr>
+          <p:cNvPr id="386" name="TextBox 385"/>
+          <p:cNvSpPr txBox="1"/>
+          <p:nvPr/>
+        </p:nvSpPr>
+        <p:spPr>
+          <a:xfrm>
+            <a:off x="694944" y="3735324"/>
+            <a:ext cx="6729984" cy="448056"/>
+          </a:xfrm>
+          <a:prstGeom prst="rect">
+            <a:avLst/>
+          </a:prstGeom>
+          <a:noFill/>
+        </p:spPr>
+        <p:txBody>
+          <a:bodyPr wrap="square" lIns="82296" rIns="36576" tIns="18288" bIns="18288">
+            <a:normAutofit/>
+          </a:bodyPr>
+          <a:lstStyle/>
+          <a:p>
+            <a:pPr>
+              <a:lnSpc>
+                <a:spcPct val="100000"/>
+              </a:lnSpc>
+              <a:spcBef>
+                <a:spcPts val="0"/>
+              </a:spcBef>
+              <a:spcAft>
+                <a:spcPts val="0"/>
+              </a:spcAft>
+            </a:pPr>
+            <a:r>
+              <a:rPr sz="1350" b="0">
+                <a:solidFill>
+                  <a:srgbClr val="000000"/>
+                </a:solidFill>
+                <a:latin typeface="Montserrat"/>
+              </a:rPr>
               <a:t>Credentials remain excluded: config/config.json, .env, and supplied token/config files are not tracked.</a:t>
             </a:r>
           </a:p>
@@ -43261,13 +44096,13 @@
       </p:sp>
       <p:sp>
         <p:nvSpPr>
-          <p:cNvPr id="385" name="Oval 384"/>
+          <p:cNvPr id="387" name="Oval 386"/>
           <p:cNvSpPr/>
           <p:nvPr/>
         </p:nvSpPr>
         <p:spPr>
           <a:xfrm>
-            <a:off x="402336" y="3355848"/>
+            <a:off x="402336" y="3835908"/>
             <a:ext cx="192024" cy="192024"/>
           </a:xfrm>
           <a:prstGeom prst="ellipse">
@@ -43713,7 +44548,7 @@
                 </a:solidFill>
                 <a:latin typeface="Montserrat"/>
               </a:rPr>
-              <a:t>Production smoke tests used the parking-fee query and the ASH-CHI Loop pet-charge query.</a:t>
+              <a:t>Validated local endpoints: frontend http://localhost:8501 and backend http://127.0.0.1:5000.</a:t>
             </a:r>
           </a:p>
         </p:txBody>
@@ -43801,6 +44636,94 @@
                 </a:solidFill>
                 <a:latin typeface="Montserrat"/>
               </a:rPr>
+              <a:t>Production smoke tests used the parking-fee query and the ASH-CHI Loop pet-charge query.</a:t>
+            </a:r>
+          </a:p>
+        </p:txBody>
+      </p:sp>
+      <p:sp>
+        <p:nvSpPr>
+          <p:cNvPr id="393" name="Oval 392"/>
+          <p:cNvSpPr/>
+          <p:nvPr/>
+        </p:nvSpPr>
+        <p:spPr>
+          <a:xfrm>
+            <a:off x="402336" y="3346703"/>
+            <a:ext cx="192024" cy="192024"/>
+          </a:xfrm>
+          <a:prstGeom prst="ellipse">
+            <a:avLst/>
+          </a:prstGeom>
+          <a:solidFill>
+            <a:srgbClr val="0944A1"/>
+          </a:solidFill>
+          <a:ln>
+            <a:noFill/>
+          </a:ln>
+        </p:spPr>
+        <p:style>
+          <a:lnRef idx="1">
+            <a:schemeClr val="accent1"/>
+          </a:lnRef>
+          <a:fillRef idx="3">
+            <a:schemeClr val="accent1"/>
+          </a:fillRef>
+          <a:effectRef idx="2">
+            <a:schemeClr val="accent1"/>
+          </a:effectRef>
+          <a:fontRef idx="minor">
+            <a:schemeClr val="lt1"/>
+          </a:fontRef>
+        </p:style>
+        <p:txBody>
+          <a:bodyPr rtlCol="0" anchor="ctr"/>
+          <a:lstStyle/>
+          <a:p>
+            <a:pPr algn="ctr"/>
+          </a:p>
+        </p:txBody>
+      </p:sp>
+      <p:sp>
+        <p:nvSpPr>
+          <p:cNvPr id="394" name="TextBox 393"/>
+          <p:cNvSpPr txBox="1"/>
+          <p:nvPr/>
+        </p:nvSpPr>
+        <p:spPr>
+          <a:xfrm>
+            <a:off x="694944" y="3726180"/>
+            <a:ext cx="6729984" cy="448056"/>
+          </a:xfrm>
+          <a:prstGeom prst="rect">
+            <a:avLst/>
+          </a:prstGeom>
+          <a:noFill/>
+        </p:spPr>
+        <p:txBody>
+          <a:bodyPr wrap="square" lIns="82296" rIns="36576" tIns="18288" bIns="18288">
+            <a:normAutofit/>
+          </a:bodyPr>
+          <a:lstStyle/>
+          <a:p>
+            <a:pPr>
+              <a:lnSpc>
+                <a:spcPct val="100000"/>
+              </a:lnSpc>
+              <a:spcBef>
+                <a:spcPts val="0"/>
+              </a:spcBef>
+              <a:spcAft>
+                <a:spcPts val="0"/>
+              </a:spcAft>
+            </a:pPr>
+            <a:r>
+              <a:rPr sz="1350" b="0">
+                <a:solidFill>
+                  <a:srgbClr val="000000"/>
+                </a:solidFill>
+                <a:latin typeface="Montserrat"/>
+              </a:rPr>
               <a:t>API keys belong in Codespaces Secrets or a private local config file, never in the forwarded URL or source code.</a:t>
             </a:r>
           </a:p>
@@ -43808,13 +44731,13 @@
       </p:sp>
       <p:sp>
         <p:nvSpPr>
-          <p:cNvPr id="393" name="Oval 392"/>
+          <p:cNvPr id="395" name="Oval 394"/>
           <p:cNvSpPr/>
           <p:nvPr/>
         </p:nvSpPr>
         <p:spPr>
           <a:xfrm>
-            <a:off x="402336" y="3346703"/>
+            <a:off x="402336" y="3826764"/>
             <a:ext cx="192024" cy="192024"/>
           </a:xfrm>
           <a:prstGeom prst="ellipse">
@@ -44229,7 +45152,7 @@
         <p:spPr>
           <a:xfrm>
             <a:off x="694944" y="2382012"/>
-            <a:ext cx="6729984" cy="448056"/>
+            <a:ext cx="6729984" cy="649224"/>
           </a:xfrm>
           <a:prstGeom prst="rect">
             <a:avLst/>
@@ -44260,7 +45183,7 @@
                 </a:solidFill>
                 <a:latin typeface="Montserrat"/>
               </a:rPr>
-              <a:t>Expected evidence includes ASH-ATL Midtown self parking at $28 per night and ASH-MIA Brickell valet at $55 per night.</a:t>
+              <a:t>Response excerpt: relevant_chunks include ASH-ATL Midtown self parking at $28 per night and ASH-MIA Brickell valet at $55 per night.</a:t>
             </a:r>
           </a:p>
         </p:txBody>
@@ -44316,7 +45239,7 @@
         </p:nvSpPr>
         <p:spPr>
           <a:xfrm>
-            <a:off x="694944" y="2862072"/>
+            <a:off x="694944" y="3063240"/>
             <a:ext cx="6729984" cy="448056"/>
           </a:xfrm>
           <a:prstGeom prst="rect">
@@ -44361,7 +45284,7 @@
         </p:nvSpPr>
         <p:spPr>
           <a:xfrm>
-            <a:off x="402336" y="2962656"/>
+            <a:off x="402336" y="3163824"/>
             <a:ext cx="192024" cy="192024"/>
           </a:xfrm>
           <a:prstGeom prst="ellipse">
@@ -44807,7 +45730,7 @@
                 </a:solidFill>
                 <a:latin typeface="Montserrat"/>
               </a:rPr>
-              <a:t>The parking example returns a grounded comparison of the Atlanta and Miami fees with supporting chunks.</a:t>
+              <a:t>Answer excerpt: Atlanta Midtown self parking is $28 per night; Miami Brickell uses valet parking at $55 per night.</a:t>
             </a:r>
           </a:p>
         </p:txBody>
@@ -44895,6 +45818,94 @@
                 </a:solidFill>
                 <a:latin typeface="Montserrat"/>
               </a:rPr>
+              <a:t>The response also returns the supporting chunks for auditability.</a:t>
+            </a:r>
+          </a:p>
+        </p:txBody>
+      </p:sp>
+      <p:sp>
+        <p:nvSpPr>
+          <p:cNvPr id="409" name="Oval 408"/>
+          <p:cNvSpPr/>
+          <p:nvPr/>
+        </p:nvSpPr>
+        <p:spPr>
+          <a:xfrm>
+            <a:off x="402336" y="3154679"/>
+            <a:ext cx="192024" cy="192024"/>
+          </a:xfrm>
+          <a:prstGeom prst="ellipse">
+            <a:avLst/>
+          </a:prstGeom>
+          <a:solidFill>
+            <a:srgbClr val="0944A1"/>
+          </a:solidFill>
+          <a:ln>
+            <a:noFill/>
+          </a:ln>
+        </p:spPr>
+        <p:style>
+          <a:lnRef idx="1">
+            <a:schemeClr val="accent1"/>
+          </a:lnRef>
+          <a:fillRef idx="3">
+            <a:schemeClr val="accent1"/>
+          </a:fillRef>
+          <a:effectRef idx="2">
+            <a:schemeClr val="accent1"/>
+          </a:effectRef>
+          <a:fontRef idx="minor">
+            <a:schemeClr val="lt1"/>
+          </a:fontRef>
+        </p:style>
+        <p:txBody>
+          <a:bodyPr rtlCol="0" anchor="ctr"/>
+          <a:lstStyle/>
+          <a:p>
+            <a:pPr algn="ctr"/>
+          </a:p>
+        </p:txBody>
+      </p:sp>
+      <p:sp>
+        <p:nvSpPr>
+          <p:cNvPr id="410" name="TextBox 409"/>
+          <p:cNvSpPr txBox="1"/>
+          <p:nvPr/>
+        </p:nvSpPr>
+        <p:spPr>
+          <a:xfrm>
+            <a:off x="694944" y="3534156"/>
+            <a:ext cx="6729984" cy="448056"/>
+          </a:xfrm>
+          <a:prstGeom prst="rect">
+            <a:avLst/>
+          </a:prstGeom>
+          <a:noFill/>
+        </p:spPr>
+        <p:txBody>
+          <a:bodyPr wrap="square" lIns="82296" rIns="36576" tIns="18288" bIns="18288">
+            <a:normAutofit/>
+          </a:bodyPr>
+          <a:lstStyle/>
+          <a:p>
+            <a:pPr>
+              <a:lnSpc>
+                <a:spcPct val="100000"/>
+              </a:lnSpc>
+              <a:spcBef>
+                <a:spcPts val="0"/>
+              </a:spcBef>
+              <a:spcAft>
+                <a:spcPts val="0"/>
+              </a:spcAft>
+            </a:pPr>
+            <a:r>
+              <a:rPr sz="1350" b="0">
+                <a:solidFill>
+                  <a:srgbClr val="000000"/>
+                </a:solidFill>
+                <a:latin typeface="Montserrat"/>
+              </a:rPr>
               <a:t>Use POST /v1/answer when only the final answer is required; use this endpoint for auditability.</a:t>
             </a:r>
           </a:p>
@@ -44902,13 +45913,13 @@
       </p:sp>
       <p:sp>
         <p:nvSpPr>
-          <p:cNvPr id="409" name="Oval 408"/>
+          <p:cNvPr id="411" name="Oval 410"/>
           <p:cNvSpPr/>
           <p:nvPr/>
         </p:nvSpPr>
         <p:spPr>
           <a:xfrm>
-            <a:off x="402336" y="3154679"/>
+            <a:off x="402336" y="3634739"/>
             <a:ext cx="192024" cy="192024"/>
           </a:xfrm>
           <a:prstGeom prst="ellipse">
@@ -46272,7 +47283,7 @@
                 </a:solidFill>
                 <a:latin typeface="Montserrat"/>
               </a:rPr>
-              <a:t>Production Readiness and Handoff Notes</a:t>
+              <a:t>Recommendations and Success Measures</a:t>
             </a:r>
           </a:p>
         </p:txBody>
@@ -46360,7 +47371,7 @@
                 </a:solidFill>
                 <a:latin typeface="Montserrat"/>
               </a:rPr>
-              <a:t>Selected baseline: k=5 with chunk_size=512, overlap=64, MMR lambda=0.50, fetch_k=20, and CrossEncoder reranking.</a:t>
+              <a:t>Recommendation 1: pilot the k=5 baseline with evidence display enabled for support staff.</a:t>
             </a:r>
           </a:p>
         </p:txBody>
@@ -46448,7 +47459,7 @@
                 </a:solidFill>
                 <a:latin typeface="Montserrat"/>
               </a:rPr>
-              <a:t>Held-out result: 9/10 cases passed; weighted composite score 0.941.</a:t>
+              <a:t>Recommendation 2: route ambiguous or insufficient-context questions to assisted review rather than forcing an auto-answer.</a:t>
             </a:r>
           </a:p>
         </p:txBody>
@@ -46536,7 +47547,7 @@
                 </a:solidFill>
                 <a:latin typeface="Montserrat"/>
               </a:rPr>
-              <a:t>The application is runnable through the Flask backend and Streamlit frontend, locally or in GitHub Codespaces.</a:t>
+              <a:t>Recommendation 3: keep the benchmark question unchanged, but improve production question clarification and prompt handling.</a:t>
             </a:r>
           </a:p>
         </p:txBody>
@@ -46593,7 +47604,7 @@
         <p:spPr>
           <a:xfrm>
             <a:off x="694944" y="2766060"/>
-            <a:ext cx="6729984" cy="649224"/>
+            <a:ext cx="6729984" cy="448056"/>
           </a:xfrm>
           <a:prstGeom prst="rect">
             <a:avLst/>
@@ -46624,7 +47635,7 @@
                 </a:solidFill>
                 <a:latin typeface="Montserrat"/>
               </a:rPr>
-              <a:t>Keep the benchmark question unchanged for evaluation; treat the remaining precision issue as a question/auto-answer limitation.</a:t>
+              <a:t>Track success through held-out pass rate, Contextual Precision, escalation rate, answer latency, and evidence-click usage.</a:t>
             </a:r>
           </a:p>
         </p:txBody>
@@ -46680,7 +47691,7 @@
         </p:nvSpPr>
         <p:spPr>
           <a:xfrm>
-            <a:off x="694944" y="3447288"/>
+            <a:off x="694944" y="3246120"/>
             <a:ext cx="6729984" cy="448056"/>
           </a:xfrm>
           <a:prstGeom prst="rect">
@@ -46712,7 +47723,7 @@
                 </a:solidFill>
                 <a:latin typeface="Montserrat"/>
               </a:rPr>
-              <a:t>Next operational step: add monitoring for insufficient context and review the single known failure before broader rollout.</a:t>
+              <a:t>Before broader rollout, capture the live Codespaces URL and screenshots, then repeat the two production smoke tests.</a:t>
             </a:r>
           </a:p>
         </p:txBody>
@@ -46725,7 +47736,95 @@
         </p:nvSpPr>
         <p:spPr>
           <a:xfrm>
-            <a:off x="402336" y="3547872"/>
+            <a:off x="402336" y="3346703"/>
+            <a:ext cx="192024" cy="192024"/>
+          </a:xfrm>
+          <a:prstGeom prst="ellipse">
+            <a:avLst/>
+          </a:prstGeom>
+          <a:solidFill>
+            <a:srgbClr val="0944A1"/>
+          </a:solidFill>
+          <a:ln>
+            <a:noFill/>
+          </a:ln>
+        </p:spPr>
+        <p:style>
+          <a:lnRef idx="1">
+            <a:schemeClr val="accent1"/>
+          </a:lnRef>
+          <a:fillRef idx="3">
+            <a:schemeClr val="accent1"/>
+          </a:fillRef>
+          <a:effectRef idx="2">
+            <a:schemeClr val="accent1"/>
+          </a:effectRef>
+          <a:fontRef idx="minor">
+            <a:schemeClr val="lt1"/>
+          </a:fontRef>
+        </p:style>
+        <p:txBody>
+          <a:bodyPr rtlCol="0" anchor="ctr"/>
+          <a:lstStyle/>
+          <a:p>
+            <a:pPr algn="ctr"/>
+          </a:p>
+        </p:txBody>
+      </p:sp>
+      <p:sp>
+        <p:nvSpPr>
+          <p:cNvPr id="424" name="TextBox 423"/>
+          <p:cNvSpPr txBox="1"/>
+          <p:nvPr/>
+        </p:nvSpPr>
+        <p:spPr>
+          <a:xfrm>
+            <a:off x="694944" y="3726180"/>
+            <a:ext cx="6729984" cy="448056"/>
+          </a:xfrm>
+          <a:prstGeom prst="rect">
+            <a:avLst/>
+          </a:prstGeom>
+          <a:noFill/>
+        </p:spPr>
+        <p:txBody>
+          <a:bodyPr wrap="square" lIns="82296" rIns="36576" tIns="18288" bIns="18288">
+            <a:normAutofit/>
+          </a:bodyPr>
+          <a:lstStyle/>
+          <a:p>
+            <a:pPr>
+              <a:lnSpc>
+                <a:spcPct val="100000"/>
+              </a:lnSpc>
+              <a:spcBef>
+                <a:spcPts val="0"/>
+              </a:spcBef>
+              <a:spcAft>
+                <a:spcPts val="0"/>
+              </a:spcAft>
+            </a:pPr>
+            <a:r>
+              <a:rPr sz="1350" b="0">
+                <a:solidFill>
+                  <a:srgbClr val="000000"/>
+                </a:solidFill>
+                <a:latin typeface="Montserrat"/>
+              </a:rPr>
+              <a:t>Decision: proceed with a controlled pilot; review the single known Accessible King failure before wider release.</a:t>
+            </a:r>
+          </a:p>
+        </p:txBody>
+      </p:sp>
+      <p:sp>
+        <p:nvSpPr>
+          <p:cNvPr id="425" name="Oval 424"/>
+          <p:cNvSpPr/>
+          <p:nvPr/>
+        </p:nvSpPr>
+        <p:spPr>
+          <a:xfrm>
+            <a:off x="402336" y="3826764"/>
             <a:ext cx="192024" cy="192024"/>
           </a:xfrm>
           <a:prstGeom prst="ellipse">

</xml_diff>

<commit_message>
Convert slide 19 results to a table
</commit_message>
<xml_diff>
--- a/presentations/Aurora_Stays_RAG_Project_Presentation_Template_Style.pptx
+++ b/presentations/Aurora_Stays_RAG_Project_Presentation_Template_Style.pptx
@@ -37905,16 +37905,2974 @@
           </a:p>
         </p:txBody>
       </p:sp>
-      <p:sp>
-        <p:nvSpPr>
-          <p:cNvPr id="320" name="TextBox 319"/>
+      <p:graphicFrame>
+        <p:nvGraphicFramePr>
+          <p:cNvPr id="320" name="Table 319"/>
+          <p:cNvGraphicFramePr>
+            <a:graphicFrameLocks noGrp="1"/>
+          </p:cNvGraphicFramePr>
+          <p:nvPr/>
+        </p:nvGraphicFramePr>
+        <p:xfrm>
+          <a:off x="438912" y="1207008"/>
+          <a:ext cx="6821424" cy="3401568"/>
+        </p:xfrm>
+        <a:graphic>
+          <a:graphicData uri="http://schemas.openxmlformats.org/drawingml/2006/table">
+            <a:tbl>
+              <a:tblPr firstRow="1" bandRow="1">
+                <a:tableStyleId>{5C22544A-7EE6-4342-B048-85BDC9FD1C3A}</a:tableStyleId>
+              </a:tblPr>
+              <a:tblGrid>
+                <a:gridCol w="429768"/>
+                <a:gridCol w="2743200"/>
+                <a:gridCol w="530352"/>
+                <a:gridCol w="530352"/>
+                <a:gridCol w="530352"/>
+                <a:gridCol w="530352"/>
+                <a:gridCol w="777240"/>
+                <a:gridCol w="749808"/>
+              </a:tblGrid>
+              <a:tr h="309233">
+                <a:tc>
+                  <a:txBody>
+                    <a:bodyPr/>
+                    <a:lstStyle/>
+                    <a:p>
+                      <a:pPr algn="ctr">
+                        <a:lnSpc>
+                          <a:spcPct val="100000"/>
+                        </a:lnSpc>
+                        <a:spcBef>
+                          <a:spcPts val="0"/>
+                        </a:spcBef>
+                        <a:spcAft>
+                          <a:spcPts val="0"/>
+                        </a:spcAft>
+                      </a:pPr>
+                      <a:r>
+                        <a:rPr sz="819" b="1">
+                          <a:solidFill>
+                            <a:srgbClr val="FFFFFF"/>
+                          </a:solidFill>
+                          <a:latin typeface="Montserrat"/>
+                        </a:rPr>
+                        <a:t>Case</a:t>
+                      </a:r>
+                    </a:p>
+                  </a:txBody>
+                  <a:tcPr marL="32004" marR="32004" marT="9144" marB="9144">
+                    <a:solidFill>
+                      <a:srgbClr val="0E39A9"/>
+                    </a:solidFill>
+                  </a:tcPr>
+                </a:tc>
+                <a:tc>
+                  <a:txBody>
+                    <a:bodyPr/>
+                    <a:lstStyle/>
+                    <a:p>
+                      <a:pPr algn="l">
+                        <a:lnSpc>
+                          <a:spcPct val="100000"/>
+                        </a:lnSpc>
+                        <a:spcBef>
+                          <a:spcPts val="0"/>
+                        </a:spcBef>
+                        <a:spcAft>
+                          <a:spcPts val="0"/>
+                        </a:spcAft>
+                      </a:pPr>
+                      <a:r>
+                        <a:rPr sz="819" b="1">
+                          <a:solidFill>
+                            <a:srgbClr val="FFFFFF"/>
+                          </a:solidFill>
+                          <a:latin typeface="Montserrat"/>
+                        </a:rPr>
+                        <a:t>Test case</a:t>
+                      </a:r>
+                    </a:p>
+                  </a:txBody>
+                  <a:tcPr marL="32004" marR="32004" marT="9144" marB="9144">
+                    <a:solidFill>
+                      <a:srgbClr val="0E39A9"/>
+                    </a:solidFill>
+                  </a:tcPr>
+                </a:tc>
+                <a:tc>
+                  <a:txBody>
+                    <a:bodyPr/>
+                    <a:lstStyle/>
+                    <a:p>
+                      <a:pPr algn="ctr">
+                        <a:lnSpc>
+                          <a:spcPct val="100000"/>
+                        </a:lnSpc>
+                        <a:spcBef>
+                          <a:spcPts val="0"/>
+                        </a:spcBef>
+                        <a:spcAft>
+                          <a:spcPts val="0"/>
+                        </a:spcAft>
+                      </a:pPr>
+                      <a:r>
+                        <a:rPr sz="819" b="1">
+                          <a:solidFill>
+                            <a:srgbClr val="FFFFFF"/>
+                          </a:solidFill>
+                          <a:latin typeface="Montserrat"/>
+                        </a:rPr>
+                        <a:t>F</a:t>
+                      </a:r>
+                    </a:p>
+                  </a:txBody>
+                  <a:tcPr marL="32004" marR="32004" marT="9144" marB="9144">
+                    <a:solidFill>
+                      <a:srgbClr val="0E39A9"/>
+                    </a:solidFill>
+                  </a:tcPr>
+                </a:tc>
+                <a:tc>
+                  <a:txBody>
+                    <a:bodyPr/>
+                    <a:lstStyle/>
+                    <a:p>
+                      <a:pPr algn="ctr">
+                        <a:lnSpc>
+                          <a:spcPct val="100000"/>
+                        </a:lnSpc>
+                        <a:spcBef>
+                          <a:spcPts val="0"/>
+                        </a:spcBef>
+                        <a:spcAft>
+                          <a:spcPts val="0"/>
+                        </a:spcAft>
+                      </a:pPr>
+                      <a:r>
+                        <a:rPr sz="819" b="1">
+                          <a:solidFill>
+                            <a:srgbClr val="FFFFFF"/>
+                          </a:solidFill>
+                          <a:latin typeface="Montserrat"/>
+                        </a:rPr>
+                        <a:t>R</a:t>
+                      </a:r>
+                    </a:p>
+                  </a:txBody>
+                  <a:tcPr marL="32004" marR="32004" marT="9144" marB="9144">
+                    <a:solidFill>
+                      <a:srgbClr val="0E39A9"/>
+                    </a:solidFill>
+                  </a:tcPr>
+                </a:tc>
+                <a:tc>
+                  <a:txBody>
+                    <a:bodyPr/>
+                    <a:lstStyle/>
+                    <a:p>
+                      <a:pPr algn="ctr">
+                        <a:lnSpc>
+                          <a:spcPct val="100000"/>
+                        </a:lnSpc>
+                        <a:spcBef>
+                          <a:spcPts val="0"/>
+                        </a:spcBef>
+                        <a:spcAft>
+                          <a:spcPts val="0"/>
+                        </a:spcAft>
+                      </a:pPr>
+                      <a:r>
+                        <a:rPr sz="819" b="1">
+                          <a:solidFill>
+                            <a:srgbClr val="FFFFFF"/>
+                          </a:solidFill>
+                          <a:latin typeface="Montserrat"/>
+                        </a:rPr>
+                        <a:t>P</a:t>
+                      </a:r>
+                    </a:p>
+                  </a:txBody>
+                  <a:tcPr marL="32004" marR="32004" marT="9144" marB="9144">
+                    <a:solidFill>
+                      <a:srgbClr val="0E39A9"/>
+                    </a:solidFill>
+                  </a:tcPr>
+                </a:tc>
+                <a:tc>
+                  <a:txBody>
+                    <a:bodyPr/>
+                    <a:lstStyle/>
+                    <a:p>
+                      <a:pPr algn="ctr">
+                        <a:lnSpc>
+                          <a:spcPct val="100000"/>
+                        </a:lnSpc>
+                        <a:spcBef>
+                          <a:spcPts val="0"/>
+                        </a:spcBef>
+                        <a:spcAft>
+                          <a:spcPts val="0"/>
+                        </a:spcAft>
+                      </a:pPr>
+                      <a:r>
+                        <a:rPr sz="819" b="1">
+                          <a:solidFill>
+                            <a:srgbClr val="FFFFFF"/>
+                          </a:solidFill>
+                          <a:latin typeface="Montserrat"/>
+                        </a:rPr>
+                        <a:t>AR</a:t>
+                      </a:r>
+                    </a:p>
+                  </a:txBody>
+                  <a:tcPr marL="32004" marR="32004" marT="9144" marB="9144">
+                    <a:solidFill>
+                      <a:srgbClr val="0E39A9"/>
+                    </a:solidFill>
+                  </a:tcPr>
+                </a:tc>
+                <a:tc>
+                  <a:txBody>
+                    <a:bodyPr/>
+                    <a:lstStyle/>
+                    <a:p>
+                      <a:pPr algn="ctr">
+                        <a:lnSpc>
+                          <a:spcPct val="100000"/>
+                        </a:lnSpc>
+                        <a:spcBef>
+                          <a:spcPts val="0"/>
+                        </a:spcBef>
+                        <a:spcAft>
+                          <a:spcPts val="0"/>
+                        </a:spcAft>
+                      </a:pPr>
+                      <a:r>
+                        <a:rPr sz="819" b="1">
+                          <a:solidFill>
+                            <a:srgbClr val="FFFFFF"/>
+                          </a:solidFill>
+                          <a:latin typeface="Montserrat"/>
+                        </a:rPr>
+                        <a:t>Composite</a:t>
+                      </a:r>
+                    </a:p>
+                  </a:txBody>
+                  <a:tcPr marL="32004" marR="32004" marT="9144" marB="9144">
+                    <a:solidFill>
+                      <a:srgbClr val="0E39A9"/>
+                    </a:solidFill>
+                  </a:tcPr>
+                </a:tc>
+                <a:tc>
+                  <a:txBody>
+                    <a:bodyPr/>
+                    <a:lstStyle/>
+                    <a:p>
+                      <a:pPr algn="ctr">
+                        <a:lnSpc>
+                          <a:spcPct val="100000"/>
+                        </a:lnSpc>
+                        <a:spcBef>
+                          <a:spcPts val="0"/>
+                        </a:spcBef>
+                        <a:spcAft>
+                          <a:spcPts val="0"/>
+                        </a:spcAft>
+                      </a:pPr>
+                      <a:r>
+                        <a:rPr sz="819" b="1">
+                          <a:solidFill>
+                            <a:srgbClr val="FFFFFF"/>
+                          </a:solidFill>
+                          <a:latin typeface="Montserrat"/>
+                        </a:rPr>
+                        <a:t>Result</a:t>
+                      </a:r>
+                    </a:p>
+                  </a:txBody>
+                  <a:tcPr marL="32004" marR="32004" marT="9144" marB="9144">
+                    <a:solidFill>
+                      <a:srgbClr val="0E39A9"/>
+                    </a:solidFill>
+                  </a:tcPr>
+                </a:tc>
+              </a:tr>
+              <a:tr h="309233">
+                <a:tc>
+                  <a:txBody>
+                    <a:bodyPr/>
+                    <a:lstStyle/>
+                    <a:p>
+                      <a:pPr algn="ctr">
+                        <a:lnSpc>
+                          <a:spcPct val="100000"/>
+                        </a:lnSpc>
+                        <a:spcBef>
+                          <a:spcPts val="0"/>
+                        </a:spcBef>
+                        <a:spcAft>
+                          <a:spcPts val="0"/>
+                        </a:spcAft>
+                      </a:pPr>
+                      <a:r>
+                        <a:rPr sz="840" b="0">
+                          <a:solidFill>
+                            <a:srgbClr val="000000"/>
+                          </a:solidFill>
+                          <a:latin typeface="Montserrat"/>
+                        </a:rPr>
+                        <a:t>01</a:t>
+                      </a:r>
+                    </a:p>
+                  </a:txBody>
+                  <a:tcPr marL="32004" marR="32004" marT="9144" marB="9144">
+                    <a:solidFill>
+                      <a:srgbClr val="FFFFFF"/>
+                    </a:solidFill>
+                  </a:tcPr>
+                </a:tc>
+                <a:tc>
+                  <a:txBody>
+                    <a:bodyPr/>
+                    <a:lstStyle/>
+                    <a:p>
+                      <a:pPr algn="l">
+                        <a:lnSpc>
+                          <a:spcPct val="100000"/>
+                        </a:lnSpc>
+                        <a:spcBef>
+                          <a:spcPts val="0"/>
+                        </a:spcBef>
+                        <a:spcAft>
+                          <a:spcPts val="0"/>
+                        </a:spcAft>
+                      </a:pPr>
+                      <a:r>
+                        <a:rPr sz="840" b="0">
+                          <a:solidFill>
+                            <a:srgbClr val="000000"/>
+                          </a:solidFill>
+                          <a:latin typeface="Montserrat"/>
+                        </a:rPr>
+                        <a:t>OTA cancellation/refund</a:t>
+                      </a:r>
+                    </a:p>
+                  </a:txBody>
+                  <a:tcPr marL="32004" marR="32004" marT="9144" marB="9144">
+                    <a:solidFill>
+                      <a:srgbClr val="FFFFFF"/>
+                    </a:solidFill>
+                  </a:tcPr>
+                </a:tc>
+                <a:tc>
+                  <a:txBody>
+                    <a:bodyPr/>
+                    <a:lstStyle/>
+                    <a:p>
+                      <a:pPr algn="ctr">
+                        <a:lnSpc>
+                          <a:spcPct val="100000"/>
+                        </a:lnSpc>
+                        <a:spcBef>
+                          <a:spcPts val="0"/>
+                        </a:spcBef>
+                        <a:spcAft>
+                          <a:spcPts val="0"/>
+                        </a:spcAft>
+                      </a:pPr>
+                      <a:r>
+                        <a:rPr sz="840" b="0">
+                          <a:solidFill>
+                            <a:srgbClr val="000000"/>
+                          </a:solidFill>
+                          <a:latin typeface="Montserrat"/>
+                        </a:rPr>
+                        <a:t>.991</a:t>
+                      </a:r>
+                    </a:p>
+                  </a:txBody>
+                  <a:tcPr marL="32004" marR="32004" marT="9144" marB="9144">
+                    <a:solidFill>
+                      <a:srgbClr val="FFFFFF"/>
+                    </a:solidFill>
+                  </a:tcPr>
+                </a:tc>
+                <a:tc>
+                  <a:txBody>
+                    <a:bodyPr/>
+                    <a:lstStyle/>
+                    <a:p>
+                      <a:pPr algn="ctr">
+                        <a:lnSpc>
+                          <a:spcPct val="100000"/>
+                        </a:lnSpc>
+                        <a:spcBef>
+                          <a:spcPts val="0"/>
+                        </a:spcBef>
+                        <a:spcAft>
+                          <a:spcPts val="0"/>
+                        </a:spcAft>
+                      </a:pPr>
+                      <a:r>
+                        <a:rPr sz="840" b="0">
+                          <a:solidFill>
+                            <a:srgbClr val="000000"/>
+                          </a:solidFill>
+                          <a:latin typeface="Montserrat"/>
+                        </a:rPr>
+                        <a:t>.946</a:t>
+                      </a:r>
+                    </a:p>
+                  </a:txBody>
+                  <a:tcPr marL="32004" marR="32004" marT="9144" marB="9144">
+                    <a:solidFill>
+                      <a:srgbClr val="FFFFFF"/>
+                    </a:solidFill>
+                  </a:tcPr>
+                </a:tc>
+                <a:tc>
+                  <a:txBody>
+                    <a:bodyPr/>
+                    <a:lstStyle/>
+                    <a:p>
+                      <a:pPr algn="ctr">
+                        <a:lnSpc>
+                          <a:spcPct val="100000"/>
+                        </a:lnSpc>
+                        <a:spcBef>
+                          <a:spcPts val="0"/>
+                        </a:spcBef>
+                        <a:spcAft>
+                          <a:spcPts val="0"/>
+                        </a:spcAft>
+                      </a:pPr>
+                      <a:r>
+                        <a:rPr sz="840" b="0">
+                          <a:solidFill>
+                            <a:srgbClr val="000000"/>
+                          </a:solidFill>
+                          <a:latin typeface="Montserrat"/>
+                        </a:rPr>
+                        <a:t>.826</a:t>
+                      </a:r>
+                    </a:p>
+                  </a:txBody>
+                  <a:tcPr marL="32004" marR="32004" marT="9144" marB="9144">
+                    <a:solidFill>
+                      <a:srgbClr val="FFFFFF"/>
+                    </a:solidFill>
+                  </a:tcPr>
+                </a:tc>
+                <a:tc>
+                  <a:txBody>
+                    <a:bodyPr/>
+                    <a:lstStyle/>
+                    <a:p>
+                      <a:pPr algn="ctr">
+                        <a:lnSpc>
+                          <a:spcPct val="100000"/>
+                        </a:lnSpc>
+                        <a:spcBef>
+                          <a:spcPts val="0"/>
+                        </a:spcBef>
+                        <a:spcAft>
+                          <a:spcPts val="0"/>
+                        </a:spcAft>
+                      </a:pPr>
+                      <a:r>
+                        <a:rPr sz="840" b="0">
+                          <a:solidFill>
+                            <a:srgbClr val="000000"/>
+                          </a:solidFill>
+                          <a:latin typeface="Montserrat"/>
+                        </a:rPr>
+                        <a:t>.977</a:t>
+                      </a:r>
+                    </a:p>
+                  </a:txBody>
+                  <a:tcPr marL="32004" marR="32004" marT="9144" marB="9144">
+                    <a:solidFill>
+                      <a:srgbClr val="FFFFFF"/>
+                    </a:solidFill>
+                  </a:tcPr>
+                </a:tc>
+                <a:tc>
+                  <a:txBody>
+                    <a:bodyPr/>
+                    <a:lstStyle/>
+                    <a:p>
+                      <a:pPr algn="ctr">
+                        <a:lnSpc>
+                          <a:spcPct val="100000"/>
+                        </a:lnSpc>
+                        <a:spcBef>
+                          <a:spcPts val="0"/>
+                        </a:spcBef>
+                        <a:spcAft>
+                          <a:spcPts val="0"/>
+                        </a:spcAft>
+                      </a:pPr>
+                      <a:r>
+                        <a:rPr sz="840" b="0">
+                          <a:solidFill>
+                            <a:srgbClr val="000000"/>
+                          </a:solidFill>
+                          <a:latin typeface="Montserrat"/>
+                        </a:rPr>
+                        <a:t>.944</a:t>
+                      </a:r>
+                    </a:p>
+                  </a:txBody>
+                  <a:tcPr marL="32004" marR="32004" marT="9144" marB="9144">
+                    <a:solidFill>
+                      <a:srgbClr val="FFFFFF"/>
+                    </a:solidFill>
+                  </a:tcPr>
+                </a:tc>
+                <a:tc>
+                  <a:txBody>
+                    <a:bodyPr/>
+                    <a:lstStyle/>
+                    <a:p>
+                      <a:pPr algn="ctr">
+                        <a:lnSpc>
+                          <a:spcPct val="100000"/>
+                        </a:lnSpc>
+                        <a:spcBef>
+                          <a:spcPts val="0"/>
+                        </a:spcBef>
+                        <a:spcAft>
+                          <a:spcPts val="0"/>
+                        </a:spcAft>
+                      </a:pPr>
+                      <a:r>
+                        <a:rPr sz="840" b="1">
+                          <a:solidFill>
+                            <a:srgbClr val="1F7752"/>
+                          </a:solidFill>
+                          <a:latin typeface="Montserrat"/>
+                        </a:rPr>
+                        <a:t>PASS</a:t>
+                      </a:r>
+                    </a:p>
+                  </a:txBody>
+                  <a:tcPr marL="32004" marR="32004" marT="9144" marB="9144">
+                    <a:solidFill>
+                      <a:srgbClr val="FFFFFF"/>
+                    </a:solidFill>
+                  </a:tcPr>
+                </a:tc>
+              </a:tr>
+              <a:tr h="309233">
+                <a:tc>
+                  <a:txBody>
+                    <a:bodyPr/>
+                    <a:lstStyle/>
+                    <a:p>
+                      <a:pPr algn="ctr">
+                        <a:lnSpc>
+                          <a:spcPct val="100000"/>
+                        </a:lnSpc>
+                        <a:spcBef>
+                          <a:spcPts val="0"/>
+                        </a:spcBef>
+                        <a:spcAft>
+                          <a:spcPts val="0"/>
+                        </a:spcAft>
+                      </a:pPr>
+                      <a:r>
+                        <a:rPr sz="840" b="0">
+                          <a:solidFill>
+                            <a:srgbClr val="000000"/>
+                          </a:solidFill>
+                          <a:latin typeface="Montserrat"/>
+                        </a:rPr>
+                        <a:t>02</a:t>
+                      </a:r>
+                    </a:p>
+                  </a:txBody>
+                  <a:tcPr marL="32004" marR="32004" marT="9144" marB="9144">
+                    <a:solidFill>
+                      <a:srgbClr val="F2F6FF"/>
+                    </a:solidFill>
+                  </a:tcPr>
+                </a:tc>
+                <a:tc>
+                  <a:txBody>
+                    <a:bodyPr/>
+                    <a:lstStyle/>
+                    <a:p>
+                      <a:pPr algn="l">
+                        <a:lnSpc>
+                          <a:spcPct val="100000"/>
+                        </a:lnSpc>
+                        <a:spcBef>
+                          <a:spcPts val="0"/>
+                        </a:spcBef>
+                        <a:spcAft>
+                          <a:spcPts val="0"/>
+                        </a:spcAft>
+                      </a:pPr>
+                      <a:r>
+                        <a:rPr sz="840" b="0">
+                          <a:solidFill>
+                            <a:srgbClr val="000000"/>
+                          </a:solidFill>
+                          <a:latin typeface="Montserrat"/>
+                        </a:rPr>
+                        <a:t>Member discount/cancellation</a:t>
+                      </a:r>
+                    </a:p>
+                  </a:txBody>
+                  <a:tcPr marL="32004" marR="32004" marT="9144" marB="9144">
+                    <a:solidFill>
+                      <a:srgbClr val="F2F6FF"/>
+                    </a:solidFill>
+                  </a:tcPr>
+                </a:tc>
+                <a:tc>
+                  <a:txBody>
+                    <a:bodyPr/>
+                    <a:lstStyle/>
+                    <a:p>
+                      <a:pPr algn="ctr">
+                        <a:lnSpc>
+                          <a:spcPct val="100000"/>
+                        </a:lnSpc>
+                        <a:spcBef>
+                          <a:spcPts val="0"/>
+                        </a:spcBef>
+                        <a:spcAft>
+                          <a:spcPts val="0"/>
+                        </a:spcAft>
+                      </a:pPr>
+                      <a:r>
+                        <a:rPr sz="840" b="0">
+                          <a:solidFill>
+                            <a:srgbClr val="000000"/>
+                          </a:solidFill>
+                          <a:latin typeface="Montserrat"/>
+                        </a:rPr>
+                        <a:t>1.000</a:t>
+                      </a:r>
+                    </a:p>
+                  </a:txBody>
+                  <a:tcPr marL="32004" marR="32004" marT="9144" marB="9144">
+                    <a:solidFill>
+                      <a:srgbClr val="F2F6FF"/>
+                    </a:solidFill>
+                  </a:tcPr>
+                </a:tc>
+                <a:tc>
+                  <a:txBody>
+                    <a:bodyPr/>
+                    <a:lstStyle/>
+                    <a:p>
+                      <a:pPr algn="ctr">
+                        <a:lnSpc>
+                          <a:spcPct val="100000"/>
+                        </a:lnSpc>
+                        <a:spcBef>
+                          <a:spcPts val="0"/>
+                        </a:spcBef>
+                        <a:spcAft>
+                          <a:spcPts val="0"/>
+                        </a:spcAft>
+                      </a:pPr>
+                      <a:r>
+                        <a:rPr sz="840" b="0">
+                          <a:solidFill>
+                            <a:srgbClr val="000000"/>
+                          </a:solidFill>
+                          <a:latin typeface="Montserrat"/>
+                        </a:rPr>
+                        <a:t>.995</a:t>
+                      </a:r>
+                    </a:p>
+                  </a:txBody>
+                  <a:tcPr marL="32004" marR="32004" marT="9144" marB="9144">
+                    <a:solidFill>
+                      <a:srgbClr val="F2F6FF"/>
+                    </a:solidFill>
+                  </a:tcPr>
+                </a:tc>
+                <a:tc>
+                  <a:txBody>
+                    <a:bodyPr/>
+                    <a:lstStyle/>
+                    <a:p>
+                      <a:pPr algn="ctr">
+                        <a:lnSpc>
+                          <a:spcPct val="100000"/>
+                        </a:lnSpc>
+                        <a:spcBef>
+                          <a:spcPts val="0"/>
+                        </a:spcBef>
+                        <a:spcAft>
+                          <a:spcPts val="0"/>
+                        </a:spcAft>
+                      </a:pPr>
+                      <a:r>
+                        <a:rPr sz="840" b="0">
+                          <a:solidFill>
+                            <a:srgbClr val="000000"/>
+                          </a:solidFill>
+                          <a:latin typeface="Montserrat"/>
+                        </a:rPr>
+                        <a:t>.814</a:t>
+                      </a:r>
+                    </a:p>
+                  </a:txBody>
+                  <a:tcPr marL="32004" marR="32004" marT="9144" marB="9144">
+                    <a:solidFill>
+                      <a:srgbClr val="F2F6FF"/>
+                    </a:solidFill>
+                  </a:tcPr>
+                </a:tc>
+                <a:tc>
+                  <a:txBody>
+                    <a:bodyPr/>
+                    <a:lstStyle/>
+                    <a:p>
+                      <a:pPr algn="ctr">
+                        <a:lnSpc>
+                          <a:spcPct val="100000"/>
+                        </a:lnSpc>
+                        <a:spcBef>
+                          <a:spcPts val="0"/>
+                        </a:spcBef>
+                        <a:spcAft>
+                          <a:spcPts val="0"/>
+                        </a:spcAft>
+                      </a:pPr>
+                      <a:r>
+                        <a:rPr sz="840" b="0">
+                          <a:solidFill>
+                            <a:srgbClr val="000000"/>
+                          </a:solidFill>
+                          <a:latin typeface="Montserrat"/>
+                        </a:rPr>
+                        <a:t>.971</a:t>
+                      </a:r>
+                    </a:p>
+                  </a:txBody>
+                  <a:tcPr marL="32004" marR="32004" marT="9144" marB="9144">
+                    <a:solidFill>
+                      <a:srgbClr val="F2F6FF"/>
+                    </a:solidFill>
+                  </a:tcPr>
+                </a:tc>
+                <a:tc>
+                  <a:txBody>
+                    <a:bodyPr/>
+                    <a:lstStyle/>
+                    <a:p>
+                      <a:pPr algn="ctr">
+                        <a:lnSpc>
+                          <a:spcPct val="100000"/>
+                        </a:lnSpc>
+                        <a:spcBef>
+                          <a:spcPts val="0"/>
+                        </a:spcBef>
+                        <a:spcAft>
+                          <a:spcPts val="0"/>
+                        </a:spcAft>
+                      </a:pPr>
+                      <a:r>
+                        <a:rPr sz="840" b="0">
+                          <a:solidFill>
+                            <a:srgbClr val="000000"/>
+                          </a:solidFill>
+                          <a:latin typeface="Montserrat"/>
+                        </a:rPr>
+                        <a:t>.956</a:t>
+                      </a:r>
+                    </a:p>
+                  </a:txBody>
+                  <a:tcPr marL="32004" marR="32004" marT="9144" marB="9144">
+                    <a:solidFill>
+                      <a:srgbClr val="F2F6FF"/>
+                    </a:solidFill>
+                  </a:tcPr>
+                </a:tc>
+                <a:tc>
+                  <a:txBody>
+                    <a:bodyPr/>
+                    <a:lstStyle/>
+                    <a:p>
+                      <a:pPr algn="ctr">
+                        <a:lnSpc>
+                          <a:spcPct val="100000"/>
+                        </a:lnSpc>
+                        <a:spcBef>
+                          <a:spcPts val="0"/>
+                        </a:spcBef>
+                        <a:spcAft>
+                          <a:spcPts val="0"/>
+                        </a:spcAft>
+                      </a:pPr>
+                      <a:r>
+                        <a:rPr sz="840" b="1">
+                          <a:solidFill>
+                            <a:srgbClr val="1F7752"/>
+                          </a:solidFill>
+                          <a:latin typeface="Montserrat"/>
+                        </a:rPr>
+                        <a:t>PASS</a:t>
+                      </a:r>
+                    </a:p>
+                  </a:txBody>
+                  <a:tcPr marL="32004" marR="32004" marT="9144" marB="9144">
+                    <a:solidFill>
+                      <a:srgbClr val="F2F6FF"/>
+                    </a:solidFill>
+                  </a:tcPr>
+                </a:tc>
+              </a:tr>
+              <a:tr h="309233">
+                <a:tc>
+                  <a:txBody>
+                    <a:bodyPr/>
+                    <a:lstStyle/>
+                    <a:p>
+                      <a:pPr algn="ctr">
+                        <a:lnSpc>
+                          <a:spcPct val="100000"/>
+                        </a:lnSpc>
+                        <a:spcBef>
+                          <a:spcPts val="0"/>
+                        </a:spcBef>
+                        <a:spcAft>
+                          <a:spcPts val="0"/>
+                        </a:spcAft>
+                      </a:pPr>
+                      <a:r>
+                        <a:rPr sz="840" b="0">
+                          <a:solidFill>
+                            <a:srgbClr val="000000"/>
+                          </a:solidFill>
+                          <a:latin typeface="Montserrat"/>
+                        </a:rPr>
+                        <a:t>03</a:t>
+                      </a:r>
+                    </a:p>
+                  </a:txBody>
+                  <a:tcPr marL="32004" marR="32004" marT="9144" marB="9144">
+                    <a:solidFill>
+                      <a:srgbClr val="FFFFFF"/>
+                    </a:solidFill>
+                  </a:tcPr>
+                </a:tc>
+                <a:tc>
+                  <a:txBody>
+                    <a:bodyPr/>
+                    <a:lstStyle/>
+                    <a:p>
+                      <a:pPr algn="l">
+                        <a:lnSpc>
+                          <a:spcPct val="100000"/>
+                        </a:lnSpc>
+                        <a:spcBef>
+                          <a:spcPts val="0"/>
+                        </a:spcBef>
+                        <a:spcAft>
+                          <a:spcPts val="0"/>
+                        </a:spcAft>
+                      </a:pPr>
+                      <a:r>
+                        <a:rPr sz="840" b="0">
+                          <a:solidFill>
+                            <a:srgbClr val="000000"/>
+                          </a:solidFill>
+                          <a:latin typeface="Montserrat"/>
+                        </a:rPr>
+                        <a:t>Double Queen occupancy</a:t>
+                      </a:r>
+                    </a:p>
+                  </a:txBody>
+                  <a:tcPr marL="32004" marR="32004" marT="9144" marB="9144">
+                    <a:solidFill>
+                      <a:srgbClr val="FFFFFF"/>
+                    </a:solidFill>
+                  </a:tcPr>
+                </a:tc>
+                <a:tc>
+                  <a:txBody>
+                    <a:bodyPr/>
+                    <a:lstStyle/>
+                    <a:p>
+                      <a:pPr algn="ctr">
+                        <a:lnSpc>
+                          <a:spcPct val="100000"/>
+                        </a:lnSpc>
+                        <a:spcBef>
+                          <a:spcPts val="0"/>
+                        </a:spcBef>
+                        <a:spcAft>
+                          <a:spcPts val="0"/>
+                        </a:spcAft>
+                      </a:pPr>
+                      <a:r>
+                        <a:rPr sz="840" b="0">
+                          <a:solidFill>
+                            <a:srgbClr val="000000"/>
+                          </a:solidFill>
+                          <a:latin typeface="Montserrat"/>
+                        </a:rPr>
+                        <a:t>1.000</a:t>
+                      </a:r>
+                    </a:p>
+                  </a:txBody>
+                  <a:tcPr marL="32004" marR="32004" marT="9144" marB="9144">
+                    <a:solidFill>
+                      <a:srgbClr val="FFFFFF"/>
+                    </a:solidFill>
+                  </a:tcPr>
+                </a:tc>
+                <a:tc>
+                  <a:txBody>
+                    <a:bodyPr/>
+                    <a:lstStyle/>
+                    <a:p>
+                      <a:pPr algn="ctr">
+                        <a:lnSpc>
+                          <a:spcPct val="100000"/>
+                        </a:lnSpc>
+                        <a:spcBef>
+                          <a:spcPts val="0"/>
+                        </a:spcBef>
+                        <a:spcAft>
+                          <a:spcPts val="0"/>
+                        </a:spcAft>
+                      </a:pPr>
+                      <a:r>
+                        <a:rPr sz="840" b="0">
+                          <a:solidFill>
+                            <a:srgbClr val="000000"/>
+                          </a:solidFill>
+                          <a:latin typeface="Montserrat"/>
+                        </a:rPr>
+                        <a:t>.994</a:t>
+                      </a:r>
+                    </a:p>
+                  </a:txBody>
+                  <a:tcPr marL="32004" marR="32004" marT="9144" marB="9144">
+                    <a:solidFill>
+                      <a:srgbClr val="FFFFFF"/>
+                    </a:solidFill>
+                  </a:tcPr>
+                </a:tc>
+                <a:tc>
+                  <a:txBody>
+                    <a:bodyPr/>
+                    <a:lstStyle/>
+                    <a:p>
+                      <a:pPr algn="ctr">
+                        <a:lnSpc>
+                          <a:spcPct val="100000"/>
+                        </a:lnSpc>
+                        <a:spcBef>
+                          <a:spcPts val="0"/>
+                        </a:spcBef>
+                        <a:spcAft>
+                          <a:spcPts val="0"/>
+                        </a:spcAft>
+                      </a:pPr>
+                      <a:r>
+                        <a:rPr sz="840" b="0">
+                          <a:solidFill>
+                            <a:srgbClr val="000000"/>
+                          </a:solidFill>
+                          <a:latin typeface="Montserrat"/>
+                        </a:rPr>
+                        <a:t>.958</a:t>
+                      </a:r>
+                    </a:p>
+                  </a:txBody>
+                  <a:tcPr marL="32004" marR="32004" marT="9144" marB="9144">
+                    <a:solidFill>
+                      <a:srgbClr val="FFFFFF"/>
+                    </a:solidFill>
+                  </a:tcPr>
+                </a:tc>
+                <a:tc>
+                  <a:txBody>
+                    <a:bodyPr/>
+                    <a:lstStyle/>
+                    <a:p>
+                      <a:pPr algn="ctr">
+                        <a:lnSpc>
+                          <a:spcPct val="100000"/>
+                        </a:lnSpc>
+                        <a:spcBef>
+                          <a:spcPts val="0"/>
+                        </a:spcBef>
+                        <a:spcAft>
+                          <a:spcPts val="0"/>
+                        </a:spcAft>
+                      </a:pPr>
+                      <a:r>
+                        <a:rPr sz="840" b="0">
+                          <a:solidFill>
+                            <a:srgbClr val="000000"/>
+                          </a:solidFill>
+                          <a:latin typeface="Montserrat"/>
+                        </a:rPr>
+                        <a:t>.990</a:t>
+                      </a:r>
+                    </a:p>
+                  </a:txBody>
+                  <a:tcPr marL="32004" marR="32004" marT="9144" marB="9144">
+                    <a:solidFill>
+                      <a:srgbClr val="FFFFFF"/>
+                    </a:solidFill>
+                  </a:tcPr>
+                </a:tc>
+                <a:tc>
+                  <a:txBody>
+                    <a:bodyPr/>
+                    <a:lstStyle/>
+                    <a:p>
+                      <a:pPr algn="ctr">
+                        <a:lnSpc>
+                          <a:spcPct val="100000"/>
+                        </a:lnSpc>
+                        <a:spcBef>
+                          <a:spcPts val="0"/>
+                        </a:spcBef>
+                        <a:spcAft>
+                          <a:spcPts val="0"/>
+                        </a:spcAft>
+                      </a:pPr>
+                      <a:r>
+                        <a:rPr sz="840" b="0">
+                          <a:solidFill>
+                            <a:srgbClr val="000000"/>
+                          </a:solidFill>
+                          <a:latin typeface="Montserrat"/>
+                        </a:rPr>
+                        <a:t>.988</a:t>
+                      </a:r>
+                    </a:p>
+                  </a:txBody>
+                  <a:tcPr marL="32004" marR="32004" marT="9144" marB="9144">
+                    <a:solidFill>
+                      <a:srgbClr val="FFFFFF"/>
+                    </a:solidFill>
+                  </a:tcPr>
+                </a:tc>
+                <a:tc>
+                  <a:txBody>
+                    <a:bodyPr/>
+                    <a:lstStyle/>
+                    <a:p>
+                      <a:pPr algn="ctr">
+                        <a:lnSpc>
+                          <a:spcPct val="100000"/>
+                        </a:lnSpc>
+                        <a:spcBef>
+                          <a:spcPts val="0"/>
+                        </a:spcBef>
+                        <a:spcAft>
+                          <a:spcPts val="0"/>
+                        </a:spcAft>
+                      </a:pPr>
+                      <a:r>
+                        <a:rPr sz="840" b="1">
+                          <a:solidFill>
+                            <a:srgbClr val="1F7752"/>
+                          </a:solidFill>
+                          <a:latin typeface="Montserrat"/>
+                        </a:rPr>
+                        <a:t>PASS</a:t>
+                      </a:r>
+                    </a:p>
+                  </a:txBody>
+                  <a:tcPr marL="32004" marR="32004" marT="9144" marB="9144">
+                    <a:solidFill>
+                      <a:srgbClr val="FFFFFF"/>
+                    </a:solidFill>
+                  </a:tcPr>
+                </a:tc>
+              </a:tr>
+              <a:tr h="309233">
+                <a:tc>
+                  <a:txBody>
+                    <a:bodyPr/>
+                    <a:lstStyle/>
+                    <a:p>
+                      <a:pPr algn="ctr">
+                        <a:lnSpc>
+                          <a:spcPct val="100000"/>
+                        </a:lnSpc>
+                        <a:spcBef>
+                          <a:spcPts val="0"/>
+                        </a:spcBef>
+                        <a:spcAft>
+                          <a:spcPts val="0"/>
+                        </a:spcAft>
+                      </a:pPr>
+                      <a:r>
+                        <a:rPr sz="840" b="0">
+                          <a:solidFill>
+                            <a:srgbClr val="000000"/>
+                          </a:solidFill>
+                          <a:latin typeface="Montserrat"/>
+                        </a:rPr>
+                        <a:t>04</a:t>
+                      </a:r>
+                    </a:p>
+                  </a:txBody>
+                  <a:tcPr marL="32004" marR="32004" marT="9144" marB="9144">
+                    <a:solidFill>
+                      <a:srgbClr val="FFEBEB"/>
+                    </a:solidFill>
+                  </a:tcPr>
+                </a:tc>
+                <a:tc>
+                  <a:txBody>
+                    <a:bodyPr/>
+                    <a:lstStyle/>
+                    <a:p>
+                      <a:pPr algn="l">
+                        <a:lnSpc>
+                          <a:spcPct val="100000"/>
+                        </a:lnSpc>
+                        <a:spcBef>
+                          <a:spcPts val="0"/>
+                        </a:spcBef>
+                        <a:spcAft>
+                          <a:spcPts val="0"/>
+                        </a:spcAft>
+                      </a:pPr>
+                      <a:r>
+                        <a:rPr sz="840" b="0">
+                          <a:solidFill>
+                            <a:srgbClr val="000000"/>
+                          </a:solidFill>
+                          <a:latin typeface="Montserrat"/>
+                        </a:rPr>
+                        <a:t>Accessible King inclusions</a:t>
+                      </a:r>
+                    </a:p>
+                  </a:txBody>
+                  <a:tcPr marL="32004" marR="32004" marT="9144" marB="9144">
+                    <a:solidFill>
+                      <a:srgbClr val="FFEBEB"/>
+                    </a:solidFill>
+                  </a:tcPr>
+                </a:tc>
+                <a:tc>
+                  <a:txBody>
+                    <a:bodyPr/>
+                    <a:lstStyle/>
+                    <a:p>
+                      <a:pPr algn="ctr">
+                        <a:lnSpc>
+                          <a:spcPct val="100000"/>
+                        </a:lnSpc>
+                        <a:spcBef>
+                          <a:spcPts val="0"/>
+                        </a:spcBef>
+                        <a:spcAft>
+                          <a:spcPts val="0"/>
+                        </a:spcAft>
+                      </a:pPr>
+                      <a:r>
+                        <a:rPr sz="840" b="0">
+                          <a:solidFill>
+                            <a:srgbClr val="000000"/>
+                          </a:solidFill>
+                          <a:latin typeface="Montserrat"/>
+                        </a:rPr>
+                        <a:t>.989</a:t>
+                      </a:r>
+                    </a:p>
+                  </a:txBody>
+                  <a:tcPr marL="32004" marR="32004" marT="9144" marB="9144">
+                    <a:solidFill>
+                      <a:srgbClr val="FFEBEB"/>
+                    </a:solidFill>
+                  </a:tcPr>
+                </a:tc>
+                <a:tc>
+                  <a:txBody>
+                    <a:bodyPr/>
+                    <a:lstStyle/>
+                    <a:p>
+                      <a:pPr algn="ctr">
+                        <a:lnSpc>
+                          <a:spcPct val="100000"/>
+                        </a:lnSpc>
+                        <a:spcBef>
+                          <a:spcPts val="0"/>
+                        </a:spcBef>
+                        <a:spcAft>
+                          <a:spcPts val="0"/>
+                        </a:spcAft>
+                      </a:pPr>
+                      <a:r>
+                        <a:rPr sz="840" b="0">
+                          <a:solidFill>
+                            <a:srgbClr val="000000"/>
+                          </a:solidFill>
+                          <a:latin typeface="Montserrat"/>
+                        </a:rPr>
+                        <a:t>.913</a:t>
+                      </a:r>
+                    </a:p>
+                  </a:txBody>
+                  <a:tcPr marL="32004" marR="32004" marT="9144" marB="9144">
+                    <a:solidFill>
+                      <a:srgbClr val="FFEBEB"/>
+                    </a:solidFill>
+                  </a:tcPr>
+                </a:tc>
+                <a:tc>
+                  <a:txBody>
+                    <a:bodyPr/>
+                    <a:lstStyle/>
+                    <a:p>
+                      <a:pPr algn="ctr">
+                        <a:lnSpc>
+                          <a:spcPct val="100000"/>
+                        </a:lnSpc>
+                        <a:spcBef>
+                          <a:spcPts val="0"/>
+                        </a:spcBef>
+                        <a:spcAft>
+                          <a:spcPts val="0"/>
+                        </a:spcAft>
+                      </a:pPr>
+                      <a:r>
+                        <a:rPr sz="840" b="0">
+                          <a:solidFill>
+                            <a:srgbClr val="000000"/>
+                          </a:solidFill>
+                          <a:latin typeface="Montserrat"/>
+                        </a:rPr>
+                        <a:t>.451</a:t>
+                      </a:r>
+                    </a:p>
+                  </a:txBody>
+                  <a:tcPr marL="32004" marR="32004" marT="9144" marB="9144">
+                    <a:solidFill>
+                      <a:srgbClr val="FFEBEB"/>
+                    </a:solidFill>
+                  </a:tcPr>
+                </a:tc>
+                <a:tc>
+                  <a:txBody>
+                    <a:bodyPr/>
+                    <a:lstStyle/>
+                    <a:p>
+                      <a:pPr algn="ctr">
+                        <a:lnSpc>
+                          <a:spcPct val="100000"/>
+                        </a:lnSpc>
+                        <a:spcBef>
+                          <a:spcPts val="0"/>
+                        </a:spcBef>
+                        <a:spcAft>
+                          <a:spcPts val="0"/>
+                        </a:spcAft>
+                      </a:pPr>
+                      <a:r>
+                        <a:rPr sz="840" b="0">
+                          <a:solidFill>
+                            <a:srgbClr val="000000"/>
+                          </a:solidFill>
+                          <a:latin typeface="Montserrat"/>
+                        </a:rPr>
+                        <a:t>.801</a:t>
+                      </a:r>
+                    </a:p>
+                  </a:txBody>
+                  <a:tcPr marL="32004" marR="32004" marT="9144" marB="9144">
+                    <a:solidFill>
+                      <a:srgbClr val="FFEBEB"/>
+                    </a:solidFill>
+                  </a:tcPr>
+                </a:tc>
+                <a:tc>
+                  <a:txBody>
+                    <a:bodyPr/>
+                    <a:lstStyle/>
+                    <a:p>
+                      <a:pPr algn="ctr">
+                        <a:lnSpc>
+                          <a:spcPct val="100000"/>
+                        </a:lnSpc>
+                        <a:spcBef>
+                          <a:spcPts val="0"/>
+                        </a:spcBef>
+                        <a:spcAft>
+                          <a:spcPts val="0"/>
+                        </a:spcAft>
+                      </a:pPr>
+                      <a:r>
+                        <a:rPr sz="840" b="0">
+                          <a:solidFill>
+                            <a:srgbClr val="000000"/>
+                          </a:solidFill>
+                          <a:latin typeface="Montserrat"/>
+                        </a:rPr>
+                        <a:t>.825</a:t>
+                      </a:r>
+                    </a:p>
+                  </a:txBody>
+                  <a:tcPr marL="32004" marR="32004" marT="9144" marB="9144">
+                    <a:solidFill>
+                      <a:srgbClr val="FFEBEB"/>
+                    </a:solidFill>
+                  </a:tcPr>
+                </a:tc>
+                <a:tc>
+                  <a:txBody>
+                    <a:bodyPr/>
+                    <a:lstStyle/>
+                    <a:p>
+                      <a:pPr algn="ctr">
+                        <a:lnSpc>
+                          <a:spcPct val="100000"/>
+                        </a:lnSpc>
+                        <a:spcBef>
+                          <a:spcPts val="0"/>
+                        </a:spcBef>
+                        <a:spcAft>
+                          <a:spcPts val="0"/>
+                        </a:spcAft>
+                      </a:pPr>
+                      <a:r>
+                        <a:rPr sz="840" b="1">
+                          <a:solidFill>
+                            <a:srgbClr val="A62A2A"/>
+                          </a:solidFill>
+                          <a:latin typeface="Montserrat"/>
+                        </a:rPr>
+                        <a:t>FAIL</a:t>
+                      </a:r>
+                    </a:p>
+                  </a:txBody>
+                  <a:tcPr marL="32004" marR="32004" marT="9144" marB="9144">
+                    <a:solidFill>
+                      <a:srgbClr val="FFEBEB"/>
+                    </a:solidFill>
+                  </a:tcPr>
+                </a:tc>
+              </a:tr>
+              <a:tr h="309233">
+                <a:tc>
+                  <a:txBody>
+                    <a:bodyPr/>
+                    <a:lstStyle/>
+                    <a:p>
+                      <a:pPr algn="ctr">
+                        <a:lnSpc>
+                          <a:spcPct val="100000"/>
+                        </a:lnSpc>
+                        <a:spcBef>
+                          <a:spcPts val="0"/>
+                        </a:spcBef>
+                        <a:spcAft>
+                          <a:spcPts val="0"/>
+                        </a:spcAft>
+                      </a:pPr>
+                      <a:r>
+                        <a:rPr sz="840" b="0">
+                          <a:solidFill>
+                            <a:srgbClr val="000000"/>
+                          </a:solidFill>
+                          <a:latin typeface="Montserrat"/>
+                        </a:rPr>
+                        <a:t>05</a:t>
+                      </a:r>
+                    </a:p>
+                  </a:txBody>
+                  <a:tcPr marL="32004" marR="32004" marT="9144" marB="9144">
+                    <a:solidFill>
+                      <a:srgbClr val="FFFFFF"/>
+                    </a:solidFill>
+                  </a:tcPr>
+                </a:tc>
+                <a:tc>
+                  <a:txBody>
+                    <a:bodyPr/>
+                    <a:lstStyle/>
+                    <a:p>
+                      <a:pPr algn="l">
+                        <a:lnSpc>
+                          <a:spcPct val="100000"/>
+                        </a:lnSpc>
+                        <a:spcBef>
+                          <a:spcPts val="0"/>
+                        </a:spcBef>
+                        <a:spcAft>
+                          <a:spcPts val="0"/>
+                        </a:spcAft>
+                      </a:pPr>
+                      <a:r>
+                        <a:rPr sz="840" b="0">
+                          <a:solidFill>
+                            <a:srgbClr val="000000"/>
+                          </a:solidFill>
+                          <a:latin typeface="Montserrat"/>
+                        </a:rPr>
+                        <a:t>Atlanta/Miami parking</a:t>
+                      </a:r>
+                    </a:p>
+                  </a:txBody>
+                  <a:tcPr marL="32004" marR="32004" marT="9144" marB="9144">
+                    <a:solidFill>
+                      <a:srgbClr val="FFFFFF"/>
+                    </a:solidFill>
+                  </a:tcPr>
+                </a:tc>
+                <a:tc>
+                  <a:txBody>
+                    <a:bodyPr/>
+                    <a:lstStyle/>
+                    <a:p>
+                      <a:pPr algn="ctr">
+                        <a:lnSpc>
+                          <a:spcPct val="100000"/>
+                        </a:lnSpc>
+                        <a:spcBef>
+                          <a:spcPts val="0"/>
+                        </a:spcBef>
+                        <a:spcAft>
+                          <a:spcPts val="0"/>
+                        </a:spcAft>
+                      </a:pPr>
+                      <a:r>
+                        <a:rPr sz="840" b="0">
+                          <a:solidFill>
+                            <a:srgbClr val="000000"/>
+                          </a:solidFill>
+                          <a:latin typeface="Montserrat"/>
+                        </a:rPr>
+                        <a:t>1.000</a:t>
+                      </a:r>
+                    </a:p>
+                  </a:txBody>
+                  <a:tcPr marL="32004" marR="32004" marT="9144" marB="9144">
+                    <a:solidFill>
+                      <a:srgbClr val="FFFFFF"/>
+                    </a:solidFill>
+                  </a:tcPr>
+                </a:tc>
+                <a:tc>
+                  <a:txBody>
+                    <a:bodyPr/>
+                    <a:lstStyle/>
+                    <a:p>
+                      <a:pPr algn="ctr">
+                        <a:lnSpc>
+                          <a:spcPct val="100000"/>
+                        </a:lnSpc>
+                        <a:spcBef>
+                          <a:spcPts val="0"/>
+                        </a:spcBef>
+                        <a:spcAft>
+                          <a:spcPts val="0"/>
+                        </a:spcAft>
+                      </a:pPr>
+                      <a:r>
+                        <a:rPr sz="840" b="0">
+                          <a:solidFill>
+                            <a:srgbClr val="000000"/>
+                          </a:solidFill>
+                          <a:latin typeface="Montserrat"/>
+                        </a:rPr>
+                        <a:t>1.000</a:t>
+                      </a:r>
+                    </a:p>
+                  </a:txBody>
+                  <a:tcPr marL="32004" marR="32004" marT="9144" marB="9144">
+                    <a:solidFill>
+                      <a:srgbClr val="FFFFFF"/>
+                    </a:solidFill>
+                  </a:tcPr>
+                </a:tc>
+                <a:tc>
+                  <a:txBody>
+                    <a:bodyPr/>
+                    <a:lstStyle/>
+                    <a:p>
+                      <a:pPr algn="ctr">
+                        <a:lnSpc>
+                          <a:spcPct val="100000"/>
+                        </a:lnSpc>
+                        <a:spcBef>
+                          <a:spcPts val="0"/>
+                        </a:spcBef>
+                        <a:spcAft>
+                          <a:spcPts val="0"/>
+                        </a:spcAft>
+                      </a:pPr>
+                      <a:r>
+                        <a:rPr sz="840" b="0">
+                          <a:solidFill>
+                            <a:srgbClr val="000000"/>
+                          </a:solidFill>
+                          <a:latin typeface="Montserrat"/>
+                        </a:rPr>
+                        <a:t>.893</a:t>
+                      </a:r>
+                    </a:p>
+                  </a:txBody>
+                  <a:tcPr marL="32004" marR="32004" marT="9144" marB="9144">
+                    <a:solidFill>
+                      <a:srgbClr val="FFFFFF"/>
+                    </a:solidFill>
+                  </a:tcPr>
+                </a:tc>
+                <a:tc>
+                  <a:txBody>
+                    <a:bodyPr/>
+                    <a:lstStyle/>
+                    <a:p>
+                      <a:pPr algn="ctr">
+                        <a:lnSpc>
+                          <a:spcPct val="100000"/>
+                        </a:lnSpc>
+                        <a:spcBef>
+                          <a:spcPts val="0"/>
+                        </a:spcBef>
+                        <a:spcAft>
+                          <a:spcPts val="0"/>
+                        </a:spcAft>
+                      </a:pPr>
+                      <a:r>
+                        <a:rPr sz="840" b="0">
+                          <a:solidFill>
+                            <a:srgbClr val="000000"/>
+                          </a:solidFill>
+                          <a:latin typeface="Montserrat"/>
+                        </a:rPr>
+                        <a:t>.982</a:t>
+                      </a:r>
+                    </a:p>
+                  </a:txBody>
+                  <a:tcPr marL="32004" marR="32004" marT="9144" marB="9144">
+                    <a:solidFill>
+                      <a:srgbClr val="FFFFFF"/>
+                    </a:solidFill>
+                  </a:tcPr>
+                </a:tc>
+                <a:tc>
+                  <a:txBody>
+                    <a:bodyPr/>
+                    <a:lstStyle/>
+                    <a:p>
+                      <a:pPr algn="ctr">
+                        <a:lnSpc>
+                          <a:spcPct val="100000"/>
+                        </a:lnSpc>
+                        <a:spcBef>
+                          <a:spcPts val="0"/>
+                        </a:spcBef>
+                        <a:spcAft>
+                          <a:spcPts val="0"/>
+                        </a:spcAft>
+                      </a:pPr>
+                      <a:r>
+                        <a:rPr sz="840" b="0">
+                          <a:solidFill>
+                            <a:srgbClr val="000000"/>
+                          </a:solidFill>
+                          <a:latin typeface="Montserrat"/>
+                        </a:rPr>
+                        <a:t>.975</a:t>
+                      </a:r>
+                    </a:p>
+                  </a:txBody>
+                  <a:tcPr marL="32004" marR="32004" marT="9144" marB="9144">
+                    <a:solidFill>
+                      <a:srgbClr val="FFFFFF"/>
+                    </a:solidFill>
+                  </a:tcPr>
+                </a:tc>
+                <a:tc>
+                  <a:txBody>
+                    <a:bodyPr/>
+                    <a:lstStyle/>
+                    <a:p>
+                      <a:pPr algn="ctr">
+                        <a:lnSpc>
+                          <a:spcPct val="100000"/>
+                        </a:lnSpc>
+                        <a:spcBef>
+                          <a:spcPts val="0"/>
+                        </a:spcBef>
+                        <a:spcAft>
+                          <a:spcPts val="0"/>
+                        </a:spcAft>
+                      </a:pPr>
+                      <a:r>
+                        <a:rPr sz="840" b="1">
+                          <a:solidFill>
+                            <a:srgbClr val="1F7752"/>
+                          </a:solidFill>
+                          <a:latin typeface="Montserrat"/>
+                        </a:rPr>
+                        <a:t>PASS</a:t>
+                      </a:r>
+                    </a:p>
+                  </a:txBody>
+                  <a:tcPr marL="32004" marR="32004" marT="9144" marB="9144">
+                    <a:solidFill>
+                      <a:srgbClr val="FFFFFF"/>
+                    </a:solidFill>
+                  </a:tcPr>
+                </a:tc>
+              </a:tr>
+              <a:tr h="309233">
+                <a:tc>
+                  <a:txBody>
+                    <a:bodyPr/>
+                    <a:lstStyle/>
+                    <a:p>
+                      <a:pPr algn="ctr">
+                        <a:lnSpc>
+                          <a:spcPct val="100000"/>
+                        </a:lnSpc>
+                        <a:spcBef>
+                          <a:spcPts val="0"/>
+                        </a:spcBef>
+                        <a:spcAft>
+                          <a:spcPts val="0"/>
+                        </a:spcAft>
+                      </a:pPr>
+                      <a:r>
+                        <a:rPr sz="840" b="0">
+                          <a:solidFill>
+                            <a:srgbClr val="000000"/>
+                          </a:solidFill>
+                          <a:latin typeface="Montserrat"/>
+                        </a:rPr>
+                        <a:t>06</a:t>
+                      </a:r>
+                    </a:p>
+                  </a:txBody>
+                  <a:tcPr marL="32004" marR="32004" marT="9144" marB="9144">
+                    <a:solidFill>
+                      <a:srgbClr val="F2F6FF"/>
+                    </a:solidFill>
+                  </a:tcPr>
+                </a:tc>
+                <a:tc>
+                  <a:txBody>
+                    <a:bodyPr/>
+                    <a:lstStyle/>
+                    <a:p>
+                      <a:pPr algn="l">
+                        <a:lnSpc>
+                          <a:spcPct val="100000"/>
+                        </a:lnSpc>
+                        <a:spcBef>
+                          <a:spcPts val="0"/>
+                        </a:spcBef>
+                        <a:spcAft>
+                          <a:spcPts val="0"/>
+                        </a:spcAft>
+                      </a:pPr>
+                      <a:r>
+                        <a:rPr sz="840" b="0">
+                          <a:solidFill>
+                            <a:srgbClr val="000000"/>
+                          </a:solidFill>
+                          <a:latin typeface="Montserrat"/>
+                        </a:rPr>
+                        <a:t>Miami breakfast</a:t>
+                      </a:r>
+                    </a:p>
+                  </a:txBody>
+                  <a:tcPr marL="32004" marR="32004" marT="9144" marB="9144">
+                    <a:solidFill>
+                      <a:srgbClr val="F2F6FF"/>
+                    </a:solidFill>
+                  </a:tcPr>
+                </a:tc>
+                <a:tc>
+                  <a:txBody>
+                    <a:bodyPr/>
+                    <a:lstStyle/>
+                    <a:p>
+                      <a:pPr algn="ctr">
+                        <a:lnSpc>
+                          <a:spcPct val="100000"/>
+                        </a:lnSpc>
+                        <a:spcBef>
+                          <a:spcPts val="0"/>
+                        </a:spcBef>
+                        <a:spcAft>
+                          <a:spcPts val="0"/>
+                        </a:spcAft>
+                      </a:pPr>
+                      <a:r>
+                        <a:rPr sz="840" b="0">
+                          <a:solidFill>
+                            <a:srgbClr val="000000"/>
+                          </a:solidFill>
+                          <a:latin typeface="Montserrat"/>
+                        </a:rPr>
+                        <a:t>1.000</a:t>
+                      </a:r>
+                    </a:p>
+                  </a:txBody>
+                  <a:tcPr marL="32004" marR="32004" marT="9144" marB="9144">
+                    <a:solidFill>
+                      <a:srgbClr val="F2F6FF"/>
+                    </a:solidFill>
+                  </a:tcPr>
+                </a:tc>
+                <a:tc>
+                  <a:txBody>
+                    <a:bodyPr/>
+                    <a:lstStyle/>
+                    <a:p>
+                      <a:pPr algn="ctr">
+                        <a:lnSpc>
+                          <a:spcPct val="100000"/>
+                        </a:lnSpc>
+                        <a:spcBef>
+                          <a:spcPts val="0"/>
+                        </a:spcBef>
+                        <a:spcAft>
+                          <a:spcPts val="0"/>
+                        </a:spcAft>
+                      </a:pPr>
+                      <a:r>
+                        <a:rPr sz="840" b="0">
+                          <a:solidFill>
+                            <a:srgbClr val="000000"/>
+                          </a:solidFill>
+                          <a:latin typeface="Montserrat"/>
+                        </a:rPr>
+                        <a:t>.994</a:t>
+                      </a:r>
+                    </a:p>
+                  </a:txBody>
+                  <a:tcPr marL="32004" marR="32004" marT="9144" marB="9144">
+                    <a:solidFill>
+                      <a:srgbClr val="F2F6FF"/>
+                    </a:solidFill>
+                  </a:tcPr>
+                </a:tc>
+                <a:tc>
+                  <a:txBody>
+                    <a:bodyPr/>
+                    <a:lstStyle/>
+                    <a:p>
+                      <a:pPr algn="ctr">
+                        <a:lnSpc>
+                          <a:spcPct val="100000"/>
+                        </a:lnSpc>
+                        <a:spcBef>
+                          <a:spcPts val="0"/>
+                        </a:spcBef>
+                        <a:spcAft>
+                          <a:spcPts val="0"/>
+                        </a:spcAft>
+                      </a:pPr>
+                      <a:r>
+                        <a:rPr sz="840" b="0">
+                          <a:solidFill>
+                            <a:srgbClr val="000000"/>
+                          </a:solidFill>
+                          <a:latin typeface="Montserrat"/>
+                        </a:rPr>
+                        <a:t>.828</a:t>
+                      </a:r>
+                    </a:p>
+                  </a:txBody>
+                  <a:tcPr marL="32004" marR="32004" marT="9144" marB="9144">
+                    <a:solidFill>
+                      <a:srgbClr val="F2F6FF"/>
+                    </a:solidFill>
+                  </a:tcPr>
+                </a:tc>
+                <a:tc>
+                  <a:txBody>
+                    <a:bodyPr/>
+                    <a:lstStyle/>
+                    <a:p>
+                      <a:pPr algn="ctr">
+                        <a:lnSpc>
+                          <a:spcPct val="100000"/>
+                        </a:lnSpc>
+                        <a:spcBef>
+                          <a:spcPts val="0"/>
+                        </a:spcBef>
+                        <a:spcAft>
+                          <a:spcPts val="0"/>
+                        </a:spcAft>
+                      </a:pPr>
+                      <a:r>
+                        <a:rPr sz="840" b="0">
+                          <a:solidFill>
+                            <a:srgbClr val="000000"/>
+                          </a:solidFill>
+                          <a:latin typeface="Montserrat"/>
+                        </a:rPr>
+                        <a:t>.994</a:t>
+                      </a:r>
+                    </a:p>
+                  </a:txBody>
+                  <a:tcPr marL="32004" marR="32004" marT="9144" marB="9144">
+                    <a:solidFill>
+                      <a:srgbClr val="F2F6FF"/>
+                    </a:solidFill>
+                  </a:tcPr>
+                </a:tc>
+                <a:tc>
+                  <a:txBody>
+                    <a:bodyPr/>
+                    <a:lstStyle/>
+                    <a:p>
+                      <a:pPr algn="ctr">
+                        <a:lnSpc>
+                          <a:spcPct val="100000"/>
+                        </a:lnSpc>
+                        <a:spcBef>
+                          <a:spcPts val="0"/>
+                        </a:spcBef>
+                        <a:spcAft>
+                          <a:spcPts val="0"/>
+                        </a:spcAft>
+                      </a:pPr>
+                      <a:r>
+                        <a:rPr sz="840" b="0">
+                          <a:solidFill>
+                            <a:srgbClr val="000000"/>
+                          </a:solidFill>
+                          <a:latin typeface="Montserrat"/>
+                        </a:rPr>
+                        <a:t>.963</a:t>
+                      </a:r>
+                    </a:p>
+                  </a:txBody>
+                  <a:tcPr marL="32004" marR="32004" marT="9144" marB="9144">
+                    <a:solidFill>
+                      <a:srgbClr val="F2F6FF"/>
+                    </a:solidFill>
+                  </a:tcPr>
+                </a:tc>
+                <a:tc>
+                  <a:txBody>
+                    <a:bodyPr/>
+                    <a:lstStyle/>
+                    <a:p>
+                      <a:pPr algn="ctr">
+                        <a:lnSpc>
+                          <a:spcPct val="100000"/>
+                        </a:lnSpc>
+                        <a:spcBef>
+                          <a:spcPts val="0"/>
+                        </a:spcBef>
+                        <a:spcAft>
+                          <a:spcPts val="0"/>
+                        </a:spcAft>
+                      </a:pPr>
+                      <a:r>
+                        <a:rPr sz="840" b="1">
+                          <a:solidFill>
+                            <a:srgbClr val="1F7752"/>
+                          </a:solidFill>
+                          <a:latin typeface="Montserrat"/>
+                        </a:rPr>
+                        <a:t>PASS</a:t>
+                      </a:r>
+                    </a:p>
+                  </a:txBody>
+                  <a:tcPr marL="32004" marR="32004" marT="9144" marB="9144">
+                    <a:solidFill>
+                      <a:srgbClr val="F2F6FF"/>
+                    </a:solidFill>
+                  </a:tcPr>
+                </a:tc>
+              </a:tr>
+              <a:tr h="309233">
+                <a:tc>
+                  <a:txBody>
+                    <a:bodyPr/>
+                    <a:lstStyle/>
+                    <a:p>
+                      <a:pPr algn="ctr">
+                        <a:lnSpc>
+                          <a:spcPct val="100000"/>
+                        </a:lnSpc>
+                        <a:spcBef>
+                          <a:spcPts val="0"/>
+                        </a:spcBef>
+                        <a:spcAft>
+                          <a:spcPts val="0"/>
+                        </a:spcAft>
+                      </a:pPr>
+                      <a:r>
+                        <a:rPr sz="840" b="0">
+                          <a:solidFill>
+                            <a:srgbClr val="000000"/>
+                          </a:solidFill>
+                          <a:latin typeface="Montserrat"/>
+                        </a:rPr>
+                        <a:t>07</a:t>
+                      </a:r>
+                    </a:p>
+                  </a:txBody>
+                  <a:tcPr marL="32004" marR="32004" marT="9144" marB="9144">
+                    <a:solidFill>
+                      <a:srgbClr val="FFFFFF"/>
+                    </a:solidFill>
+                  </a:tcPr>
+                </a:tc>
+                <a:tc>
+                  <a:txBody>
+                    <a:bodyPr/>
+                    <a:lstStyle/>
+                    <a:p>
+                      <a:pPr algn="l">
+                        <a:lnSpc>
+                          <a:spcPct val="100000"/>
+                        </a:lnSpc>
+                        <a:spcBef>
+                          <a:spcPts val="0"/>
+                        </a:spcBef>
+                        <a:spcAft>
+                          <a:spcPts val="0"/>
+                        </a:spcAft>
+                      </a:pPr>
+                      <a:r>
+                        <a:rPr sz="840" b="0">
+                          <a:solidFill>
+                            <a:srgbClr val="000000"/>
+                          </a:solidFill>
+                          <a:latin typeface="Montserrat"/>
+                        </a:rPr>
+                        <a:t>Advance Purchase change</a:t>
+                      </a:r>
+                    </a:p>
+                  </a:txBody>
+                  <a:tcPr marL="32004" marR="32004" marT="9144" marB="9144">
+                    <a:solidFill>
+                      <a:srgbClr val="FFFFFF"/>
+                    </a:solidFill>
+                  </a:tcPr>
+                </a:tc>
+                <a:tc>
+                  <a:txBody>
+                    <a:bodyPr/>
+                    <a:lstStyle/>
+                    <a:p>
+                      <a:pPr algn="ctr">
+                        <a:lnSpc>
+                          <a:spcPct val="100000"/>
+                        </a:lnSpc>
+                        <a:spcBef>
+                          <a:spcPts val="0"/>
+                        </a:spcBef>
+                        <a:spcAft>
+                          <a:spcPts val="0"/>
+                        </a:spcAft>
+                      </a:pPr>
+                      <a:r>
+                        <a:rPr sz="840" b="0">
+                          <a:solidFill>
+                            <a:srgbClr val="000000"/>
+                          </a:solidFill>
+                          <a:latin typeface="Montserrat"/>
+                        </a:rPr>
+                        <a:t>.956</a:t>
+                      </a:r>
+                    </a:p>
+                  </a:txBody>
+                  <a:tcPr marL="32004" marR="32004" marT="9144" marB="9144">
+                    <a:solidFill>
+                      <a:srgbClr val="FFFFFF"/>
+                    </a:solidFill>
+                  </a:tcPr>
+                </a:tc>
+                <a:tc>
+                  <a:txBody>
+                    <a:bodyPr/>
+                    <a:lstStyle/>
+                    <a:p>
+                      <a:pPr algn="ctr">
+                        <a:lnSpc>
+                          <a:spcPct val="100000"/>
+                        </a:lnSpc>
+                        <a:spcBef>
+                          <a:spcPts val="0"/>
+                        </a:spcBef>
+                        <a:spcAft>
+                          <a:spcPts val="0"/>
+                        </a:spcAft>
+                      </a:pPr>
+                      <a:r>
+                        <a:rPr sz="840" b="0">
+                          <a:solidFill>
+                            <a:srgbClr val="000000"/>
+                          </a:solidFill>
+                          <a:latin typeface="Montserrat"/>
+                        </a:rPr>
+                        <a:t>.962</a:t>
+                      </a:r>
+                    </a:p>
+                  </a:txBody>
+                  <a:tcPr marL="32004" marR="32004" marT="9144" marB="9144">
+                    <a:solidFill>
+                      <a:srgbClr val="FFFFFF"/>
+                    </a:solidFill>
+                  </a:tcPr>
+                </a:tc>
+                <a:tc>
+                  <a:txBody>
+                    <a:bodyPr/>
+                    <a:lstStyle/>
+                    <a:p>
+                      <a:pPr algn="ctr">
+                        <a:lnSpc>
+                          <a:spcPct val="100000"/>
+                        </a:lnSpc>
+                        <a:spcBef>
+                          <a:spcPts val="0"/>
+                        </a:spcBef>
+                        <a:spcAft>
+                          <a:spcPts val="0"/>
+                        </a:spcAft>
+                      </a:pPr>
+                      <a:r>
+                        <a:rPr sz="840" b="0">
+                          <a:solidFill>
+                            <a:srgbClr val="000000"/>
+                          </a:solidFill>
+                          <a:latin typeface="Montserrat"/>
+                        </a:rPr>
+                        <a:t>.809</a:t>
+                      </a:r>
+                    </a:p>
+                  </a:txBody>
+                  <a:tcPr marL="32004" marR="32004" marT="9144" marB="9144">
+                    <a:solidFill>
+                      <a:srgbClr val="FFFFFF"/>
+                    </a:solidFill>
+                  </a:tcPr>
+                </a:tc>
+                <a:tc>
+                  <a:txBody>
+                    <a:bodyPr/>
+                    <a:lstStyle/>
+                    <a:p>
+                      <a:pPr algn="ctr">
+                        <a:lnSpc>
+                          <a:spcPct val="100000"/>
+                        </a:lnSpc>
+                        <a:spcBef>
+                          <a:spcPts val="0"/>
+                        </a:spcBef>
+                        <a:spcAft>
+                          <a:spcPts val="0"/>
+                        </a:spcAft>
+                      </a:pPr>
+                      <a:r>
+                        <a:rPr sz="840" b="0">
+                          <a:solidFill>
+                            <a:srgbClr val="000000"/>
+                          </a:solidFill>
+                          <a:latin typeface="Montserrat"/>
+                        </a:rPr>
+                        <a:t>.896</a:t>
+                      </a:r>
+                    </a:p>
+                  </a:txBody>
+                  <a:tcPr marL="32004" marR="32004" marT="9144" marB="9144">
+                    <a:solidFill>
+                      <a:srgbClr val="FFFFFF"/>
+                    </a:solidFill>
+                  </a:tcPr>
+                </a:tc>
+                <a:tc>
+                  <a:txBody>
+                    <a:bodyPr/>
+                    <a:lstStyle/>
+                    <a:p>
+                      <a:pPr algn="ctr">
+                        <a:lnSpc>
+                          <a:spcPct val="100000"/>
+                        </a:lnSpc>
+                        <a:spcBef>
+                          <a:spcPts val="0"/>
+                        </a:spcBef>
+                        <a:spcAft>
+                          <a:spcPts val="0"/>
+                        </a:spcAft>
+                      </a:pPr>
+                      <a:r>
+                        <a:rPr sz="840" b="0">
+                          <a:solidFill>
+                            <a:srgbClr val="000000"/>
+                          </a:solidFill>
+                          <a:latin typeface="Montserrat"/>
+                        </a:rPr>
+                        <a:t>.916</a:t>
+                      </a:r>
+                    </a:p>
+                  </a:txBody>
+                  <a:tcPr marL="32004" marR="32004" marT="9144" marB="9144">
+                    <a:solidFill>
+                      <a:srgbClr val="FFFFFF"/>
+                    </a:solidFill>
+                  </a:tcPr>
+                </a:tc>
+                <a:tc>
+                  <a:txBody>
+                    <a:bodyPr/>
+                    <a:lstStyle/>
+                    <a:p>
+                      <a:pPr algn="ctr">
+                        <a:lnSpc>
+                          <a:spcPct val="100000"/>
+                        </a:lnSpc>
+                        <a:spcBef>
+                          <a:spcPts val="0"/>
+                        </a:spcBef>
+                        <a:spcAft>
+                          <a:spcPts val="0"/>
+                        </a:spcAft>
+                      </a:pPr>
+                      <a:r>
+                        <a:rPr sz="840" b="1">
+                          <a:solidFill>
+                            <a:srgbClr val="1F7752"/>
+                          </a:solidFill>
+                          <a:latin typeface="Montserrat"/>
+                        </a:rPr>
+                        <a:t>PASS</a:t>
+                      </a:r>
+                    </a:p>
+                  </a:txBody>
+                  <a:tcPr marL="32004" marR="32004" marT="9144" marB="9144">
+                    <a:solidFill>
+                      <a:srgbClr val="FFFFFF"/>
+                    </a:solidFill>
+                  </a:tcPr>
+                </a:tc>
+              </a:tr>
+              <a:tr h="309233">
+                <a:tc>
+                  <a:txBody>
+                    <a:bodyPr/>
+                    <a:lstStyle/>
+                    <a:p>
+                      <a:pPr algn="ctr">
+                        <a:lnSpc>
+                          <a:spcPct val="100000"/>
+                        </a:lnSpc>
+                        <a:spcBef>
+                          <a:spcPts val="0"/>
+                        </a:spcBef>
+                        <a:spcAft>
+                          <a:spcPts val="0"/>
+                        </a:spcAft>
+                      </a:pPr>
+                      <a:r>
+                        <a:rPr sz="840" b="0">
+                          <a:solidFill>
+                            <a:srgbClr val="000000"/>
+                          </a:solidFill>
+                          <a:latin typeface="Montserrat"/>
+                        </a:rPr>
+                        <a:t>08</a:t>
+                      </a:r>
+                    </a:p>
+                  </a:txBody>
+                  <a:tcPr marL="32004" marR="32004" marT="9144" marB="9144">
+                    <a:solidFill>
+                      <a:srgbClr val="F2F6FF"/>
+                    </a:solidFill>
+                  </a:tcPr>
+                </a:tc>
+                <a:tc>
+                  <a:txBody>
+                    <a:bodyPr/>
+                    <a:lstStyle/>
+                    <a:p>
+                      <a:pPr algn="l">
+                        <a:lnSpc>
+                          <a:spcPct val="100000"/>
+                        </a:lnSpc>
+                        <a:spcBef>
+                          <a:spcPts val="0"/>
+                        </a:spcBef>
+                        <a:spcAft>
+                          <a:spcPts val="0"/>
+                        </a:spcAft>
+                      </a:pPr>
+                      <a:r>
+                        <a:rPr sz="840" b="0">
+                          <a:solidFill>
+                            <a:srgbClr val="000000"/>
+                          </a:solidFill>
+                          <a:latin typeface="Montserrat"/>
+                        </a:rPr>
+                        <a:t>Denver late checkout</a:t>
+                      </a:r>
+                    </a:p>
+                  </a:txBody>
+                  <a:tcPr marL="32004" marR="32004" marT="9144" marB="9144">
+                    <a:solidFill>
+                      <a:srgbClr val="F2F6FF"/>
+                    </a:solidFill>
+                  </a:tcPr>
+                </a:tc>
+                <a:tc>
+                  <a:txBody>
+                    <a:bodyPr/>
+                    <a:lstStyle/>
+                    <a:p>
+                      <a:pPr algn="ctr">
+                        <a:lnSpc>
+                          <a:spcPct val="100000"/>
+                        </a:lnSpc>
+                        <a:spcBef>
+                          <a:spcPts val="0"/>
+                        </a:spcBef>
+                        <a:spcAft>
+                          <a:spcPts val="0"/>
+                        </a:spcAft>
+                      </a:pPr>
+                      <a:r>
+                        <a:rPr sz="840" b="0">
+                          <a:solidFill>
+                            <a:srgbClr val="000000"/>
+                          </a:solidFill>
+                          <a:latin typeface="Montserrat"/>
+                        </a:rPr>
+                        <a:t>.998</a:t>
+                      </a:r>
+                    </a:p>
+                  </a:txBody>
+                  <a:tcPr marL="32004" marR="32004" marT="9144" marB="9144">
+                    <a:solidFill>
+                      <a:srgbClr val="F2F6FF"/>
+                    </a:solidFill>
+                  </a:tcPr>
+                </a:tc>
+                <a:tc>
+                  <a:txBody>
+                    <a:bodyPr/>
+                    <a:lstStyle/>
+                    <a:p>
+                      <a:pPr algn="ctr">
+                        <a:lnSpc>
+                          <a:spcPct val="100000"/>
+                        </a:lnSpc>
+                        <a:spcBef>
+                          <a:spcPts val="0"/>
+                        </a:spcBef>
+                        <a:spcAft>
+                          <a:spcPts val="0"/>
+                        </a:spcAft>
+                      </a:pPr>
+                      <a:r>
+                        <a:rPr sz="840" b="0">
+                          <a:solidFill>
+                            <a:srgbClr val="000000"/>
+                          </a:solidFill>
+                          <a:latin typeface="Montserrat"/>
+                        </a:rPr>
+                        <a:t>.986</a:t>
+                      </a:r>
+                    </a:p>
+                  </a:txBody>
+                  <a:tcPr marL="32004" marR="32004" marT="9144" marB="9144">
+                    <a:solidFill>
+                      <a:srgbClr val="F2F6FF"/>
+                    </a:solidFill>
+                  </a:tcPr>
+                </a:tc>
+                <a:tc>
+                  <a:txBody>
+                    <a:bodyPr/>
+                    <a:lstStyle/>
+                    <a:p>
+                      <a:pPr algn="ctr">
+                        <a:lnSpc>
+                          <a:spcPct val="100000"/>
+                        </a:lnSpc>
+                        <a:spcBef>
+                          <a:spcPts val="0"/>
+                        </a:spcBef>
+                        <a:spcAft>
+                          <a:spcPts val="0"/>
+                        </a:spcAft>
+                      </a:pPr>
+                      <a:r>
+                        <a:rPr sz="840" b="0">
+                          <a:solidFill>
+                            <a:srgbClr val="000000"/>
+                          </a:solidFill>
+                          <a:latin typeface="Montserrat"/>
+                        </a:rPr>
+                        <a:t>.834</a:t>
+                      </a:r>
+                    </a:p>
+                  </a:txBody>
+                  <a:tcPr marL="32004" marR="32004" marT="9144" marB="9144">
+                    <a:solidFill>
+                      <a:srgbClr val="F2F6FF"/>
+                    </a:solidFill>
+                  </a:tcPr>
+                </a:tc>
+                <a:tc>
+                  <a:txBody>
+                    <a:bodyPr/>
+                    <a:lstStyle/>
+                    <a:p>
+                      <a:pPr algn="ctr">
+                        <a:lnSpc>
+                          <a:spcPct val="100000"/>
+                        </a:lnSpc>
+                        <a:spcBef>
+                          <a:spcPts val="0"/>
+                        </a:spcBef>
+                        <a:spcAft>
+                          <a:spcPts val="0"/>
+                        </a:spcAft>
+                      </a:pPr>
+                      <a:r>
+                        <a:rPr sz="840" b="0">
+                          <a:solidFill>
+                            <a:srgbClr val="000000"/>
+                          </a:solidFill>
+                          <a:latin typeface="Montserrat"/>
+                        </a:rPr>
+                        <a:t>.884</a:t>
+                      </a:r>
+                    </a:p>
+                  </a:txBody>
+                  <a:tcPr marL="32004" marR="32004" marT="9144" marB="9144">
+                    <a:solidFill>
+                      <a:srgbClr val="F2F6FF"/>
+                    </a:solidFill>
+                  </a:tcPr>
+                </a:tc>
+                <a:tc>
+                  <a:txBody>
+                    <a:bodyPr/>
+                    <a:lstStyle/>
+                    <a:p>
+                      <a:pPr algn="ctr">
+                        <a:lnSpc>
+                          <a:spcPct val="100000"/>
+                        </a:lnSpc>
+                        <a:spcBef>
+                          <a:spcPts val="0"/>
+                        </a:spcBef>
+                        <a:spcAft>
+                          <a:spcPts val="0"/>
+                        </a:spcAft>
+                      </a:pPr>
+                      <a:r>
+                        <a:rPr sz="840" b="0">
+                          <a:solidFill>
+                            <a:srgbClr val="000000"/>
+                          </a:solidFill>
+                          <a:latin typeface="Montserrat"/>
+                        </a:rPr>
+                        <a:t>.939</a:t>
+                      </a:r>
+                    </a:p>
+                  </a:txBody>
+                  <a:tcPr marL="32004" marR="32004" marT="9144" marB="9144">
+                    <a:solidFill>
+                      <a:srgbClr val="F2F6FF"/>
+                    </a:solidFill>
+                  </a:tcPr>
+                </a:tc>
+                <a:tc>
+                  <a:txBody>
+                    <a:bodyPr/>
+                    <a:lstStyle/>
+                    <a:p>
+                      <a:pPr algn="ctr">
+                        <a:lnSpc>
+                          <a:spcPct val="100000"/>
+                        </a:lnSpc>
+                        <a:spcBef>
+                          <a:spcPts val="0"/>
+                        </a:spcBef>
+                        <a:spcAft>
+                          <a:spcPts val="0"/>
+                        </a:spcAft>
+                      </a:pPr>
+                      <a:r>
+                        <a:rPr sz="840" b="1">
+                          <a:solidFill>
+                            <a:srgbClr val="1F7752"/>
+                          </a:solidFill>
+                          <a:latin typeface="Montserrat"/>
+                        </a:rPr>
+                        <a:t>PASS</a:t>
+                      </a:r>
+                    </a:p>
+                  </a:txBody>
+                  <a:tcPr marL="32004" marR="32004" marT="9144" marB="9144">
+                    <a:solidFill>
+                      <a:srgbClr val="F2F6FF"/>
+                    </a:solidFill>
+                  </a:tcPr>
+                </a:tc>
+              </a:tr>
+              <a:tr h="309233">
+                <a:tc>
+                  <a:txBody>
+                    <a:bodyPr/>
+                    <a:lstStyle/>
+                    <a:p>
+                      <a:pPr algn="ctr">
+                        <a:lnSpc>
+                          <a:spcPct val="100000"/>
+                        </a:lnSpc>
+                        <a:spcBef>
+                          <a:spcPts val="0"/>
+                        </a:spcBef>
+                        <a:spcAft>
+                          <a:spcPts val="0"/>
+                        </a:spcAft>
+                      </a:pPr>
+                      <a:r>
+                        <a:rPr sz="840" b="0">
+                          <a:solidFill>
+                            <a:srgbClr val="000000"/>
+                          </a:solidFill>
+                          <a:latin typeface="Montserrat"/>
+                        </a:rPr>
+                        <a:t>09</a:t>
+                      </a:r>
+                    </a:p>
+                  </a:txBody>
+                  <a:tcPr marL="32004" marR="32004" marT="9144" marB="9144">
+                    <a:solidFill>
+                      <a:srgbClr val="FFFFFF"/>
+                    </a:solidFill>
+                  </a:tcPr>
+                </a:tc>
+                <a:tc>
+                  <a:txBody>
+                    <a:bodyPr/>
+                    <a:lstStyle/>
+                    <a:p>
+                      <a:pPr algn="l">
+                        <a:lnSpc>
+                          <a:spcPct val="100000"/>
+                        </a:lnSpc>
+                        <a:spcBef>
+                          <a:spcPts val="0"/>
+                        </a:spcBef>
+                        <a:spcAft>
+                          <a:spcPts val="0"/>
+                        </a:spcAft>
+                      </a:pPr>
+                      <a:r>
+                        <a:rPr sz="840" b="0">
+                          <a:solidFill>
+                            <a:srgbClr val="000000"/>
+                          </a:solidFill>
+                          <a:latin typeface="Montserrat"/>
+                        </a:rPr>
+                        <a:t>ASH-CHI pet fee</a:t>
+                      </a:r>
+                    </a:p>
+                  </a:txBody>
+                  <a:tcPr marL="32004" marR="32004" marT="9144" marB="9144">
+                    <a:solidFill>
+                      <a:srgbClr val="FFFFFF"/>
+                    </a:solidFill>
+                  </a:tcPr>
+                </a:tc>
+                <a:tc>
+                  <a:txBody>
+                    <a:bodyPr/>
+                    <a:lstStyle/>
+                    <a:p>
+                      <a:pPr algn="ctr">
+                        <a:lnSpc>
+                          <a:spcPct val="100000"/>
+                        </a:lnSpc>
+                        <a:spcBef>
+                          <a:spcPts val="0"/>
+                        </a:spcBef>
+                        <a:spcAft>
+                          <a:spcPts val="0"/>
+                        </a:spcAft>
+                      </a:pPr>
+                      <a:r>
+                        <a:rPr sz="840" b="0">
+                          <a:solidFill>
+                            <a:srgbClr val="000000"/>
+                          </a:solidFill>
+                          <a:latin typeface="Montserrat"/>
+                        </a:rPr>
+                        <a:t>1.000</a:t>
+                      </a:r>
+                    </a:p>
+                  </a:txBody>
+                  <a:tcPr marL="32004" marR="32004" marT="9144" marB="9144">
+                    <a:solidFill>
+                      <a:srgbClr val="FFFFFF"/>
+                    </a:solidFill>
+                  </a:tcPr>
+                </a:tc>
+                <a:tc>
+                  <a:txBody>
+                    <a:bodyPr/>
+                    <a:lstStyle/>
+                    <a:p>
+                      <a:pPr algn="ctr">
+                        <a:lnSpc>
+                          <a:spcPct val="100000"/>
+                        </a:lnSpc>
+                        <a:spcBef>
+                          <a:spcPts val="0"/>
+                        </a:spcBef>
+                        <a:spcAft>
+                          <a:spcPts val="0"/>
+                        </a:spcAft>
+                      </a:pPr>
+                      <a:r>
+                        <a:rPr sz="840" b="0">
+                          <a:solidFill>
+                            <a:srgbClr val="000000"/>
+                          </a:solidFill>
+                          <a:latin typeface="Montserrat"/>
+                        </a:rPr>
+                        <a:t>.986</a:t>
+                      </a:r>
+                    </a:p>
+                  </a:txBody>
+                  <a:tcPr marL="32004" marR="32004" marT="9144" marB="9144">
+                    <a:solidFill>
+                      <a:srgbClr val="FFFFFF"/>
+                    </a:solidFill>
+                  </a:tcPr>
+                </a:tc>
+                <a:tc>
+                  <a:txBody>
+                    <a:bodyPr/>
+                    <a:lstStyle/>
+                    <a:p>
+                      <a:pPr algn="ctr">
+                        <a:lnSpc>
+                          <a:spcPct val="100000"/>
+                        </a:lnSpc>
+                        <a:spcBef>
+                          <a:spcPts val="0"/>
+                        </a:spcBef>
+                        <a:spcAft>
+                          <a:spcPts val="0"/>
+                        </a:spcAft>
+                      </a:pPr>
+                      <a:r>
+                        <a:rPr sz="840" b="0">
+                          <a:solidFill>
+                            <a:srgbClr val="000000"/>
+                          </a:solidFill>
+                          <a:latin typeface="Montserrat"/>
+                        </a:rPr>
+                        <a:t>.888</a:t>
+                      </a:r>
+                    </a:p>
+                  </a:txBody>
+                  <a:tcPr marL="32004" marR="32004" marT="9144" marB="9144">
+                    <a:solidFill>
+                      <a:srgbClr val="FFFFFF"/>
+                    </a:solidFill>
+                  </a:tcPr>
+                </a:tc>
+                <a:tc>
+                  <a:txBody>
+                    <a:bodyPr/>
+                    <a:lstStyle/>
+                    <a:p>
+                      <a:pPr algn="ctr">
+                        <a:lnSpc>
+                          <a:spcPct val="100000"/>
+                        </a:lnSpc>
+                        <a:spcBef>
+                          <a:spcPts val="0"/>
+                        </a:spcBef>
+                        <a:spcAft>
+                          <a:spcPts val="0"/>
+                        </a:spcAft>
+                      </a:pPr>
+                      <a:r>
+                        <a:rPr sz="840" b="0">
+                          <a:solidFill>
+                            <a:srgbClr val="000000"/>
+                          </a:solidFill>
+                          <a:latin typeface="Montserrat"/>
+                        </a:rPr>
+                        <a:t>1.000</a:t>
+                      </a:r>
+                    </a:p>
+                  </a:txBody>
+                  <a:tcPr marL="32004" marR="32004" marT="9144" marB="9144">
+                    <a:solidFill>
+                      <a:srgbClr val="FFFFFF"/>
+                    </a:solidFill>
+                  </a:tcPr>
+                </a:tc>
+                <a:tc>
+                  <a:txBody>
+                    <a:bodyPr/>
+                    <a:lstStyle/>
+                    <a:p>
+                      <a:pPr algn="ctr">
+                        <a:lnSpc>
+                          <a:spcPct val="100000"/>
+                        </a:lnSpc>
+                        <a:spcBef>
+                          <a:spcPts val="0"/>
+                        </a:spcBef>
+                        <a:spcAft>
+                          <a:spcPts val="0"/>
+                        </a:spcAft>
+                      </a:pPr>
+                      <a:r>
+                        <a:rPr sz="840" b="0">
+                          <a:solidFill>
+                            <a:srgbClr val="000000"/>
+                          </a:solidFill>
+                          <a:latin typeface="Montserrat"/>
+                        </a:rPr>
+                        <a:t>.974</a:t>
+                      </a:r>
+                    </a:p>
+                  </a:txBody>
+                  <a:tcPr marL="32004" marR="32004" marT="9144" marB="9144">
+                    <a:solidFill>
+                      <a:srgbClr val="FFFFFF"/>
+                    </a:solidFill>
+                  </a:tcPr>
+                </a:tc>
+                <a:tc>
+                  <a:txBody>
+                    <a:bodyPr/>
+                    <a:lstStyle/>
+                    <a:p>
+                      <a:pPr algn="ctr">
+                        <a:lnSpc>
+                          <a:spcPct val="100000"/>
+                        </a:lnSpc>
+                        <a:spcBef>
+                          <a:spcPts val="0"/>
+                        </a:spcBef>
+                        <a:spcAft>
+                          <a:spcPts val="0"/>
+                        </a:spcAft>
+                      </a:pPr>
+                      <a:r>
+                        <a:rPr sz="840" b="1">
+                          <a:solidFill>
+                            <a:srgbClr val="1F7752"/>
+                          </a:solidFill>
+                          <a:latin typeface="Montserrat"/>
+                        </a:rPr>
+                        <a:t>PASS</a:t>
+                      </a:r>
+                    </a:p>
+                  </a:txBody>
+                  <a:tcPr marL="32004" marR="32004" marT="9144" marB="9144">
+                    <a:solidFill>
+                      <a:srgbClr val="FFFFFF"/>
+                    </a:solidFill>
+                  </a:tcPr>
+                </a:tc>
+              </a:tr>
+              <a:tr h="309238">
+                <a:tc>
+                  <a:txBody>
+                    <a:bodyPr/>
+                    <a:lstStyle/>
+                    <a:p>
+                      <a:pPr algn="ctr">
+                        <a:lnSpc>
+                          <a:spcPct val="100000"/>
+                        </a:lnSpc>
+                        <a:spcBef>
+                          <a:spcPts val="0"/>
+                        </a:spcBef>
+                        <a:spcAft>
+                          <a:spcPts val="0"/>
+                        </a:spcAft>
+                      </a:pPr>
+                      <a:r>
+                        <a:rPr sz="840" b="0">
+                          <a:solidFill>
+                            <a:srgbClr val="000000"/>
+                          </a:solidFill>
+                          <a:latin typeface="Montserrat"/>
+                        </a:rPr>
+                        <a:t>10</a:t>
+                      </a:r>
+                    </a:p>
+                  </a:txBody>
+                  <a:tcPr marL="32004" marR="32004" marT="9144" marB="9144">
+                    <a:solidFill>
+                      <a:srgbClr val="F2F6FF"/>
+                    </a:solidFill>
+                  </a:tcPr>
+                </a:tc>
+                <a:tc>
+                  <a:txBody>
+                    <a:bodyPr/>
+                    <a:lstStyle/>
+                    <a:p>
+                      <a:pPr algn="l">
+                        <a:lnSpc>
+                          <a:spcPct val="100000"/>
+                        </a:lnSpc>
+                        <a:spcBef>
+                          <a:spcPts val="0"/>
+                        </a:spcBef>
+                        <a:spcAft>
+                          <a:spcPts val="0"/>
+                        </a:spcAft>
+                      </a:pPr>
+                      <a:r>
+                        <a:rPr sz="840" b="0">
+                          <a:solidFill>
+                            <a:srgbClr val="000000"/>
+                          </a:solidFill>
+                          <a:latin typeface="Montserrat"/>
+                        </a:rPr>
+                        <a:t>Card-hold difference</a:t>
+                      </a:r>
+                    </a:p>
+                  </a:txBody>
+                  <a:tcPr marL="32004" marR="32004" marT="9144" marB="9144">
+                    <a:solidFill>
+                      <a:srgbClr val="F2F6FF"/>
+                    </a:solidFill>
+                  </a:tcPr>
+                </a:tc>
+                <a:tc>
+                  <a:txBody>
+                    <a:bodyPr/>
+                    <a:lstStyle/>
+                    <a:p>
+                      <a:pPr algn="ctr">
+                        <a:lnSpc>
+                          <a:spcPct val="100000"/>
+                        </a:lnSpc>
+                        <a:spcBef>
+                          <a:spcPts val="0"/>
+                        </a:spcBef>
+                        <a:spcAft>
+                          <a:spcPts val="0"/>
+                        </a:spcAft>
+                      </a:pPr>
+                      <a:r>
+                        <a:rPr sz="840" b="0">
+                          <a:solidFill>
+                            <a:srgbClr val="000000"/>
+                          </a:solidFill>
+                          <a:latin typeface="Montserrat"/>
+                        </a:rPr>
+                        <a:t>.999</a:t>
+                      </a:r>
+                    </a:p>
+                  </a:txBody>
+                  <a:tcPr marL="32004" marR="32004" marT="9144" marB="9144">
+                    <a:solidFill>
+                      <a:srgbClr val="F2F6FF"/>
+                    </a:solidFill>
+                  </a:tcPr>
+                </a:tc>
+                <a:tc>
+                  <a:txBody>
+                    <a:bodyPr/>
+                    <a:lstStyle/>
+                    <a:p>
+                      <a:pPr algn="ctr">
+                        <a:lnSpc>
+                          <a:spcPct val="100000"/>
+                        </a:lnSpc>
+                        <a:spcBef>
+                          <a:spcPts val="0"/>
+                        </a:spcBef>
+                        <a:spcAft>
+                          <a:spcPts val="0"/>
+                        </a:spcAft>
+                      </a:pPr>
+                      <a:r>
+                        <a:rPr sz="840" b="0">
+                          <a:solidFill>
+                            <a:srgbClr val="000000"/>
+                          </a:solidFill>
+                          <a:latin typeface="Montserrat"/>
+                        </a:rPr>
+                        <a:t>.998</a:t>
+                      </a:r>
+                    </a:p>
+                  </a:txBody>
+                  <a:tcPr marL="32004" marR="32004" marT="9144" marB="9144">
+                    <a:solidFill>
+                      <a:srgbClr val="F2F6FF"/>
+                    </a:solidFill>
+                  </a:tcPr>
+                </a:tc>
+                <a:tc>
+                  <a:txBody>
+                    <a:bodyPr/>
+                    <a:lstStyle/>
+                    <a:p>
+                      <a:pPr algn="ctr">
+                        <a:lnSpc>
+                          <a:spcPct val="100000"/>
+                        </a:lnSpc>
+                        <a:spcBef>
+                          <a:spcPts val="0"/>
+                        </a:spcBef>
+                        <a:spcAft>
+                          <a:spcPts val="0"/>
+                        </a:spcAft>
+                      </a:pPr>
+                      <a:r>
+                        <a:rPr sz="840" b="0">
+                          <a:solidFill>
+                            <a:srgbClr val="000000"/>
+                          </a:solidFill>
+                          <a:latin typeface="Montserrat"/>
+                        </a:rPr>
+                        <a:t>.781</a:t>
+                      </a:r>
+                    </a:p>
+                  </a:txBody>
+                  <a:tcPr marL="32004" marR="32004" marT="9144" marB="9144">
+                    <a:solidFill>
+                      <a:srgbClr val="F2F6FF"/>
+                    </a:solidFill>
+                  </a:tcPr>
+                </a:tc>
+                <a:tc>
+                  <a:txBody>
+                    <a:bodyPr/>
+                    <a:lstStyle/>
+                    <a:p>
+                      <a:pPr algn="ctr">
+                        <a:lnSpc>
+                          <a:spcPct val="100000"/>
+                        </a:lnSpc>
+                        <a:spcBef>
+                          <a:spcPts val="0"/>
+                        </a:spcBef>
+                        <a:spcAft>
+                          <a:spcPts val="0"/>
+                        </a:spcAft>
+                      </a:pPr>
+                      <a:r>
+                        <a:rPr sz="840" b="0">
+                          <a:solidFill>
+                            <a:srgbClr val="000000"/>
+                          </a:solidFill>
+                          <a:latin typeface="Montserrat"/>
+                        </a:rPr>
+                        <a:t>.895</a:t>
+                      </a:r>
+                    </a:p>
+                  </a:txBody>
+                  <a:tcPr marL="32004" marR="32004" marT="9144" marB="9144">
+                    <a:solidFill>
+                      <a:srgbClr val="F2F6FF"/>
+                    </a:solidFill>
+                  </a:tcPr>
+                </a:tc>
+                <a:tc>
+                  <a:txBody>
+                    <a:bodyPr/>
+                    <a:lstStyle/>
+                    <a:p>
+                      <a:pPr algn="ctr">
+                        <a:lnSpc>
+                          <a:spcPct val="100000"/>
+                        </a:lnSpc>
+                        <a:spcBef>
+                          <a:spcPts val="0"/>
+                        </a:spcBef>
+                        <a:spcAft>
+                          <a:spcPts val="0"/>
+                        </a:spcAft>
+                      </a:pPr>
+                      <a:r>
+                        <a:rPr sz="840" b="0">
+                          <a:solidFill>
+                            <a:srgbClr val="000000"/>
+                          </a:solidFill>
+                          <a:latin typeface="Montserrat"/>
+                        </a:rPr>
+                        <a:t>.934</a:t>
+                      </a:r>
+                    </a:p>
+                  </a:txBody>
+                  <a:tcPr marL="32004" marR="32004" marT="9144" marB="9144">
+                    <a:solidFill>
+                      <a:srgbClr val="F2F6FF"/>
+                    </a:solidFill>
+                  </a:tcPr>
+                </a:tc>
+                <a:tc>
+                  <a:txBody>
+                    <a:bodyPr/>
+                    <a:lstStyle/>
+                    <a:p>
+                      <a:pPr algn="ctr">
+                        <a:lnSpc>
+                          <a:spcPct val="100000"/>
+                        </a:lnSpc>
+                        <a:spcBef>
+                          <a:spcPts val="0"/>
+                        </a:spcBef>
+                        <a:spcAft>
+                          <a:spcPts val="0"/>
+                        </a:spcAft>
+                      </a:pPr>
+                      <a:r>
+                        <a:rPr sz="840" b="1">
+                          <a:solidFill>
+                            <a:srgbClr val="1F7752"/>
+                          </a:solidFill>
+                          <a:latin typeface="Montserrat"/>
+                        </a:rPr>
+                        <a:t>PASS</a:t>
+                      </a:r>
+                    </a:p>
+                  </a:txBody>
+                  <a:tcPr marL="32004" marR="32004" marT="9144" marB="9144">
+                    <a:solidFill>
+                      <a:srgbClr val="F2F6FF"/>
+                    </a:solidFill>
+                  </a:tcPr>
+                </a:tc>
+              </a:tr>
+            </a:tbl>
+          </a:graphicData>
+        </a:graphic>
+      </p:graphicFrame>
+      <p:sp>
+        <p:nvSpPr>
+          <p:cNvPr id="321" name="TextBox 320"/>
           <p:cNvSpPr txBox="1"/>
           <p:nvPr/>
         </p:nvSpPr>
         <p:spPr>
           <a:xfrm>
-            <a:off x="694944" y="1325880"/>
-            <a:ext cx="6729984" cy="256032"/>
+            <a:off x="502920" y="4681728"/>
+            <a:ext cx="8138160" cy="256032"/>
           </a:xfrm>
           <a:prstGeom prst="rect">
             <a:avLst/>
@@ -37922,15 +40880,12 @@
           <a:noFill/>
         </p:spPr>
         <p:txBody>
-          <a:bodyPr wrap="square" lIns="82296" rIns="36576" tIns="18288" bIns="18288">
-            <a:normAutofit/>
+          <a:bodyPr wrap="square" lIns="27432" rIns="27432">
+            <a:spAutoFit/>
           </a:bodyPr>
           <a:lstStyle/>
           <a:p>
             <a:pPr>
-              <a:lnSpc>
-                <a:spcPct val="100000"/>
-              </a:lnSpc>
               <a:spcBef>
                 <a:spcPts val="0"/>
               </a:spcBef>
@@ -37939,1113 +40894,14 @@
               </a:spcAft>
             </a:pPr>
             <a:r>
-              <a:rPr sz="1350" b="0">
-                <a:solidFill>
-                  <a:srgbClr val="000000"/>
+              <a:rPr sz="950" b="1">
+                <a:solidFill>
+                  <a:srgbClr val="0E39A9"/>
                 </a:solidFill>
                 <a:latin typeface="Montserrat"/>
               </a:rPr>
-              <a:t>Held-out case-level output — selected baseline k=5</a:t>
+              <a:t>Selected baseline: 9/10 passed; weighted composite .941. The only failure is Accessible King Precision=.451.</a:t>
             </a:r>
-          </a:p>
-        </p:txBody>
-      </p:sp>
-      <p:sp>
-        <p:nvSpPr>
-          <p:cNvPr id="321" name="Oval 320"/>
-          <p:cNvSpPr/>
-          <p:nvPr/>
-        </p:nvSpPr>
-        <p:spPr>
-          <a:xfrm>
-            <a:off x="402336" y="1426464"/>
-            <a:ext cx="192024" cy="192024"/>
-          </a:xfrm>
-          <a:prstGeom prst="ellipse">
-            <a:avLst/>
-          </a:prstGeom>
-          <a:solidFill>
-            <a:srgbClr val="0944A1"/>
-          </a:solidFill>
-          <a:ln>
-            <a:noFill/>
-          </a:ln>
-        </p:spPr>
-        <p:style>
-          <a:lnRef idx="1">
-            <a:schemeClr val="accent1"/>
-          </a:lnRef>
-          <a:fillRef idx="3">
-            <a:schemeClr val="accent1"/>
-          </a:fillRef>
-          <a:effectRef idx="2">
-            <a:schemeClr val="accent1"/>
-          </a:effectRef>
-          <a:fontRef idx="minor">
-            <a:schemeClr val="lt1"/>
-          </a:fontRef>
-        </p:style>
-        <p:txBody>
-          <a:bodyPr rtlCol="0" anchor="ctr"/>
-          <a:lstStyle/>
-          <a:p>
-            <a:pPr algn="ctr"/>
-          </a:p>
-        </p:txBody>
-      </p:sp>
-      <p:sp>
-        <p:nvSpPr>
-          <p:cNvPr id="322" name="TextBox 321"/>
-          <p:cNvSpPr txBox="1"/>
-          <p:nvPr/>
-        </p:nvSpPr>
-        <p:spPr>
-          <a:xfrm>
-            <a:off x="694944" y="1613916"/>
-            <a:ext cx="6729984" cy="256032"/>
-          </a:xfrm>
-          <a:prstGeom prst="rect">
-            <a:avLst/>
-          </a:prstGeom>
-          <a:noFill/>
-        </p:spPr>
-        <p:txBody>
-          <a:bodyPr wrap="square" lIns="82296" rIns="36576" tIns="18288" bIns="18288">
-            <a:normAutofit/>
-          </a:bodyPr>
-          <a:lstStyle/>
-          <a:p>
-            <a:pPr>
-              <a:lnSpc>
-                <a:spcPct val="100000"/>
-              </a:lnSpc>
-              <a:spcBef>
-                <a:spcPts val="0"/>
-              </a:spcBef>
-              <a:spcAft>
-                <a:spcPts val="0"/>
-              </a:spcAft>
-            </a:pPr>
-            <a:r>
-              <a:rPr sz="1350" b="0">
-                <a:solidFill>
-                  <a:srgbClr val="000000"/>
-                </a:solidFill>
-                <a:latin typeface="Montserrat"/>
-              </a:rPr>
-              <a:t>Case 01 | OTA cancellation/refund | PASS | Composite .944</a:t>
-            </a:r>
-          </a:p>
-        </p:txBody>
-      </p:sp>
-      <p:sp>
-        <p:nvSpPr>
-          <p:cNvPr id="323" name="Oval 322"/>
-          <p:cNvSpPr/>
-          <p:nvPr/>
-        </p:nvSpPr>
-        <p:spPr>
-          <a:xfrm>
-            <a:off x="402336" y="1714500"/>
-            <a:ext cx="192024" cy="192024"/>
-          </a:xfrm>
-          <a:prstGeom prst="ellipse">
-            <a:avLst/>
-          </a:prstGeom>
-          <a:solidFill>
-            <a:srgbClr val="0944A1"/>
-          </a:solidFill>
-          <a:ln>
-            <a:noFill/>
-          </a:ln>
-        </p:spPr>
-        <p:style>
-          <a:lnRef idx="1">
-            <a:schemeClr val="accent1"/>
-          </a:lnRef>
-          <a:fillRef idx="3">
-            <a:schemeClr val="accent1"/>
-          </a:fillRef>
-          <a:effectRef idx="2">
-            <a:schemeClr val="accent1"/>
-          </a:effectRef>
-          <a:fontRef idx="minor">
-            <a:schemeClr val="lt1"/>
-          </a:fontRef>
-        </p:style>
-        <p:txBody>
-          <a:bodyPr rtlCol="0" anchor="ctr"/>
-          <a:lstStyle/>
-          <a:p>
-            <a:pPr algn="ctr"/>
-          </a:p>
-        </p:txBody>
-      </p:sp>
-      <p:sp>
-        <p:nvSpPr>
-          <p:cNvPr id="324" name="TextBox 323"/>
-          <p:cNvSpPr txBox="1"/>
-          <p:nvPr/>
-        </p:nvSpPr>
-        <p:spPr>
-          <a:xfrm>
-            <a:off x="694944" y="1901952"/>
-            <a:ext cx="6729984" cy="256032"/>
-          </a:xfrm>
-          <a:prstGeom prst="rect">
-            <a:avLst/>
-          </a:prstGeom>
-          <a:noFill/>
-        </p:spPr>
-        <p:txBody>
-          <a:bodyPr wrap="square" lIns="82296" rIns="36576" tIns="18288" bIns="18288">
-            <a:normAutofit/>
-          </a:bodyPr>
-          <a:lstStyle/>
-          <a:p>
-            <a:pPr>
-              <a:lnSpc>
-                <a:spcPct val="100000"/>
-              </a:lnSpc>
-              <a:spcBef>
-                <a:spcPts val="0"/>
-              </a:spcBef>
-              <a:spcAft>
-                <a:spcPts val="0"/>
-              </a:spcAft>
-            </a:pPr>
-            <a:r>
-              <a:rPr sz="1350" b="0">
-                <a:solidFill>
-                  <a:srgbClr val="000000"/>
-                </a:solidFill>
-                <a:latin typeface="Montserrat"/>
-              </a:rPr>
-              <a:t>Case 02 | Member discount/cancellation | PASS | Composite .956</a:t>
-            </a:r>
-          </a:p>
-        </p:txBody>
-      </p:sp>
-      <p:sp>
-        <p:nvSpPr>
-          <p:cNvPr id="325" name="Oval 324"/>
-          <p:cNvSpPr/>
-          <p:nvPr/>
-        </p:nvSpPr>
-        <p:spPr>
-          <a:xfrm>
-            <a:off x="402336" y="2002536"/>
-            <a:ext cx="192024" cy="192024"/>
-          </a:xfrm>
-          <a:prstGeom prst="ellipse">
-            <a:avLst/>
-          </a:prstGeom>
-          <a:solidFill>
-            <a:srgbClr val="0944A1"/>
-          </a:solidFill>
-          <a:ln>
-            <a:noFill/>
-          </a:ln>
-        </p:spPr>
-        <p:style>
-          <a:lnRef idx="1">
-            <a:schemeClr val="accent1"/>
-          </a:lnRef>
-          <a:fillRef idx="3">
-            <a:schemeClr val="accent1"/>
-          </a:fillRef>
-          <a:effectRef idx="2">
-            <a:schemeClr val="accent1"/>
-          </a:effectRef>
-          <a:fontRef idx="minor">
-            <a:schemeClr val="lt1"/>
-          </a:fontRef>
-        </p:style>
-        <p:txBody>
-          <a:bodyPr rtlCol="0" anchor="ctr"/>
-          <a:lstStyle/>
-          <a:p>
-            <a:pPr algn="ctr"/>
-          </a:p>
-        </p:txBody>
-      </p:sp>
-      <p:sp>
-        <p:nvSpPr>
-          <p:cNvPr id="326" name="TextBox 325"/>
-          <p:cNvSpPr txBox="1"/>
-          <p:nvPr/>
-        </p:nvSpPr>
-        <p:spPr>
-          <a:xfrm>
-            <a:off x="694944" y="2189988"/>
-            <a:ext cx="6729984" cy="256032"/>
-          </a:xfrm>
-          <a:prstGeom prst="rect">
-            <a:avLst/>
-          </a:prstGeom>
-          <a:noFill/>
-        </p:spPr>
-        <p:txBody>
-          <a:bodyPr wrap="square" lIns="82296" rIns="36576" tIns="18288" bIns="18288">
-            <a:normAutofit/>
-          </a:bodyPr>
-          <a:lstStyle/>
-          <a:p>
-            <a:pPr>
-              <a:lnSpc>
-                <a:spcPct val="100000"/>
-              </a:lnSpc>
-              <a:spcBef>
-                <a:spcPts val="0"/>
-              </a:spcBef>
-              <a:spcAft>
-                <a:spcPts val="0"/>
-              </a:spcAft>
-            </a:pPr>
-            <a:r>
-              <a:rPr sz="1350" b="0">
-                <a:solidFill>
-                  <a:srgbClr val="000000"/>
-                </a:solidFill>
-                <a:latin typeface="Montserrat"/>
-              </a:rPr>
-              <a:t>Case 03 | Double Queen occupancy | PASS | Composite .988</a:t>
-            </a:r>
-          </a:p>
-        </p:txBody>
-      </p:sp>
-      <p:sp>
-        <p:nvSpPr>
-          <p:cNvPr id="327" name="Oval 326"/>
-          <p:cNvSpPr/>
-          <p:nvPr/>
-        </p:nvSpPr>
-        <p:spPr>
-          <a:xfrm>
-            <a:off x="402336" y="2290572"/>
-            <a:ext cx="192024" cy="192024"/>
-          </a:xfrm>
-          <a:prstGeom prst="ellipse">
-            <a:avLst/>
-          </a:prstGeom>
-          <a:solidFill>
-            <a:srgbClr val="0944A1"/>
-          </a:solidFill>
-          <a:ln>
-            <a:noFill/>
-          </a:ln>
-        </p:spPr>
-        <p:style>
-          <a:lnRef idx="1">
-            <a:schemeClr val="accent1"/>
-          </a:lnRef>
-          <a:fillRef idx="3">
-            <a:schemeClr val="accent1"/>
-          </a:fillRef>
-          <a:effectRef idx="2">
-            <a:schemeClr val="accent1"/>
-          </a:effectRef>
-          <a:fontRef idx="minor">
-            <a:schemeClr val="lt1"/>
-          </a:fontRef>
-        </p:style>
-        <p:txBody>
-          <a:bodyPr rtlCol="0" anchor="ctr"/>
-          <a:lstStyle/>
-          <a:p>
-            <a:pPr algn="ctr"/>
-          </a:p>
-        </p:txBody>
-      </p:sp>
-      <p:sp>
-        <p:nvSpPr>
-          <p:cNvPr id="328" name="TextBox 327"/>
-          <p:cNvSpPr txBox="1"/>
-          <p:nvPr/>
-        </p:nvSpPr>
-        <p:spPr>
-          <a:xfrm>
-            <a:off x="694944" y="2478024"/>
-            <a:ext cx="6729984" cy="256032"/>
-          </a:xfrm>
-          <a:prstGeom prst="rect">
-            <a:avLst/>
-          </a:prstGeom>
-          <a:noFill/>
-        </p:spPr>
-        <p:txBody>
-          <a:bodyPr wrap="square" lIns="82296" rIns="36576" tIns="18288" bIns="18288">
-            <a:normAutofit/>
-          </a:bodyPr>
-          <a:lstStyle/>
-          <a:p>
-            <a:pPr>
-              <a:lnSpc>
-                <a:spcPct val="100000"/>
-              </a:lnSpc>
-              <a:spcBef>
-                <a:spcPts val="0"/>
-              </a:spcBef>
-              <a:spcAft>
-                <a:spcPts val="0"/>
-              </a:spcAft>
-            </a:pPr>
-            <a:r>
-              <a:rPr sz="1350" b="0">
-                <a:solidFill>
-                  <a:srgbClr val="000000"/>
-                </a:solidFill>
-                <a:latin typeface="Montserrat"/>
-              </a:rPr>
-              <a:t>Case 04 | Accessible King inclusions | FAIL | Precision .451</a:t>
-            </a:r>
-          </a:p>
-        </p:txBody>
-      </p:sp>
-      <p:sp>
-        <p:nvSpPr>
-          <p:cNvPr id="329" name="Oval 328"/>
-          <p:cNvSpPr/>
-          <p:nvPr/>
-        </p:nvSpPr>
-        <p:spPr>
-          <a:xfrm>
-            <a:off x="402336" y="2578608"/>
-            <a:ext cx="192024" cy="192024"/>
-          </a:xfrm>
-          <a:prstGeom prst="ellipse">
-            <a:avLst/>
-          </a:prstGeom>
-          <a:solidFill>
-            <a:srgbClr val="0944A1"/>
-          </a:solidFill>
-          <a:ln>
-            <a:noFill/>
-          </a:ln>
-        </p:spPr>
-        <p:style>
-          <a:lnRef idx="1">
-            <a:schemeClr val="accent1"/>
-          </a:lnRef>
-          <a:fillRef idx="3">
-            <a:schemeClr val="accent1"/>
-          </a:fillRef>
-          <a:effectRef idx="2">
-            <a:schemeClr val="accent1"/>
-          </a:effectRef>
-          <a:fontRef idx="minor">
-            <a:schemeClr val="lt1"/>
-          </a:fontRef>
-        </p:style>
-        <p:txBody>
-          <a:bodyPr rtlCol="0" anchor="ctr"/>
-          <a:lstStyle/>
-          <a:p>
-            <a:pPr algn="ctr"/>
-          </a:p>
-        </p:txBody>
-      </p:sp>
-      <p:sp>
-        <p:nvSpPr>
-          <p:cNvPr id="330" name="TextBox 329"/>
-          <p:cNvSpPr txBox="1"/>
-          <p:nvPr/>
-        </p:nvSpPr>
-        <p:spPr>
-          <a:xfrm>
-            <a:off x="694944" y="2766060"/>
-            <a:ext cx="6729984" cy="256032"/>
-          </a:xfrm>
-          <a:prstGeom prst="rect">
-            <a:avLst/>
-          </a:prstGeom>
-          <a:noFill/>
-        </p:spPr>
-        <p:txBody>
-          <a:bodyPr wrap="square" lIns="82296" rIns="36576" tIns="18288" bIns="18288">
-            <a:normAutofit/>
-          </a:bodyPr>
-          <a:lstStyle/>
-          <a:p>
-            <a:pPr>
-              <a:lnSpc>
-                <a:spcPct val="100000"/>
-              </a:lnSpc>
-              <a:spcBef>
-                <a:spcPts val="0"/>
-              </a:spcBef>
-              <a:spcAft>
-                <a:spcPts val="0"/>
-              </a:spcAft>
-            </a:pPr>
-            <a:r>
-              <a:rPr sz="1350" b="0">
-                <a:solidFill>
-                  <a:srgbClr val="000000"/>
-                </a:solidFill>
-                <a:latin typeface="Montserrat"/>
-              </a:rPr>
-              <a:t>Case 05 | Atlanta/Miami parking | PASS | Composite .975</a:t>
-            </a:r>
-          </a:p>
-        </p:txBody>
-      </p:sp>
-      <p:sp>
-        <p:nvSpPr>
-          <p:cNvPr id="331" name="Oval 330"/>
-          <p:cNvSpPr/>
-          <p:nvPr/>
-        </p:nvSpPr>
-        <p:spPr>
-          <a:xfrm>
-            <a:off x="402336" y="2866644"/>
-            <a:ext cx="192024" cy="192024"/>
-          </a:xfrm>
-          <a:prstGeom prst="ellipse">
-            <a:avLst/>
-          </a:prstGeom>
-          <a:solidFill>
-            <a:srgbClr val="0944A1"/>
-          </a:solidFill>
-          <a:ln>
-            <a:noFill/>
-          </a:ln>
-        </p:spPr>
-        <p:style>
-          <a:lnRef idx="1">
-            <a:schemeClr val="accent1"/>
-          </a:lnRef>
-          <a:fillRef idx="3">
-            <a:schemeClr val="accent1"/>
-          </a:fillRef>
-          <a:effectRef idx="2">
-            <a:schemeClr val="accent1"/>
-          </a:effectRef>
-          <a:fontRef idx="minor">
-            <a:schemeClr val="lt1"/>
-          </a:fontRef>
-        </p:style>
-        <p:txBody>
-          <a:bodyPr rtlCol="0" anchor="ctr"/>
-          <a:lstStyle/>
-          <a:p>
-            <a:pPr algn="ctr"/>
-          </a:p>
-        </p:txBody>
-      </p:sp>
-      <p:sp>
-        <p:nvSpPr>
-          <p:cNvPr id="332" name="TextBox 331"/>
-          <p:cNvSpPr txBox="1"/>
-          <p:nvPr/>
-        </p:nvSpPr>
-        <p:spPr>
-          <a:xfrm>
-            <a:off x="694944" y="3054096"/>
-            <a:ext cx="6729984" cy="256032"/>
-          </a:xfrm>
-          <a:prstGeom prst="rect">
-            <a:avLst/>
-          </a:prstGeom>
-          <a:noFill/>
-        </p:spPr>
-        <p:txBody>
-          <a:bodyPr wrap="square" lIns="82296" rIns="36576" tIns="18288" bIns="18288">
-            <a:normAutofit/>
-          </a:bodyPr>
-          <a:lstStyle/>
-          <a:p>
-            <a:pPr>
-              <a:lnSpc>
-                <a:spcPct val="100000"/>
-              </a:lnSpc>
-              <a:spcBef>
-                <a:spcPts val="0"/>
-              </a:spcBef>
-              <a:spcAft>
-                <a:spcPts val="0"/>
-              </a:spcAft>
-            </a:pPr>
-            <a:r>
-              <a:rPr sz="1350" b="0">
-                <a:solidFill>
-                  <a:srgbClr val="000000"/>
-                </a:solidFill>
-                <a:latin typeface="Montserrat"/>
-              </a:rPr>
-              <a:t>Case 06 | Miami breakfast | PASS | Composite .963</a:t>
-            </a:r>
-          </a:p>
-        </p:txBody>
-      </p:sp>
-      <p:sp>
-        <p:nvSpPr>
-          <p:cNvPr id="333" name="Oval 332"/>
-          <p:cNvSpPr/>
-          <p:nvPr/>
-        </p:nvSpPr>
-        <p:spPr>
-          <a:xfrm>
-            <a:off x="402336" y="3154679"/>
-            <a:ext cx="192024" cy="192024"/>
-          </a:xfrm>
-          <a:prstGeom prst="ellipse">
-            <a:avLst/>
-          </a:prstGeom>
-          <a:solidFill>
-            <a:srgbClr val="0944A1"/>
-          </a:solidFill>
-          <a:ln>
-            <a:noFill/>
-          </a:ln>
-        </p:spPr>
-        <p:style>
-          <a:lnRef idx="1">
-            <a:schemeClr val="accent1"/>
-          </a:lnRef>
-          <a:fillRef idx="3">
-            <a:schemeClr val="accent1"/>
-          </a:fillRef>
-          <a:effectRef idx="2">
-            <a:schemeClr val="accent1"/>
-          </a:effectRef>
-          <a:fontRef idx="minor">
-            <a:schemeClr val="lt1"/>
-          </a:fontRef>
-        </p:style>
-        <p:txBody>
-          <a:bodyPr rtlCol="0" anchor="ctr"/>
-          <a:lstStyle/>
-          <a:p>
-            <a:pPr algn="ctr"/>
-          </a:p>
-        </p:txBody>
-      </p:sp>
-      <p:sp>
-        <p:nvSpPr>
-          <p:cNvPr id="334" name="TextBox 333"/>
-          <p:cNvSpPr txBox="1"/>
-          <p:nvPr/>
-        </p:nvSpPr>
-        <p:spPr>
-          <a:xfrm>
-            <a:off x="694944" y="3342132"/>
-            <a:ext cx="6729984" cy="256032"/>
-          </a:xfrm>
-          <a:prstGeom prst="rect">
-            <a:avLst/>
-          </a:prstGeom>
-          <a:noFill/>
-        </p:spPr>
-        <p:txBody>
-          <a:bodyPr wrap="square" lIns="82296" rIns="36576" tIns="18288" bIns="18288">
-            <a:normAutofit/>
-          </a:bodyPr>
-          <a:lstStyle/>
-          <a:p>
-            <a:pPr>
-              <a:lnSpc>
-                <a:spcPct val="100000"/>
-              </a:lnSpc>
-              <a:spcBef>
-                <a:spcPts val="0"/>
-              </a:spcBef>
-              <a:spcAft>
-                <a:spcPts val="0"/>
-              </a:spcAft>
-            </a:pPr>
-            <a:r>
-              <a:rPr sz="1350" b="0">
-                <a:solidFill>
-                  <a:srgbClr val="000000"/>
-                </a:solidFill>
-                <a:latin typeface="Montserrat"/>
-              </a:rPr>
-              <a:t>Case 07 | Advance Purchase change | PASS | Composite .916</a:t>
-            </a:r>
-          </a:p>
-        </p:txBody>
-      </p:sp>
-      <p:sp>
-        <p:nvSpPr>
-          <p:cNvPr id="335" name="Oval 334"/>
-          <p:cNvSpPr/>
-          <p:nvPr/>
-        </p:nvSpPr>
-        <p:spPr>
-          <a:xfrm>
-            <a:off x="402336" y="3442715"/>
-            <a:ext cx="192024" cy="192024"/>
-          </a:xfrm>
-          <a:prstGeom prst="ellipse">
-            <a:avLst/>
-          </a:prstGeom>
-          <a:solidFill>
-            <a:srgbClr val="0944A1"/>
-          </a:solidFill>
-          <a:ln>
-            <a:noFill/>
-          </a:ln>
-        </p:spPr>
-        <p:style>
-          <a:lnRef idx="1">
-            <a:schemeClr val="accent1"/>
-          </a:lnRef>
-          <a:fillRef idx="3">
-            <a:schemeClr val="accent1"/>
-          </a:fillRef>
-          <a:effectRef idx="2">
-            <a:schemeClr val="accent1"/>
-          </a:effectRef>
-          <a:fontRef idx="minor">
-            <a:schemeClr val="lt1"/>
-          </a:fontRef>
-        </p:style>
-        <p:txBody>
-          <a:bodyPr rtlCol="0" anchor="ctr"/>
-          <a:lstStyle/>
-          <a:p>
-            <a:pPr algn="ctr"/>
-          </a:p>
-        </p:txBody>
-      </p:sp>
-      <p:sp>
-        <p:nvSpPr>
-          <p:cNvPr id="336" name="TextBox 335"/>
-          <p:cNvSpPr txBox="1"/>
-          <p:nvPr/>
-        </p:nvSpPr>
-        <p:spPr>
-          <a:xfrm>
-            <a:off x="694944" y="3630168"/>
-            <a:ext cx="6729984" cy="256032"/>
-          </a:xfrm>
-          <a:prstGeom prst="rect">
-            <a:avLst/>
-          </a:prstGeom>
-          <a:noFill/>
-        </p:spPr>
-        <p:txBody>
-          <a:bodyPr wrap="square" lIns="82296" rIns="36576" tIns="18288" bIns="18288">
-            <a:normAutofit/>
-          </a:bodyPr>
-          <a:lstStyle/>
-          <a:p>
-            <a:pPr>
-              <a:lnSpc>
-                <a:spcPct val="100000"/>
-              </a:lnSpc>
-              <a:spcBef>
-                <a:spcPts val="0"/>
-              </a:spcBef>
-              <a:spcAft>
-                <a:spcPts val="0"/>
-              </a:spcAft>
-            </a:pPr>
-            <a:r>
-              <a:rPr sz="1350" b="0">
-                <a:solidFill>
-                  <a:srgbClr val="000000"/>
-                </a:solidFill>
-                <a:latin typeface="Montserrat"/>
-              </a:rPr>
-              <a:t>Case 08 | Denver late checkout | PASS | Composite .939</a:t>
-            </a:r>
-          </a:p>
-        </p:txBody>
-      </p:sp>
-      <p:sp>
-        <p:nvSpPr>
-          <p:cNvPr id="337" name="Oval 336"/>
-          <p:cNvSpPr/>
-          <p:nvPr/>
-        </p:nvSpPr>
-        <p:spPr>
-          <a:xfrm>
-            <a:off x="402336" y="3730752"/>
-            <a:ext cx="192024" cy="192024"/>
-          </a:xfrm>
-          <a:prstGeom prst="ellipse">
-            <a:avLst/>
-          </a:prstGeom>
-          <a:solidFill>
-            <a:srgbClr val="0944A1"/>
-          </a:solidFill>
-          <a:ln>
-            <a:noFill/>
-          </a:ln>
-        </p:spPr>
-        <p:style>
-          <a:lnRef idx="1">
-            <a:schemeClr val="accent1"/>
-          </a:lnRef>
-          <a:fillRef idx="3">
-            <a:schemeClr val="accent1"/>
-          </a:fillRef>
-          <a:effectRef idx="2">
-            <a:schemeClr val="accent1"/>
-          </a:effectRef>
-          <a:fontRef idx="minor">
-            <a:schemeClr val="lt1"/>
-          </a:fontRef>
-        </p:style>
-        <p:txBody>
-          <a:bodyPr rtlCol="0" anchor="ctr"/>
-          <a:lstStyle/>
-          <a:p>
-            <a:pPr algn="ctr"/>
-          </a:p>
-        </p:txBody>
-      </p:sp>
-      <p:sp>
-        <p:nvSpPr>
-          <p:cNvPr id="338" name="TextBox 337"/>
-          <p:cNvSpPr txBox="1"/>
-          <p:nvPr/>
-        </p:nvSpPr>
-        <p:spPr>
-          <a:xfrm>
-            <a:off x="694944" y="3918204"/>
-            <a:ext cx="6729984" cy="256032"/>
-          </a:xfrm>
-          <a:prstGeom prst="rect">
-            <a:avLst/>
-          </a:prstGeom>
-          <a:noFill/>
-        </p:spPr>
-        <p:txBody>
-          <a:bodyPr wrap="square" lIns="82296" rIns="36576" tIns="18288" bIns="18288">
-            <a:normAutofit/>
-          </a:bodyPr>
-          <a:lstStyle/>
-          <a:p>
-            <a:pPr>
-              <a:lnSpc>
-                <a:spcPct val="100000"/>
-              </a:lnSpc>
-              <a:spcBef>
-                <a:spcPts val="0"/>
-              </a:spcBef>
-              <a:spcAft>
-                <a:spcPts val="0"/>
-              </a:spcAft>
-            </a:pPr>
-            <a:r>
-              <a:rPr sz="1350" b="0">
-                <a:solidFill>
-                  <a:srgbClr val="000000"/>
-                </a:solidFill>
-                <a:latin typeface="Montserrat"/>
-              </a:rPr>
-              <a:t>Case 09 | ASH-CHI pet fee | PASS | Composite .974</a:t>
-            </a:r>
-          </a:p>
-        </p:txBody>
-      </p:sp>
-      <p:sp>
-        <p:nvSpPr>
-          <p:cNvPr id="339" name="Oval 338"/>
-          <p:cNvSpPr/>
-          <p:nvPr/>
-        </p:nvSpPr>
-        <p:spPr>
-          <a:xfrm>
-            <a:off x="402336" y="4018788"/>
-            <a:ext cx="192024" cy="192024"/>
-          </a:xfrm>
-          <a:prstGeom prst="ellipse">
-            <a:avLst/>
-          </a:prstGeom>
-          <a:solidFill>
-            <a:srgbClr val="0944A1"/>
-          </a:solidFill>
-          <a:ln>
-            <a:noFill/>
-          </a:ln>
-        </p:spPr>
-        <p:style>
-          <a:lnRef idx="1">
-            <a:schemeClr val="accent1"/>
-          </a:lnRef>
-          <a:fillRef idx="3">
-            <a:schemeClr val="accent1"/>
-          </a:fillRef>
-          <a:effectRef idx="2">
-            <a:schemeClr val="accent1"/>
-          </a:effectRef>
-          <a:fontRef idx="minor">
-            <a:schemeClr val="lt1"/>
-          </a:fontRef>
-        </p:style>
-        <p:txBody>
-          <a:bodyPr rtlCol="0" anchor="ctr"/>
-          <a:lstStyle/>
-          <a:p>
-            <a:pPr algn="ctr"/>
-          </a:p>
-        </p:txBody>
-      </p:sp>
-      <p:sp>
-        <p:nvSpPr>
-          <p:cNvPr id="340" name="TextBox 339"/>
-          <p:cNvSpPr txBox="1"/>
-          <p:nvPr/>
-        </p:nvSpPr>
-        <p:spPr>
-          <a:xfrm>
-            <a:off x="694944" y="4206240"/>
-            <a:ext cx="6729984" cy="256032"/>
-          </a:xfrm>
-          <a:prstGeom prst="rect">
-            <a:avLst/>
-          </a:prstGeom>
-          <a:noFill/>
-        </p:spPr>
-        <p:txBody>
-          <a:bodyPr wrap="square" lIns="82296" rIns="36576" tIns="18288" bIns="18288">
-            <a:normAutofit/>
-          </a:bodyPr>
-          <a:lstStyle/>
-          <a:p>
-            <a:pPr>
-              <a:lnSpc>
-                <a:spcPct val="100000"/>
-              </a:lnSpc>
-              <a:spcBef>
-                <a:spcPts val="0"/>
-              </a:spcBef>
-              <a:spcAft>
-                <a:spcPts val="0"/>
-              </a:spcAft>
-            </a:pPr>
-            <a:r>
-              <a:rPr sz="1350" b="0">
-                <a:solidFill>
-                  <a:srgbClr val="000000"/>
-                </a:solidFill>
-                <a:latin typeface="Montserrat"/>
-              </a:rPr>
-              <a:t>Case 10 | Card-hold difference | PASS | Composite .934</a:t>
-            </a:r>
-          </a:p>
-        </p:txBody>
-      </p:sp>
-      <p:sp>
-        <p:nvSpPr>
-          <p:cNvPr id="341" name="Oval 340"/>
-          <p:cNvSpPr/>
-          <p:nvPr/>
-        </p:nvSpPr>
-        <p:spPr>
-          <a:xfrm>
-            <a:off x="402336" y="4306824"/>
-            <a:ext cx="192024" cy="192024"/>
-          </a:xfrm>
-          <a:prstGeom prst="ellipse">
-            <a:avLst/>
-          </a:prstGeom>
-          <a:solidFill>
-            <a:srgbClr val="0944A1"/>
-          </a:solidFill>
-          <a:ln>
-            <a:noFill/>
-          </a:ln>
-        </p:spPr>
-        <p:style>
-          <a:lnRef idx="1">
-            <a:schemeClr val="accent1"/>
-          </a:lnRef>
-          <a:fillRef idx="3">
-            <a:schemeClr val="accent1"/>
-          </a:fillRef>
-          <a:effectRef idx="2">
-            <a:schemeClr val="accent1"/>
-          </a:effectRef>
-          <a:fontRef idx="minor">
-            <a:schemeClr val="lt1"/>
-          </a:fontRef>
-        </p:style>
-        <p:txBody>
-          <a:bodyPr rtlCol="0" anchor="ctr"/>
-          <a:lstStyle/>
-          <a:p>
-            <a:pPr algn="ctr"/>
-          </a:p>
-        </p:txBody>
-      </p:sp>
-      <p:sp>
-        <p:nvSpPr>
-          <p:cNvPr id="342" name="TextBox 341"/>
-          <p:cNvSpPr txBox="1"/>
-          <p:nvPr/>
-        </p:nvSpPr>
-        <p:spPr>
-          <a:xfrm>
-            <a:off x="694944" y="4494276"/>
-            <a:ext cx="6729984" cy="187451"/>
-          </a:xfrm>
-          <a:prstGeom prst="rect">
-            <a:avLst/>
-          </a:prstGeom>
-          <a:noFill/>
-        </p:spPr>
-        <p:txBody>
-          <a:bodyPr wrap="square" lIns="82296" rIns="36576" tIns="18288" bIns="18288">
-            <a:normAutofit/>
-          </a:bodyPr>
-          <a:lstStyle/>
-          <a:p>
-            <a:pPr>
-              <a:lnSpc>
-                <a:spcPct val="100000"/>
-              </a:lnSpc>
-              <a:spcBef>
-                <a:spcPts val="0"/>
-              </a:spcBef>
-              <a:spcAft>
-                <a:spcPts val="0"/>
-              </a:spcAft>
-            </a:pPr>
-            <a:r>
-              <a:rPr sz="1350" b="0">
-                <a:solidFill>
-                  <a:srgbClr val="000000"/>
-                </a:solidFill>
-                <a:latin typeface="Montserrat"/>
-              </a:rPr>
-              <a:t>Selected baseline result: 9/10 passed; weighted composite .941.</a:t>
-            </a:r>
-          </a:p>
-        </p:txBody>
-      </p:sp>
-      <p:sp>
-        <p:nvSpPr>
-          <p:cNvPr id="343" name="Oval 342"/>
-          <p:cNvSpPr/>
-          <p:nvPr/>
-        </p:nvSpPr>
-        <p:spPr>
-          <a:xfrm>
-            <a:off x="402336" y="4594860"/>
-            <a:ext cx="192024" cy="192024"/>
-          </a:xfrm>
-          <a:prstGeom prst="ellipse">
-            <a:avLst/>
-          </a:prstGeom>
-          <a:solidFill>
-            <a:srgbClr val="0944A1"/>
-          </a:solidFill>
-          <a:ln>
-            <a:noFill/>
-          </a:ln>
-        </p:spPr>
-        <p:style>
-          <a:lnRef idx="1">
-            <a:schemeClr val="accent1"/>
-          </a:lnRef>
-          <a:fillRef idx="3">
-            <a:schemeClr val="accent1"/>
-          </a:fillRef>
-          <a:effectRef idx="2">
-            <a:schemeClr val="accent1"/>
-          </a:effectRef>
-          <a:fontRef idx="minor">
-            <a:schemeClr val="lt1"/>
-          </a:fontRef>
-        </p:style>
-        <p:txBody>
-          <a:bodyPr rtlCol="0" anchor="ctr"/>
-          <a:lstStyle/>
-          <a:p>
-            <a:pPr algn="ctr"/>
-          </a:p>
-        </p:txBody>
-      </p:sp>
-      <p:sp>
-        <p:nvSpPr>
-          <p:cNvPr id="344" name="TextBox 343"/>
-          <p:cNvSpPr txBox="1"/>
-          <p:nvPr/>
-        </p:nvSpPr>
-        <p:spPr>
-          <a:xfrm>
-            <a:off x="694944" y="4713732"/>
-            <a:ext cx="6729984" cy="182880"/>
-          </a:xfrm>
-          <a:prstGeom prst="rect">
-            <a:avLst/>
-          </a:prstGeom>
-          <a:noFill/>
-        </p:spPr>
-        <p:txBody>
-          <a:bodyPr wrap="square" lIns="82296" rIns="36576" tIns="18288" bIns="18288">
-            <a:normAutofit/>
-          </a:bodyPr>
-          <a:lstStyle/>
-          <a:p>
-            <a:pPr>
-              <a:lnSpc>
-                <a:spcPct val="100000"/>
-              </a:lnSpc>
-              <a:spcBef>
-                <a:spcPts val="0"/>
-              </a:spcBef>
-              <a:spcAft>
-                <a:spcPts val="0"/>
-              </a:spcAft>
-            </a:pPr>
-            <a:r>
-              <a:rPr sz="1350" b="0">
-                <a:solidFill>
-                  <a:srgbClr val="000000"/>
-                </a:solidFill>
-                <a:latin typeface="Montserrat"/>
-              </a:rPr>
-              <a:t>The focused clarification experiment raised the failed case's Precision to .961 and passed all four metrics.</a:t>
-            </a:r>
-          </a:p>
-        </p:txBody>
-      </p:sp>
-      <p:sp>
-        <p:nvSpPr>
-          <p:cNvPr id="345" name="Oval 344"/>
-          <p:cNvSpPr/>
-          <p:nvPr/>
-        </p:nvSpPr>
-        <p:spPr>
-          <a:xfrm>
-            <a:off x="402336" y="4814316"/>
-            <a:ext cx="192024" cy="192024"/>
-          </a:xfrm>
-          <a:prstGeom prst="ellipse">
-            <a:avLst/>
-          </a:prstGeom>
-          <a:solidFill>
-            <a:srgbClr val="0944A1"/>
-          </a:solidFill>
-          <a:ln>
-            <a:noFill/>
-          </a:ln>
-        </p:spPr>
-        <p:style>
-          <a:lnRef idx="1">
-            <a:schemeClr val="accent1"/>
-          </a:lnRef>
-          <a:fillRef idx="3">
-            <a:schemeClr val="accent1"/>
-          </a:fillRef>
-          <a:effectRef idx="2">
-            <a:schemeClr val="accent1"/>
-          </a:effectRef>
-          <a:fontRef idx="minor">
-            <a:schemeClr val="lt1"/>
-          </a:fontRef>
-        </p:style>
-        <p:txBody>
-          <a:bodyPr rtlCol="0" anchor="ctr"/>
-          <a:lstStyle/>
-          <a:p>
-            <a:pPr algn="ctr"/>
           </a:p>
         </p:txBody>
       </p:sp>

</xml_diff>

<commit_message>
Add metric footnote to slide 19
</commit_message>
<xml_diff>
--- a/presentations/Aurora_Stays_RAG_Project_Presentation_Template_Style.pptx
+++ b/presentations/Aurora_Stays_RAG_Project_Presentation_Template_Style.pptx
@@ -37915,7 +37915,7 @@
         </p:nvGraphicFramePr>
         <p:xfrm>
           <a:off x="438912" y="1207008"/>
-          <a:ext cx="6821424" cy="3401568"/>
+          <a:ext cx="6821424" cy="3200400"/>
         </p:xfrm>
         <a:graphic>
           <a:graphicData uri="http://schemas.openxmlformats.org/drawingml/2006/table">
@@ -37933,7 +37933,7 @@
                 <a:gridCol w="777240"/>
                 <a:gridCol w="749808"/>
               </a:tblGrid>
-              <a:tr h="309233">
+              <a:tr h="290945">
                 <a:tc>
                   <a:txBody>
                     <a:bodyPr/>
@@ -38199,7 +38199,7 @@
                   </a:tcPr>
                 </a:tc>
               </a:tr>
-              <a:tr h="309233">
+              <a:tr h="290945">
                 <a:tc>
                   <a:txBody>
                     <a:bodyPr/>
@@ -38465,7 +38465,7 @@
                   </a:tcPr>
                 </a:tc>
               </a:tr>
-              <a:tr h="309233">
+              <a:tr h="290945">
                 <a:tc>
                   <a:txBody>
                     <a:bodyPr/>
@@ -38731,7 +38731,7 @@
                   </a:tcPr>
                 </a:tc>
               </a:tr>
-              <a:tr h="309233">
+              <a:tr h="290945">
                 <a:tc>
                   <a:txBody>
                     <a:bodyPr/>
@@ -38997,7 +38997,7 @@
                   </a:tcPr>
                 </a:tc>
               </a:tr>
-              <a:tr h="309233">
+              <a:tr h="290945">
                 <a:tc>
                   <a:txBody>
                     <a:bodyPr/>
@@ -39263,7 +39263,7 @@
                   </a:tcPr>
                 </a:tc>
               </a:tr>
-              <a:tr h="309233">
+              <a:tr h="290945">
                 <a:tc>
                   <a:txBody>
                     <a:bodyPr/>
@@ -39529,7 +39529,7 @@
                   </a:tcPr>
                 </a:tc>
               </a:tr>
-              <a:tr h="309233">
+              <a:tr h="290945">
                 <a:tc>
                   <a:txBody>
                     <a:bodyPr/>
@@ -39795,7 +39795,7 @@
                   </a:tcPr>
                 </a:tc>
               </a:tr>
-              <a:tr h="309233">
+              <a:tr h="290945">
                 <a:tc>
                   <a:txBody>
                     <a:bodyPr/>
@@ -40061,7 +40061,7 @@
                   </a:tcPr>
                 </a:tc>
               </a:tr>
-              <a:tr h="309233">
+              <a:tr h="290945">
                 <a:tc>
                   <a:txBody>
                     <a:bodyPr/>
@@ -40327,7 +40327,7 @@
                   </a:tcPr>
                 </a:tc>
               </a:tr>
-              <a:tr h="309233">
+              <a:tr h="290945">
                 <a:tc>
                   <a:txBody>
                     <a:bodyPr/>
@@ -40593,7 +40593,7 @@
                   </a:tcPr>
                 </a:tc>
               </a:tr>
-              <a:tr h="309238">
+              <a:tr h="290950">
                 <a:tc>
                   <a:txBody>
                     <a:bodyPr/>
@@ -40871,8 +40871,8 @@
         </p:nvSpPr>
         <p:spPr>
           <a:xfrm>
-            <a:off x="502920" y="4681728"/>
-            <a:ext cx="8138160" cy="256032"/>
+            <a:off x="502920" y="4480560"/>
+            <a:ext cx="8138160" cy="219456"/>
           </a:xfrm>
           <a:prstGeom prst="rect">
             <a:avLst/>
@@ -40894,13 +40894,55 @@
               </a:spcAft>
             </a:pPr>
             <a:r>
-              <a:rPr sz="950" b="1">
+              <a:rPr sz="880" b="1">
                 <a:solidFill>
                   <a:srgbClr val="0E39A9"/>
                 </a:solidFill>
                 <a:latin typeface="Montserrat"/>
               </a:rPr>
               <a:t>Selected baseline: 9/10 passed; weighted composite .941. The only failure is Accessible King Precision=.451.</a:t>
+            </a:r>
+          </a:p>
+        </p:txBody>
+      </p:sp>
+      <p:sp>
+        <p:nvSpPr>
+          <p:cNvPr id="322" name="TextBox 321"/>
+          <p:cNvSpPr txBox="1"/>
+          <p:nvPr/>
+        </p:nvSpPr>
+        <p:spPr>
+          <a:xfrm>
+            <a:off x="502920" y="4727448"/>
+            <a:ext cx="8138160" cy="219456"/>
+          </a:xfrm>
+          <a:prstGeom prst="rect">
+            <a:avLst/>
+          </a:prstGeom>
+          <a:noFill/>
+        </p:spPr>
+        <p:txBody>
+          <a:bodyPr wrap="square" lIns="27432" rIns="27432">
+            <a:spAutoFit/>
+          </a:bodyPr>
+          <a:lstStyle/>
+          <a:p>
+            <a:pPr>
+              <a:spcBef>
+                <a:spcPts val="0"/>
+              </a:spcBef>
+              <a:spcAft>
+                <a:spcPts val="0"/>
+              </a:spcAft>
+            </a:pPr>
+            <a:r>
+              <a:rPr sz="830" i="1">
+                <a:solidFill>
+                  <a:srgbClr val="505050"/>
+                </a:solidFill>
+                <a:latin typeface="Montserrat"/>
+              </a:rPr>
+              <a:t>F = Faithfulness | R = Contextual Recall | P = Contextual Precision | AR = Answer Relevancy</a:t>
             </a:r>
           </a:p>
         </p:txBody>

</xml_diff>